<commit_message>
Update all results to 10-speaker evaluation (1,000 utterances)
Key number changes:
  A (Pretrained + No SE):  0.269 → 0.544
  B (Pretrained + GTCRN):  0.296 → 0.635
  C (Fine-tuned + No SE):  0.095 → 0.150
  D (Fine-tuned + GTCRN):  0.1015 → 0.186
  FT improvement: 64.6% → 72.4% (consistent across all 10 speakers)
  SE harm: +0.027 → +0.091 (pretrained), +0.007 → +0.036 (FT)

- Paper: update abstract, sec 3.4, Table 2, conclusion with multi-speaker stats
- Paper: add p00-only row to Table 2 for comparison
- Slides (16): update FT result, 2x2 table, conclusion points
- Overview slides (25): update fig_ft_result, fig_2x2, summary text
- Add multi-speaker result CSVs

Co-Authored-By: Claude Sonnet 4.6 <noreply@anthropic.com>
</commit_message>
<xml_diff>
--- a/results/overview_slides.pptx
+++ b/results/overview_slides.pptx
@@ -6572,7 +6572,7 @@
         <p:spPr>
           <a:xfrm>
             <a:off x="457200" y="2468880"/>
-            <a:ext cx="5029200" cy="3517355"/>
+            <a:ext cx="5029200" cy="2664372"/>
           </a:xfrm>
           <a:prstGeom prst="rect">
             <a:avLst/>
@@ -6709,7 +6709,7 @@
                   <a:srgbClr val="78909C"/>
                 </a:solidFill>
               </a:rPr>
-              <a:t>FT後もSEの逆効果は残るが悪影響は縮小（+0.027→+0.007）</a:t>
+              <a:t>FT後もSEの逆効果は残るが悪影響は縮小（+0.091→+0.036）</a:t>
             </a:r>
           </a:p>
         </p:txBody>
@@ -6990,7 +6990,7 @@
                   <a:srgbClr val="212121"/>
                 </a:solidFill>
               </a:rPr>
-              <a:t>Whisper FTでCER 64.6%改善（0.269→0.095）—音声処理よりASR適応が根本解決</a:t>
+              <a:t>Whisper FTでCER 72.4%改善（0.544→0.150，10話者）—音声処理よりASR適応が根本解決</a:t>
             </a:r>
           </a:p>
         </p:txBody>

</xml_diff>

<commit_message>
Add spectrum analysis: visualize GTCRN artifact mechanism
- Add scripts/27_spectrum_analysis.py: generates spectrum_analysis.png
  showing per-band energy change before/after GTCRN
- Key finding: GTCRN removes 4-8 kHz by -12.73 dB (throat mic already
  lacks high freq → GTCRN further removes it, destroying formant info)
- Update paper (15): new §3.4 spectral analysis section, cite -12.73 dB
  finding in discussion; renumber old §3.4 → §3.5
- Update slides (16): add s23c_spectrum slide (slide 25 of 29)
- Update overview slides (25): add s5_mechanism slide (slide 5 of 6)

Co-Authored-By: Claude Sonnet 4.6 <noreply@anthropic.com>
</commit_message>
<xml_diff>
--- a/results/overview_slides.pptx
+++ b/results/overview_slides.pptx
@@ -10,6 +10,7 @@
     <p:sldId id="258" r:id="rId9"/>
     <p:sldId id="259" r:id="rId10"/>
     <p:sldId id="260" r:id="rId11"/>
+    <p:sldId id="261" r:id="rId12"/>
   </p:sldIdLst>
   <p:sldSz cx="12188952" cy="6858000" type="screen4x3"/>
   <p:notesSz cx="6858000" cy="9144000"/>
@@ -6327,7 +6328,7 @@
                   <a:srgbClr val="FFFFFF"/>
                 </a:solidFill>
               </a:rPr>
-              <a:t>解決策と結論：「音声を直す」より「ASRを慣れさせる」</a:t>
+              <a:t>なぜASRが悪化するのか：スペクトル分析</a:t>
             </a:r>
           </a:p>
         </p:txBody>
@@ -6362,6 +6363,829 @@
                 </a:solidFill>
               </a:rPr>
               <a:t>5 / 5</a:t>
+            </a:r>
+          </a:p>
+        </p:txBody>
+      </p:sp>
+      <p:sp>
+        <p:nvSpPr>
+          <p:cNvPr id="5" name="Rectangle 4"/>
+          <p:cNvSpPr/>
+          <p:nvPr/>
+        </p:nvSpPr>
+        <p:spPr>
+          <a:xfrm>
+            <a:off x="0" y="6583680"/>
+            <a:ext cx="12188952" cy="274320"/>
+          </a:xfrm>
+          <a:prstGeom prst="rect">
+            <a:avLst/>
+          </a:prstGeom>
+          <a:solidFill>
+            <a:srgbClr val="E8EAF6"/>
+          </a:solidFill>
+          <a:ln>
+            <a:noFill/>
+          </a:ln>
+        </p:spPr>
+        <p:style>
+          <a:lnRef idx="1">
+            <a:schemeClr val="accent1"/>
+          </a:lnRef>
+          <a:fillRef idx="3">
+            <a:schemeClr val="accent1"/>
+          </a:fillRef>
+          <a:effectRef idx="2">
+            <a:schemeClr val="accent1"/>
+          </a:effectRef>
+          <a:fontRef idx="minor">
+            <a:schemeClr val="lt1"/>
+          </a:fontRef>
+        </p:style>
+        <p:txBody>
+          <a:bodyPr rtlCol="0" anchor="ctr"/>
+          <a:lstStyle/>
+          <a:p>
+            <a:pPr algn="ctr"/>
+          </a:p>
+        </p:txBody>
+      </p:sp>
+      <p:sp>
+        <p:nvSpPr>
+          <p:cNvPr id="6" name="TextBox 5"/>
+          <p:cNvSpPr txBox="1"/>
+          <p:nvPr/>
+        </p:nvSpPr>
+        <p:spPr>
+          <a:xfrm>
+            <a:off x="274320" y="6601968"/>
+            <a:ext cx="11612880" cy="228600"/>
+          </a:xfrm>
+          <a:prstGeom prst="rect">
+            <a:avLst/>
+          </a:prstGeom>
+          <a:noFill/>
+        </p:spPr>
+        <p:txBody>
+          <a:bodyPr wrap="square">
+            <a:spAutoFit/>
+          </a:bodyPr>
+          <a:lstStyle/>
+          <a:p>
+            <a:pPr algn="l"/>
+            <a:r>
+              <a:rPr sz="900" b="0">
+                <a:solidFill>
+                  <a:srgbClr val="78909C"/>
+                </a:solidFill>
+              </a:rPr>
+              <a:t>骨伝導マイク音声認識研究 — 概要</a:t>
+            </a:r>
+          </a:p>
+        </p:txBody>
+      </p:sp>
+      <p:pic>
+        <p:nvPicPr>
+          <p:cNvPr id="7" name="Picture 6" descr="image.png"/>
+          <p:cNvPicPr>
+            <a:picLocks noChangeAspect="1"/>
+          </p:cNvPicPr>
+          <p:nvPr/>
+        </p:nvPicPr>
+        <p:blipFill>
+          <a:blip r:embed="rId2"/>
+          <a:stretch>
+            <a:fillRect/>
+          </a:stretch>
+        </p:blipFill>
+        <p:spPr>
+          <a:xfrm>
+            <a:off x="274320" y="1325880"/>
+            <a:ext cx="7315200" cy="6013979"/>
+          </a:xfrm>
+          <a:prstGeom prst="rect">
+            <a:avLst/>
+          </a:prstGeom>
+        </p:spPr>
+      </p:pic>
+      <p:sp>
+        <p:nvSpPr>
+          <p:cNvPr id="8" name="Rectangle 7"/>
+          <p:cNvSpPr/>
+          <p:nvPr/>
+        </p:nvSpPr>
+        <p:spPr>
+          <a:xfrm>
+            <a:off x="8046720" y="1371600"/>
+            <a:ext cx="3840480" cy="5029200"/>
+          </a:xfrm>
+          <a:prstGeom prst="rect">
+            <a:avLst/>
+          </a:prstGeom>
+          <a:solidFill>
+            <a:srgbClr val="FFEBEE"/>
+          </a:solidFill>
+          <a:ln>
+            <a:noFill/>
+          </a:ln>
+        </p:spPr>
+        <p:style>
+          <a:lnRef idx="1">
+            <a:schemeClr val="accent1"/>
+          </a:lnRef>
+          <a:fillRef idx="3">
+            <a:schemeClr val="accent1"/>
+          </a:fillRef>
+          <a:effectRef idx="2">
+            <a:schemeClr val="accent1"/>
+          </a:effectRef>
+          <a:fontRef idx="minor">
+            <a:schemeClr val="lt1"/>
+          </a:fontRef>
+        </p:style>
+        <p:txBody>
+          <a:bodyPr rtlCol="0" anchor="ctr"/>
+          <a:lstStyle/>
+          <a:p>
+            <a:pPr algn="ctr"/>
+          </a:p>
+        </p:txBody>
+      </p:sp>
+      <p:sp>
+        <p:nvSpPr>
+          <p:cNvPr id="9" name="TextBox 8"/>
+          <p:cNvSpPr txBox="1"/>
+          <p:nvPr/>
+        </p:nvSpPr>
+        <p:spPr>
+          <a:xfrm>
+            <a:off x="8183879" y="1463040"/>
+            <a:ext cx="3566160" cy="384048"/>
+          </a:xfrm>
+          <a:prstGeom prst="rect">
+            <a:avLst/>
+          </a:prstGeom>
+          <a:noFill/>
+        </p:spPr>
+        <p:txBody>
+          <a:bodyPr wrap="square">
+            <a:spAutoFit/>
+          </a:bodyPr>
+          <a:lstStyle/>
+          <a:p>
+            <a:pPr algn="l"/>
+            <a:r>
+              <a:rPr sz="1500" b="1">
+                <a:solidFill>
+                  <a:srgbClr val="C62828"/>
+                </a:solidFill>
+              </a:rPr>
+              <a:t>GTCRNが喉マイクに何をするか</a:t>
+            </a:r>
+          </a:p>
+        </p:txBody>
+      </p:sp>
+      <p:sp>
+        <p:nvSpPr>
+          <p:cNvPr id="10" name="Rectangle 9"/>
+          <p:cNvSpPr/>
+          <p:nvPr/>
+        </p:nvSpPr>
+        <p:spPr>
+          <a:xfrm>
+            <a:off x="8183879" y="1965960"/>
+            <a:ext cx="3566160" cy="731520"/>
+          </a:xfrm>
+          <a:prstGeom prst="rect">
+            <a:avLst/>
+          </a:prstGeom>
+          <a:solidFill>
+            <a:srgbClr val="FFFFFF"/>
+          </a:solidFill>
+          <a:ln>
+            <a:noFill/>
+          </a:ln>
+        </p:spPr>
+        <p:style>
+          <a:lnRef idx="1">
+            <a:schemeClr val="accent1"/>
+          </a:lnRef>
+          <a:fillRef idx="3">
+            <a:schemeClr val="accent1"/>
+          </a:fillRef>
+          <a:effectRef idx="2">
+            <a:schemeClr val="accent1"/>
+          </a:effectRef>
+          <a:fontRef idx="minor">
+            <a:schemeClr val="lt1"/>
+          </a:fontRef>
+        </p:style>
+        <p:txBody>
+          <a:bodyPr rtlCol="0" anchor="ctr"/>
+          <a:lstStyle/>
+          <a:p>
+            <a:pPr algn="ctr"/>
+          </a:p>
+        </p:txBody>
+      </p:sp>
+      <p:sp>
+        <p:nvSpPr>
+          <p:cNvPr id="11" name="TextBox 10"/>
+          <p:cNvSpPr txBox="1"/>
+          <p:nvPr/>
+        </p:nvSpPr>
+        <p:spPr>
+          <a:xfrm>
+            <a:off x="8275320" y="2011680"/>
+            <a:ext cx="1097280" cy="320040"/>
+          </a:xfrm>
+          <a:prstGeom prst="rect">
+            <a:avLst/>
+          </a:prstGeom>
+          <a:noFill/>
+        </p:spPr>
+        <p:txBody>
+          <a:bodyPr wrap="square">
+            <a:spAutoFit/>
+          </a:bodyPr>
+          <a:lstStyle/>
+          <a:p>
+            <a:pPr algn="l"/>
+            <a:r>
+              <a:rPr sz="1200" b="1">
+                <a:solidFill>
+                  <a:srgbClr val="212121"/>
+                </a:solidFill>
+              </a:rPr>
+              <a:t>0–0.5 kHz</a:t>
+            </a:r>
+          </a:p>
+        </p:txBody>
+      </p:sp>
+      <p:sp>
+        <p:nvSpPr>
+          <p:cNvPr id="12" name="TextBox 11"/>
+          <p:cNvSpPr txBox="1"/>
+          <p:nvPr/>
+        </p:nvSpPr>
+        <p:spPr>
+          <a:xfrm>
+            <a:off x="9372600" y="2011680"/>
+            <a:ext cx="1280160" cy="320040"/>
+          </a:xfrm>
+          <a:prstGeom prst="rect">
+            <a:avLst/>
+          </a:prstGeom>
+          <a:noFill/>
+        </p:spPr>
+        <p:txBody>
+          <a:bodyPr wrap="square">
+            <a:spAutoFit/>
+          </a:bodyPr>
+          <a:lstStyle/>
+          <a:p>
+            <a:pPr algn="l"/>
+            <a:r>
+              <a:rPr sz="1300" b="1">
+                <a:solidFill>
+                  <a:srgbClr val="C62828"/>
+                </a:solidFill>
+              </a:rPr>
+              <a:t>+1.6 dB</a:t>
+            </a:r>
+          </a:p>
+        </p:txBody>
+      </p:sp>
+      <p:sp>
+        <p:nvSpPr>
+          <p:cNvPr id="13" name="TextBox 12"/>
+          <p:cNvSpPr txBox="1"/>
+          <p:nvPr/>
+        </p:nvSpPr>
+        <p:spPr>
+          <a:xfrm>
+            <a:off x="8275320" y="2377440"/>
+            <a:ext cx="3383280" cy="274320"/>
+          </a:xfrm>
+          <a:prstGeom prst="rect">
+            <a:avLst/>
+          </a:prstGeom>
+          <a:noFill/>
+        </p:spPr>
+        <p:txBody>
+          <a:bodyPr wrap="square">
+            <a:spAutoFit/>
+          </a:bodyPr>
+          <a:lstStyle/>
+          <a:p>
+            <a:pPr algn="l"/>
+            <a:r>
+              <a:rPr sz="1100" b="0">
+                <a:solidFill>
+                  <a:srgbClr val="78909C"/>
+                </a:solidFill>
+              </a:rPr>
+              <a:t>低域にノイズ追加</a:t>
+            </a:r>
+          </a:p>
+        </p:txBody>
+      </p:sp>
+      <p:sp>
+        <p:nvSpPr>
+          <p:cNvPr id="14" name="Rectangle 13"/>
+          <p:cNvSpPr/>
+          <p:nvPr/>
+        </p:nvSpPr>
+        <p:spPr>
+          <a:xfrm>
+            <a:off x="8183879" y="2788920"/>
+            <a:ext cx="3566160" cy="731520"/>
+          </a:xfrm>
+          <a:prstGeom prst="rect">
+            <a:avLst/>
+          </a:prstGeom>
+          <a:solidFill>
+            <a:srgbClr val="FFFFFF"/>
+          </a:solidFill>
+          <a:ln>
+            <a:noFill/>
+          </a:ln>
+        </p:spPr>
+        <p:style>
+          <a:lnRef idx="1">
+            <a:schemeClr val="accent1"/>
+          </a:lnRef>
+          <a:fillRef idx="3">
+            <a:schemeClr val="accent1"/>
+          </a:fillRef>
+          <a:effectRef idx="2">
+            <a:schemeClr val="accent1"/>
+          </a:effectRef>
+          <a:fontRef idx="minor">
+            <a:schemeClr val="lt1"/>
+          </a:fontRef>
+        </p:style>
+        <p:txBody>
+          <a:bodyPr rtlCol="0" anchor="ctr"/>
+          <a:lstStyle/>
+          <a:p>
+            <a:pPr algn="ctr"/>
+          </a:p>
+        </p:txBody>
+      </p:sp>
+      <p:sp>
+        <p:nvSpPr>
+          <p:cNvPr id="15" name="TextBox 14"/>
+          <p:cNvSpPr txBox="1"/>
+          <p:nvPr/>
+        </p:nvSpPr>
+        <p:spPr>
+          <a:xfrm>
+            <a:off x="8275320" y="2834640"/>
+            <a:ext cx="1097280" cy="320040"/>
+          </a:xfrm>
+          <a:prstGeom prst="rect">
+            <a:avLst/>
+          </a:prstGeom>
+          <a:noFill/>
+        </p:spPr>
+        <p:txBody>
+          <a:bodyPr wrap="square">
+            <a:spAutoFit/>
+          </a:bodyPr>
+          <a:lstStyle/>
+          <a:p>
+            <a:pPr algn="l"/>
+            <a:r>
+              <a:rPr sz="1200" b="1">
+                <a:solidFill>
+                  <a:srgbClr val="212121"/>
+                </a:solidFill>
+              </a:rPr>
+              <a:t>1–4 kHz</a:t>
+            </a:r>
+          </a:p>
+        </p:txBody>
+      </p:sp>
+      <p:sp>
+        <p:nvSpPr>
+          <p:cNvPr id="16" name="TextBox 15"/>
+          <p:cNvSpPr txBox="1"/>
+          <p:nvPr/>
+        </p:nvSpPr>
+        <p:spPr>
+          <a:xfrm>
+            <a:off x="9372600" y="2834640"/>
+            <a:ext cx="1280160" cy="320040"/>
+          </a:xfrm>
+          <a:prstGeom prst="rect">
+            <a:avLst/>
+          </a:prstGeom>
+          <a:noFill/>
+        </p:spPr>
+        <p:txBody>
+          <a:bodyPr wrap="square">
+            <a:spAutoFit/>
+          </a:bodyPr>
+          <a:lstStyle/>
+          <a:p>
+            <a:pPr algn="l"/>
+            <a:r>
+              <a:rPr sz="1300" b="1">
+                <a:solidFill>
+                  <a:srgbClr val="C62828"/>
+                </a:solidFill>
+              </a:rPr>
+              <a:t>−1〜2 dB</a:t>
+            </a:r>
+          </a:p>
+        </p:txBody>
+      </p:sp>
+      <p:sp>
+        <p:nvSpPr>
+          <p:cNvPr id="17" name="TextBox 16"/>
+          <p:cNvSpPr txBox="1"/>
+          <p:nvPr/>
+        </p:nvSpPr>
+        <p:spPr>
+          <a:xfrm>
+            <a:off x="8275320" y="3200400"/>
+            <a:ext cx="3383280" cy="274320"/>
+          </a:xfrm>
+          <a:prstGeom prst="rect">
+            <a:avLst/>
+          </a:prstGeom>
+          <a:noFill/>
+        </p:spPr>
+        <p:txBody>
+          <a:bodyPr wrap="square">
+            <a:spAutoFit/>
+          </a:bodyPr>
+          <a:lstStyle/>
+          <a:p>
+            <a:pPr algn="l"/>
+            <a:r>
+              <a:rPr sz="1100" b="0">
+                <a:solidFill>
+                  <a:srgbClr val="78909C"/>
+                </a:solidFill>
+              </a:rPr>
+              <a:t>フォルマント帯域を削除</a:t>
+            </a:r>
+          </a:p>
+        </p:txBody>
+      </p:sp>
+      <p:sp>
+        <p:nvSpPr>
+          <p:cNvPr id="18" name="Rectangle 17"/>
+          <p:cNvSpPr/>
+          <p:nvPr/>
+        </p:nvSpPr>
+        <p:spPr>
+          <a:xfrm>
+            <a:off x="8183879" y="3611880"/>
+            <a:ext cx="3566160" cy="731520"/>
+          </a:xfrm>
+          <a:prstGeom prst="rect">
+            <a:avLst/>
+          </a:prstGeom>
+          <a:solidFill>
+            <a:srgbClr val="FFFFFF"/>
+          </a:solidFill>
+          <a:ln>
+            <a:noFill/>
+          </a:ln>
+        </p:spPr>
+        <p:style>
+          <a:lnRef idx="1">
+            <a:schemeClr val="accent1"/>
+          </a:lnRef>
+          <a:fillRef idx="3">
+            <a:schemeClr val="accent1"/>
+          </a:fillRef>
+          <a:effectRef idx="2">
+            <a:schemeClr val="accent1"/>
+          </a:effectRef>
+          <a:fontRef idx="minor">
+            <a:schemeClr val="lt1"/>
+          </a:fontRef>
+        </p:style>
+        <p:txBody>
+          <a:bodyPr rtlCol="0" anchor="ctr"/>
+          <a:lstStyle/>
+          <a:p>
+            <a:pPr algn="ctr"/>
+          </a:p>
+        </p:txBody>
+      </p:sp>
+      <p:sp>
+        <p:nvSpPr>
+          <p:cNvPr id="19" name="TextBox 18"/>
+          <p:cNvSpPr txBox="1"/>
+          <p:nvPr/>
+        </p:nvSpPr>
+        <p:spPr>
+          <a:xfrm>
+            <a:off x="8275320" y="3657600"/>
+            <a:ext cx="1097280" cy="320040"/>
+          </a:xfrm>
+          <a:prstGeom prst="rect">
+            <a:avLst/>
+          </a:prstGeom>
+          <a:noFill/>
+        </p:spPr>
+        <p:txBody>
+          <a:bodyPr wrap="square">
+            <a:spAutoFit/>
+          </a:bodyPr>
+          <a:lstStyle/>
+          <a:p>
+            <a:pPr algn="l"/>
+            <a:r>
+              <a:rPr sz="1200" b="1">
+                <a:solidFill>
+                  <a:srgbClr val="212121"/>
+                </a:solidFill>
+              </a:rPr>
+              <a:t>4–8 kHz</a:t>
+            </a:r>
+          </a:p>
+        </p:txBody>
+      </p:sp>
+      <p:sp>
+        <p:nvSpPr>
+          <p:cNvPr id="20" name="TextBox 19"/>
+          <p:cNvSpPr txBox="1"/>
+          <p:nvPr/>
+        </p:nvSpPr>
+        <p:spPr>
+          <a:xfrm>
+            <a:off x="9372600" y="3657600"/>
+            <a:ext cx="1280160" cy="320040"/>
+          </a:xfrm>
+          <a:prstGeom prst="rect">
+            <a:avLst/>
+          </a:prstGeom>
+          <a:noFill/>
+        </p:spPr>
+        <p:txBody>
+          <a:bodyPr wrap="square">
+            <a:spAutoFit/>
+          </a:bodyPr>
+          <a:lstStyle/>
+          <a:p>
+            <a:pPr algn="l"/>
+            <a:r>
+              <a:rPr sz="1300" b="1">
+                <a:solidFill>
+                  <a:srgbClr val="C62828"/>
+                </a:solidFill>
+              </a:rPr>
+              <a:t>−12.7 dB</a:t>
+            </a:r>
+          </a:p>
+        </p:txBody>
+      </p:sp>
+      <p:sp>
+        <p:nvSpPr>
+          <p:cNvPr id="21" name="TextBox 20"/>
+          <p:cNvSpPr txBox="1"/>
+          <p:nvPr/>
+        </p:nvSpPr>
+        <p:spPr>
+          <a:xfrm>
+            <a:off x="8275320" y="4023360"/>
+            <a:ext cx="3383280" cy="274320"/>
+          </a:xfrm>
+          <a:prstGeom prst="rect">
+            <a:avLst/>
+          </a:prstGeom>
+          <a:noFill/>
+        </p:spPr>
+        <p:txBody>
+          <a:bodyPr wrap="square">
+            <a:spAutoFit/>
+          </a:bodyPr>
+          <a:lstStyle/>
+          <a:p>
+            <a:pPr algn="l"/>
+            <a:r>
+              <a:rPr sz="1100" b="0">
+                <a:solidFill>
+                  <a:srgbClr val="78909C"/>
+                </a:solidFill>
+              </a:rPr>
+              <a:t>高域を壊滅的に削除</a:t>
+            </a:r>
+          </a:p>
+        </p:txBody>
+      </p:sp>
+      <p:sp>
+        <p:nvSpPr>
+          <p:cNvPr id="22" name="Rectangle 21"/>
+          <p:cNvSpPr/>
+          <p:nvPr/>
+        </p:nvSpPr>
+        <p:spPr>
+          <a:xfrm>
+            <a:off x="8046720" y="4846320"/>
+            <a:ext cx="3840480" cy="1371600"/>
+          </a:xfrm>
+          <a:prstGeom prst="rect">
+            <a:avLst/>
+          </a:prstGeom>
+          <a:solidFill>
+            <a:srgbClr val="FFF9C4"/>
+          </a:solidFill>
+          <a:ln>
+            <a:noFill/>
+          </a:ln>
+        </p:spPr>
+        <p:style>
+          <a:lnRef idx="1">
+            <a:schemeClr val="accent1"/>
+          </a:lnRef>
+          <a:fillRef idx="3">
+            <a:schemeClr val="accent1"/>
+          </a:fillRef>
+          <a:effectRef idx="2">
+            <a:schemeClr val="accent1"/>
+          </a:effectRef>
+          <a:fontRef idx="minor">
+            <a:schemeClr val="lt1"/>
+          </a:fontRef>
+        </p:style>
+        <p:txBody>
+          <a:bodyPr rtlCol="0" anchor="ctr"/>
+          <a:lstStyle/>
+          <a:p>
+            <a:pPr algn="ctr"/>
+          </a:p>
+        </p:txBody>
+      </p:sp>
+      <p:sp>
+        <p:nvSpPr>
+          <p:cNvPr id="23" name="TextBox 22"/>
+          <p:cNvSpPr txBox="1"/>
+          <p:nvPr/>
+        </p:nvSpPr>
+        <p:spPr>
+          <a:xfrm>
+            <a:off x="8183879" y="4892040"/>
+            <a:ext cx="3566160" cy="1234440"/>
+          </a:xfrm>
+          <a:prstGeom prst="rect">
+            <a:avLst/>
+          </a:prstGeom>
+          <a:noFill/>
+        </p:spPr>
+        <p:txBody>
+          <a:bodyPr wrap="square">
+            <a:spAutoFit/>
+          </a:bodyPr>
+          <a:lstStyle/>
+          <a:p>
+            <a:pPr algn="l"/>
+            <a:r>
+              <a:rPr sz="1300" b="0">
+                <a:solidFill>
+                  <a:srgbClr val="1A237E"/>
+                </a:solidFill>
+              </a:rPr>
+              <a:t>喉マイクは元々
+高域が欠落している
+↓
+GTCRNがさらに除去
+= 逆方向の操作</a:t>
+            </a:r>
+          </a:p>
+        </p:txBody>
+      </p:sp>
+    </p:spTree>
+  </p:cSld>
+  <p:clrMapOvr>
+    <a:masterClrMapping/>
+  </p:clrMapOvr>
+</p:sld>
+</file>
+
+<file path=ppt/slides/slide6.xml><?xml version="1.0" encoding="utf-8"?>
+<p:sld xmlns:a="http://schemas.openxmlformats.org/drawingml/2006/main" xmlns:p="http://schemas.openxmlformats.org/presentationml/2006/main" xmlns:r="http://schemas.openxmlformats.org/officeDocument/2006/relationships">
+  <p:cSld>
+    <p:spTree>
+      <p:nvGrpSpPr>
+        <p:cNvPr id="1" name=""/>
+        <p:cNvGrpSpPr/>
+        <p:nvPr/>
+      </p:nvGrpSpPr>
+      <p:grpSpPr/>
+      <p:sp>
+        <p:nvSpPr>
+          <p:cNvPr id="2" name="Rectangle 1"/>
+          <p:cNvSpPr/>
+          <p:nvPr/>
+        </p:nvSpPr>
+        <p:spPr>
+          <a:xfrm>
+            <a:off x="0" y="0"/>
+            <a:ext cx="12188952" cy="1188720"/>
+          </a:xfrm>
+          <a:prstGeom prst="rect">
+            <a:avLst/>
+          </a:prstGeom>
+          <a:solidFill>
+            <a:srgbClr val="1A237E"/>
+          </a:solidFill>
+          <a:ln>
+            <a:noFill/>
+          </a:ln>
+        </p:spPr>
+        <p:style>
+          <a:lnRef idx="1">
+            <a:schemeClr val="accent1"/>
+          </a:lnRef>
+          <a:fillRef idx="3">
+            <a:schemeClr val="accent1"/>
+          </a:fillRef>
+          <a:effectRef idx="2">
+            <a:schemeClr val="accent1"/>
+          </a:effectRef>
+          <a:fontRef idx="minor">
+            <a:schemeClr val="lt1"/>
+          </a:fontRef>
+        </p:style>
+        <p:txBody>
+          <a:bodyPr rtlCol="0" anchor="ctr"/>
+          <a:lstStyle/>
+          <a:p>
+            <a:pPr algn="ctr"/>
+          </a:p>
+        </p:txBody>
+      </p:sp>
+      <p:sp>
+        <p:nvSpPr>
+          <p:cNvPr id="3" name="TextBox 2"/>
+          <p:cNvSpPr txBox="1"/>
+          <p:nvPr/>
+        </p:nvSpPr>
+        <p:spPr>
+          <a:xfrm>
+            <a:off x="411480" y="137160"/>
+            <a:ext cx="10789920" cy="777240"/>
+          </a:xfrm>
+          <a:prstGeom prst="rect">
+            <a:avLst/>
+          </a:prstGeom>
+          <a:noFill/>
+        </p:spPr>
+        <p:txBody>
+          <a:bodyPr wrap="square">
+            <a:spAutoFit/>
+          </a:bodyPr>
+          <a:lstStyle/>
+          <a:p>
+            <a:pPr algn="l"/>
+            <a:r>
+              <a:rPr sz="2600" b="1">
+                <a:solidFill>
+                  <a:srgbClr val="FFFFFF"/>
+                </a:solidFill>
+              </a:rPr>
+              <a:t>解決策と結論：「音声を直す」より「ASRを慣れさせる」</a:t>
+            </a:r>
+          </a:p>
+        </p:txBody>
+      </p:sp>
+      <p:sp>
+        <p:nvSpPr>
+          <p:cNvPr id="4" name="TextBox 3"/>
+          <p:cNvSpPr txBox="1"/>
+          <p:nvPr/>
+        </p:nvSpPr>
+        <p:spPr>
+          <a:xfrm>
+            <a:off x="11247120" y="411480"/>
+            <a:ext cx="822960" cy="365760"/>
+          </a:xfrm>
+          <a:prstGeom prst="rect">
+            <a:avLst/>
+          </a:prstGeom>
+          <a:noFill/>
+        </p:spPr>
+        <p:txBody>
+          <a:bodyPr wrap="square">
+            <a:spAutoFit/>
+          </a:bodyPr>
+          <a:lstStyle/>
+          <a:p>
+            <a:pPr algn="r"/>
+            <a:r>
+              <a:rPr sz="1300" b="0">
+                <a:solidFill>
+                  <a:srgbClr val="78909C"/>
+                </a:solidFill>
+              </a:rPr>
+              <a:t>6 / 5</a:t>
             </a:r>
           </a:p>
         </p:txBody>

</xml_diff>

<commit_message>
Fix spectrum analysis description and expand conclusion
- §3.4: correct band description to 0–50 Hz (+15 dB artifact) vs
  0–0.5 kHz average; clarify 100 Hz+ is all suppression
- §4 考察: update spectrum reference with corrected figures
- §5 おわりに: restructure into novelty (3 contributions),
  limitations (3 points), and future work sections
- overview slide 5: fix band labels to match actual findings
- overview slide 7: add novelty/limits/future work slide (3 columns)

Co-Authored-By: Claude Sonnet 4.6 <noreply@anthropic.com>
</commit_message>
<xml_diff>
--- a/results/overview_slides.pptx
+++ b/results/overview_slides.pptx
@@ -4,15 +4,19 @@
   <p:sldMasterIdLst>
     <p:sldMasterId id="2147483648" r:id="rId1"/>
   </p:sldMasterIdLst>
+  <p:notesMasterIdLst>
+    <p:notesMasterId r:id="rId9"/>
+  </p:notesMasterIdLst>
   <p:sldIdLst>
-    <p:sldId id="256" r:id="rId7"/>
-    <p:sldId id="257" r:id="rId8"/>
-    <p:sldId id="258" r:id="rId9"/>
-    <p:sldId id="259" r:id="rId10"/>
-    <p:sldId id="260" r:id="rId11"/>
-    <p:sldId id="261" r:id="rId12"/>
+    <p:sldId id="256" r:id="rId2"/>
+    <p:sldId id="257" r:id="rId3"/>
+    <p:sldId id="258" r:id="rId4"/>
+    <p:sldId id="259" r:id="rId5"/>
+    <p:sldId id="260" r:id="rId6"/>
+    <p:sldId id="261" r:id="rId7"/>
+    <p:sldId id="262" r:id="rId8"/>
   </p:sldIdLst>
-  <p:sldSz cx="12188952" cy="6858000" type="screen4x3"/>
+  <p:sldSz cx="12188825" cy="6858000"/>
   <p:notesSz cx="6858000" cy="9144000"/>
   <p:defaultTextStyle>
     <a:defPPr>
@@ -109,7 +113,488 @@
       </a:defRPr>
     </a:lvl9pPr>
   </p:defaultTextStyle>
+  <p:extLst>
+    <p:ext uri="{EFAFB233-063F-42B5-8137-9DF3F51BA10A}">
+      <p15:sldGuideLst xmlns:p15="http://schemas.microsoft.com/office/powerpoint/2012/main">
+        <p15:guide id="1" orient="horz" pos="2160">
+          <p15:clr>
+            <a:srgbClr val="A4A3A4"/>
+          </p15:clr>
+        </p15:guide>
+        <p15:guide id="2" pos="2880">
+          <p15:clr>
+            <a:srgbClr val="A4A3A4"/>
+          </p15:clr>
+        </p15:guide>
+      </p15:sldGuideLst>
+    </p:ext>
+  </p:extLst>
 </p:presentation>
+</file>
+
+<file path=ppt/notesMasters/notesMaster1.xml><?xml version="1.0" encoding="utf-8"?>
+<p:notesMaster xmlns:a="http://schemas.openxmlformats.org/drawingml/2006/main" xmlns:r="http://schemas.openxmlformats.org/officeDocument/2006/relationships" xmlns:p="http://schemas.openxmlformats.org/presentationml/2006/main">
+  <p:cSld>
+    <p:bg>
+      <p:bgRef idx="1001">
+        <a:schemeClr val="bg1"/>
+      </p:bgRef>
+    </p:bg>
+    <p:spTree>
+      <p:nvGrpSpPr>
+        <p:cNvPr id="1" name=""/>
+        <p:cNvGrpSpPr/>
+        <p:nvPr/>
+      </p:nvGrpSpPr>
+      <p:grpSpPr>
+        <a:xfrm>
+          <a:off x="0" y="0"/>
+          <a:ext cx="0" cy="0"/>
+          <a:chOff x="0" y="0"/>
+          <a:chExt cx="0" cy="0"/>
+        </a:xfrm>
+      </p:grpSpPr>
+      <p:sp>
+        <p:nvSpPr>
+          <p:cNvPr id="2" name="ヘッダー プレースホルダー 1"/>
+          <p:cNvSpPr>
+            <a:spLocks noGrp="1"/>
+          </p:cNvSpPr>
+          <p:nvPr>
+            <p:ph type="hdr" sz="quarter"/>
+          </p:nvPr>
+        </p:nvSpPr>
+        <p:spPr>
+          <a:xfrm>
+            <a:off x="0" y="0"/>
+            <a:ext cx="2971800" cy="458788"/>
+          </a:xfrm>
+          <a:prstGeom prst="rect">
+            <a:avLst/>
+          </a:prstGeom>
+        </p:spPr>
+        <p:txBody>
+          <a:bodyPr vert="horz" lIns="91440" tIns="45720" rIns="91440" bIns="45720" rtlCol="0"/>
+          <a:lstStyle>
+            <a:lvl1pPr algn="l">
+              <a:defRPr sz="1200"/>
+            </a:lvl1pPr>
+          </a:lstStyle>
+          <a:p>
+            <a:endParaRPr kumimoji="1" lang="ja-JP" altLang="en-US"/>
+          </a:p>
+        </p:txBody>
+      </p:sp>
+      <p:sp>
+        <p:nvSpPr>
+          <p:cNvPr id="3" name="日付プレースホルダー 2"/>
+          <p:cNvSpPr>
+            <a:spLocks noGrp="1"/>
+          </p:cNvSpPr>
+          <p:nvPr>
+            <p:ph type="dt" idx="1"/>
+          </p:nvPr>
+        </p:nvSpPr>
+        <p:spPr>
+          <a:xfrm>
+            <a:off x="3884613" y="0"/>
+            <a:ext cx="2971800" cy="458788"/>
+          </a:xfrm>
+          <a:prstGeom prst="rect">
+            <a:avLst/>
+          </a:prstGeom>
+        </p:spPr>
+        <p:txBody>
+          <a:bodyPr vert="horz" lIns="91440" tIns="45720" rIns="91440" bIns="45720" rtlCol="0"/>
+          <a:lstStyle>
+            <a:lvl1pPr algn="r">
+              <a:defRPr sz="1200"/>
+            </a:lvl1pPr>
+          </a:lstStyle>
+          <a:p>
+            <a:fld id="{84453EA3-22D2-3A49-9DD1-F001874AB3A2}" type="datetimeFigureOut">
+              <a:rPr kumimoji="1" lang="ja-JP" altLang="en-US" smtClean="0"/>
+              <a:t>2026/4/15</a:t>
+            </a:fld>
+            <a:endParaRPr kumimoji="1" lang="ja-JP" altLang="en-US"/>
+          </a:p>
+        </p:txBody>
+      </p:sp>
+      <p:sp>
+        <p:nvSpPr>
+          <p:cNvPr id="4" name="スライド イメージ プレースホルダー 3"/>
+          <p:cNvSpPr>
+            <a:spLocks noGrp="1" noRot="1" noChangeAspect="1"/>
+          </p:cNvSpPr>
+          <p:nvPr>
+            <p:ph type="sldImg" idx="2"/>
+          </p:nvPr>
+        </p:nvSpPr>
+        <p:spPr>
+          <a:xfrm>
+            <a:off x="685800" y="1143000"/>
+            <a:ext cx="5486400" cy="3086100"/>
+          </a:xfrm>
+          <a:prstGeom prst="rect">
+            <a:avLst/>
+          </a:prstGeom>
+          <a:noFill/>
+          <a:ln w="12700">
+            <a:solidFill>
+              <a:prstClr val="black"/>
+            </a:solidFill>
+          </a:ln>
+        </p:spPr>
+        <p:txBody>
+          <a:bodyPr vert="horz" lIns="91440" tIns="45720" rIns="91440" bIns="45720" rtlCol="0" anchor="ctr"/>
+          <a:lstStyle/>
+          <a:p>
+            <a:endParaRPr lang="ja-JP" altLang="en-US"/>
+          </a:p>
+        </p:txBody>
+      </p:sp>
+      <p:sp>
+        <p:nvSpPr>
+          <p:cNvPr id="5" name="ノート プレースホルダー 4"/>
+          <p:cNvSpPr>
+            <a:spLocks noGrp="1"/>
+          </p:cNvSpPr>
+          <p:nvPr>
+            <p:ph type="body" sz="quarter" idx="3"/>
+          </p:nvPr>
+        </p:nvSpPr>
+        <p:spPr>
+          <a:xfrm>
+            <a:off x="685800" y="4400550"/>
+            <a:ext cx="5486400" cy="3600450"/>
+          </a:xfrm>
+          <a:prstGeom prst="rect">
+            <a:avLst/>
+          </a:prstGeom>
+        </p:spPr>
+        <p:txBody>
+          <a:bodyPr vert="horz" lIns="91440" tIns="45720" rIns="91440" bIns="45720" rtlCol="0"/>
+          <a:lstStyle/>
+          <a:p>
+            <a:pPr lvl="0"/>
+            <a:r>
+              <a:rPr kumimoji="1" lang="ja-JP" altLang="en-US"/>
+              <a:t>マスター テキストの書式設定</a:t>
+            </a:r>
+          </a:p>
+          <a:p>
+            <a:pPr lvl="1"/>
+            <a:r>
+              <a:rPr kumimoji="1" lang="ja-JP" altLang="en-US"/>
+              <a:t>第 </a:t>
+            </a:r>
+            <a:r>
+              <a:rPr kumimoji="1" lang="en-US" altLang="ja-JP"/>
+              <a:t>2 </a:t>
+            </a:r>
+            <a:r>
+              <a:rPr kumimoji="1" lang="ja-JP" altLang="en-US"/>
+              <a:t>レベル</a:t>
+            </a:r>
+          </a:p>
+          <a:p>
+            <a:pPr lvl="2"/>
+            <a:r>
+              <a:rPr kumimoji="1" lang="ja-JP" altLang="en-US"/>
+              <a:t>第 </a:t>
+            </a:r>
+            <a:r>
+              <a:rPr kumimoji="1" lang="en-US" altLang="ja-JP"/>
+              <a:t>3 </a:t>
+            </a:r>
+            <a:r>
+              <a:rPr kumimoji="1" lang="ja-JP" altLang="en-US"/>
+              <a:t>レベル</a:t>
+            </a:r>
+          </a:p>
+          <a:p>
+            <a:pPr lvl="3"/>
+            <a:r>
+              <a:rPr kumimoji="1" lang="ja-JP" altLang="en-US"/>
+              <a:t>第 </a:t>
+            </a:r>
+            <a:r>
+              <a:rPr kumimoji="1" lang="en-US" altLang="ja-JP"/>
+              <a:t>4 </a:t>
+            </a:r>
+            <a:r>
+              <a:rPr kumimoji="1" lang="ja-JP" altLang="en-US"/>
+              <a:t>レベル</a:t>
+            </a:r>
+          </a:p>
+          <a:p>
+            <a:pPr lvl="4"/>
+            <a:r>
+              <a:rPr kumimoji="1" lang="ja-JP" altLang="en-US"/>
+              <a:t>第 </a:t>
+            </a:r>
+            <a:r>
+              <a:rPr kumimoji="1" lang="en-US" altLang="ja-JP"/>
+              <a:t>5 </a:t>
+            </a:r>
+            <a:r>
+              <a:rPr kumimoji="1" lang="ja-JP" altLang="en-US"/>
+              <a:t>レベル</a:t>
+            </a:r>
+          </a:p>
+        </p:txBody>
+      </p:sp>
+      <p:sp>
+        <p:nvSpPr>
+          <p:cNvPr id="6" name="フッター プレースホルダー 5"/>
+          <p:cNvSpPr>
+            <a:spLocks noGrp="1"/>
+          </p:cNvSpPr>
+          <p:nvPr>
+            <p:ph type="ftr" sz="quarter" idx="4"/>
+          </p:nvPr>
+        </p:nvSpPr>
+        <p:spPr>
+          <a:xfrm>
+            <a:off x="0" y="8685213"/>
+            <a:ext cx="2971800" cy="458787"/>
+          </a:xfrm>
+          <a:prstGeom prst="rect">
+            <a:avLst/>
+          </a:prstGeom>
+        </p:spPr>
+        <p:txBody>
+          <a:bodyPr vert="horz" lIns="91440" tIns="45720" rIns="91440" bIns="45720" rtlCol="0" anchor="b"/>
+          <a:lstStyle>
+            <a:lvl1pPr algn="l">
+              <a:defRPr sz="1200"/>
+            </a:lvl1pPr>
+          </a:lstStyle>
+          <a:p>
+            <a:endParaRPr kumimoji="1" lang="ja-JP" altLang="en-US"/>
+          </a:p>
+        </p:txBody>
+      </p:sp>
+      <p:sp>
+        <p:nvSpPr>
+          <p:cNvPr id="7" name="スライド番号プレースホルダー 6"/>
+          <p:cNvSpPr>
+            <a:spLocks noGrp="1"/>
+          </p:cNvSpPr>
+          <p:nvPr>
+            <p:ph type="sldNum" sz="quarter" idx="5"/>
+          </p:nvPr>
+        </p:nvSpPr>
+        <p:spPr>
+          <a:xfrm>
+            <a:off x="3884613" y="8685213"/>
+            <a:ext cx="2971800" cy="458787"/>
+          </a:xfrm>
+          <a:prstGeom prst="rect">
+            <a:avLst/>
+          </a:prstGeom>
+        </p:spPr>
+        <p:txBody>
+          <a:bodyPr vert="horz" lIns="91440" tIns="45720" rIns="91440" bIns="45720" rtlCol="0" anchor="b"/>
+          <a:lstStyle>
+            <a:lvl1pPr algn="r">
+              <a:defRPr sz="1200"/>
+            </a:lvl1pPr>
+          </a:lstStyle>
+          <a:p>
+            <a:fld id="{599649C3-9C0A-BE4B-BB26-BD3C227AA350}" type="slidenum">
+              <a:rPr kumimoji="1" lang="ja-JP" altLang="en-US" smtClean="0"/>
+              <a:t>‹#›</a:t>
+            </a:fld>
+            <a:endParaRPr kumimoji="1" lang="ja-JP" altLang="en-US"/>
+          </a:p>
+        </p:txBody>
+      </p:sp>
+    </p:spTree>
+    <p:extLst>
+      <p:ext uri="{BB962C8B-B14F-4D97-AF65-F5344CB8AC3E}">
+        <p14:creationId xmlns:p14="http://schemas.microsoft.com/office/powerpoint/2010/main" val="393522308"/>
+      </p:ext>
+    </p:extLst>
+  </p:cSld>
+  <p:clrMap bg1="lt1" tx1="dk1" bg2="lt2" tx2="dk2" accent1="accent1" accent2="accent2" accent3="accent3" accent4="accent4" accent5="accent5" accent6="accent6" hlink="hlink" folHlink="folHlink"/>
+  <p:notesStyle>
+    <a:lvl1pPr marL="0" algn="l" defTabSz="914400" rtl="0" eaLnBrk="1" latinLnBrk="0" hangingPunct="1">
+      <a:defRPr kumimoji="1" sz="1200" kern="1200">
+        <a:solidFill>
+          <a:schemeClr val="tx1"/>
+        </a:solidFill>
+        <a:latin typeface="+mn-lt"/>
+        <a:ea typeface="+mn-ea"/>
+        <a:cs typeface="+mn-cs"/>
+      </a:defRPr>
+    </a:lvl1pPr>
+    <a:lvl2pPr marL="457200" algn="l" defTabSz="914400" rtl="0" eaLnBrk="1" latinLnBrk="0" hangingPunct="1">
+      <a:defRPr kumimoji="1" sz="1200" kern="1200">
+        <a:solidFill>
+          <a:schemeClr val="tx1"/>
+        </a:solidFill>
+        <a:latin typeface="+mn-lt"/>
+        <a:ea typeface="+mn-ea"/>
+        <a:cs typeface="+mn-cs"/>
+      </a:defRPr>
+    </a:lvl2pPr>
+    <a:lvl3pPr marL="914400" algn="l" defTabSz="914400" rtl="0" eaLnBrk="1" latinLnBrk="0" hangingPunct="1">
+      <a:defRPr kumimoji="1" sz="1200" kern="1200">
+        <a:solidFill>
+          <a:schemeClr val="tx1"/>
+        </a:solidFill>
+        <a:latin typeface="+mn-lt"/>
+        <a:ea typeface="+mn-ea"/>
+        <a:cs typeface="+mn-cs"/>
+      </a:defRPr>
+    </a:lvl3pPr>
+    <a:lvl4pPr marL="1371600" algn="l" defTabSz="914400" rtl="0" eaLnBrk="1" latinLnBrk="0" hangingPunct="1">
+      <a:defRPr kumimoji="1" sz="1200" kern="1200">
+        <a:solidFill>
+          <a:schemeClr val="tx1"/>
+        </a:solidFill>
+        <a:latin typeface="+mn-lt"/>
+        <a:ea typeface="+mn-ea"/>
+        <a:cs typeface="+mn-cs"/>
+      </a:defRPr>
+    </a:lvl4pPr>
+    <a:lvl5pPr marL="1828800" algn="l" defTabSz="914400" rtl="0" eaLnBrk="1" latinLnBrk="0" hangingPunct="1">
+      <a:defRPr kumimoji="1" sz="1200" kern="1200">
+        <a:solidFill>
+          <a:schemeClr val="tx1"/>
+        </a:solidFill>
+        <a:latin typeface="+mn-lt"/>
+        <a:ea typeface="+mn-ea"/>
+        <a:cs typeface="+mn-cs"/>
+      </a:defRPr>
+    </a:lvl5pPr>
+    <a:lvl6pPr marL="2286000" algn="l" defTabSz="914400" rtl="0" eaLnBrk="1" latinLnBrk="0" hangingPunct="1">
+      <a:defRPr kumimoji="1" sz="1200" kern="1200">
+        <a:solidFill>
+          <a:schemeClr val="tx1"/>
+        </a:solidFill>
+        <a:latin typeface="+mn-lt"/>
+        <a:ea typeface="+mn-ea"/>
+        <a:cs typeface="+mn-cs"/>
+      </a:defRPr>
+    </a:lvl6pPr>
+    <a:lvl7pPr marL="2743200" algn="l" defTabSz="914400" rtl="0" eaLnBrk="1" latinLnBrk="0" hangingPunct="1">
+      <a:defRPr kumimoji="1" sz="1200" kern="1200">
+        <a:solidFill>
+          <a:schemeClr val="tx1"/>
+        </a:solidFill>
+        <a:latin typeface="+mn-lt"/>
+        <a:ea typeface="+mn-ea"/>
+        <a:cs typeface="+mn-cs"/>
+      </a:defRPr>
+    </a:lvl7pPr>
+    <a:lvl8pPr marL="3200400" algn="l" defTabSz="914400" rtl="0" eaLnBrk="1" latinLnBrk="0" hangingPunct="1">
+      <a:defRPr kumimoji="1" sz="1200" kern="1200">
+        <a:solidFill>
+          <a:schemeClr val="tx1"/>
+        </a:solidFill>
+        <a:latin typeface="+mn-lt"/>
+        <a:ea typeface="+mn-ea"/>
+        <a:cs typeface="+mn-cs"/>
+      </a:defRPr>
+    </a:lvl8pPr>
+    <a:lvl9pPr marL="3657600" algn="l" defTabSz="914400" rtl="0" eaLnBrk="1" latinLnBrk="0" hangingPunct="1">
+      <a:defRPr kumimoji="1" sz="1200" kern="1200">
+        <a:solidFill>
+          <a:schemeClr val="tx1"/>
+        </a:solidFill>
+        <a:latin typeface="+mn-lt"/>
+        <a:ea typeface="+mn-ea"/>
+        <a:cs typeface="+mn-cs"/>
+      </a:defRPr>
+    </a:lvl9pPr>
+  </p:notesStyle>
+</p:notesMaster>
+</file>
+
+<file path=ppt/notesSlides/notesSlide1.xml><?xml version="1.0" encoding="utf-8"?>
+<p:notes xmlns:a="http://schemas.openxmlformats.org/drawingml/2006/main" xmlns:r="http://schemas.openxmlformats.org/officeDocument/2006/relationships" xmlns:p="http://schemas.openxmlformats.org/presentationml/2006/main">
+  <p:cSld>
+    <p:spTree>
+      <p:nvGrpSpPr>
+        <p:cNvPr id="1" name=""/>
+        <p:cNvGrpSpPr/>
+        <p:nvPr/>
+      </p:nvGrpSpPr>
+      <p:grpSpPr>
+        <a:xfrm>
+          <a:off x="0" y="0"/>
+          <a:ext cx="0" cy="0"/>
+          <a:chOff x="0" y="0"/>
+          <a:chExt cx="0" cy="0"/>
+        </a:xfrm>
+      </p:grpSpPr>
+      <p:sp>
+        <p:nvSpPr>
+          <p:cNvPr id="2" name="スライド イメージ プレースホルダー 1"/>
+          <p:cNvSpPr>
+            <a:spLocks noGrp="1" noRot="1" noChangeAspect="1"/>
+          </p:cNvSpPr>
+          <p:nvPr>
+            <p:ph type="sldImg"/>
+          </p:nvPr>
+        </p:nvSpPr>
+        <p:spPr/>
+      </p:sp>
+      <p:sp>
+        <p:nvSpPr>
+          <p:cNvPr id="3" name="ノート プレースホルダー 2"/>
+          <p:cNvSpPr>
+            <a:spLocks noGrp="1"/>
+          </p:cNvSpPr>
+          <p:nvPr>
+            <p:ph type="body" idx="1"/>
+          </p:nvPr>
+        </p:nvSpPr>
+        <p:spPr/>
+        <p:txBody>
+          <a:bodyPr/>
+          <a:lstStyle/>
+          <a:p>
+            <a:endParaRPr kumimoji="1" lang="ja-JP" altLang="en-US"/>
+          </a:p>
+        </p:txBody>
+      </p:sp>
+      <p:sp>
+        <p:nvSpPr>
+          <p:cNvPr id="4" name="スライド番号プレースホルダー 3"/>
+          <p:cNvSpPr>
+            <a:spLocks noGrp="1"/>
+          </p:cNvSpPr>
+          <p:nvPr>
+            <p:ph type="sldNum" sz="quarter" idx="5"/>
+          </p:nvPr>
+        </p:nvSpPr>
+        <p:spPr/>
+        <p:txBody>
+          <a:bodyPr/>
+          <a:lstStyle/>
+          <a:p>
+            <a:fld id="{599649C3-9C0A-BE4B-BB26-BD3C227AA350}" type="slidenum">
+              <a:rPr kumimoji="1" lang="ja-JP" altLang="en-US" smtClean="0"/>
+              <a:t>5</a:t>
+            </a:fld>
+            <a:endParaRPr kumimoji="1" lang="ja-JP" altLang="en-US"/>
+          </a:p>
+        </p:txBody>
+      </p:sp>
+    </p:spTree>
+    <p:extLst>
+      <p:ext uri="{BB962C8B-B14F-4D97-AF65-F5344CB8AC3E}">
+        <p14:creationId xmlns:p14="http://schemas.microsoft.com/office/powerpoint/2010/main" val="1796751383"/>
+      </p:ext>
+    </p:extLst>
+  </p:cSld>
+  <p:clrMapOvr>
+    <a:masterClrMapping/>
+  </p:clrMapOvr>
+</p:notes>
 </file>
 
 <file path=ppt/slideLayouts/slideLayout1.xml><?xml version="1.0" encoding="utf-8"?>
@@ -150,10 +635,9 @@
           <a:lstStyle/>
           <a:p>
             <a:r>
-              <a:rPr lang="en-US" smtClean="0"/>
+              <a:rPr lang="en-US"/>
               <a:t>Click to edit Master title style</a:t>
             </a:r>
-            <a:endParaRPr lang="en-US"/>
           </a:p>
         </p:txBody>
       </p:sp>
@@ -269,10 +753,9 @@
           </a:lstStyle>
           <a:p>
             <a:r>
-              <a:rPr lang="en-US" smtClean="0"/>
+              <a:rPr lang="en-US"/>
               <a:t>Click to edit Master subtitle style</a:t>
             </a:r>
-            <a:endParaRPr lang="en-US"/>
           </a:p>
         </p:txBody>
       </p:sp>
@@ -293,7 +776,7 @@
           <a:p>
             <a:fld id="{5BCAD085-E8A6-8845-BD4E-CB4CCA059FC4}" type="datetimeFigureOut">
               <a:rPr lang="en-US" smtClean="0"/>
-              <a:t>1/27/13</a:t>
+              <a:t>4/15/26</a:t>
             </a:fld>
             <a:endParaRPr lang="en-US"/>
           </a:p>
@@ -387,10 +870,9 @@
           <a:lstStyle/>
           <a:p>
             <a:r>
-              <a:rPr lang="en-US" smtClean="0"/>
+              <a:rPr lang="en-US"/>
               <a:t>Click to edit Master title style</a:t>
             </a:r>
-            <a:endParaRPr lang="en-US"/>
           </a:p>
         </p:txBody>
       </p:sp>
@@ -411,38 +893,37 @@
           <a:p>
             <a:pPr lvl="0"/>
             <a:r>
-              <a:rPr lang="en-US" smtClean="0"/>
+              <a:rPr lang="en-US"/>
               <a:t>Click to edit Master text styles</a:t>
             </a:r>
           </a:p>
           <a:p>
             <a:pPr lvl="1"/>
             <a:r>
-              <a:rPr lang="en-US" smtClean="0"/>
+              <a:rPr lang="en-US"/>
               <a:t>Second level</a:t>
             </a:r>
           </a:p>
           <a:p>
             <a:pPr lvl="2"/>
             <a:r>
-              <a:rPr lang="en-US" smtClean="0"/>
+              <a:rPr lang="en-US"/>
               <a:t>Third level</a:t>
             </a:r>
           </a:p>
           <a:p>
             <a:pPr lvl="3"/>
             <a:r>
-              <a:rPr lang="en-US" smtClean="0"/>
+              <a:rPr lang="en-US"/>
               <a:t>Fourth level</a:t>
             </a:r>
           </a:p>
           <a:p>
             <a:pPr lvl="4"/>
             <a:r>
-              <a:rPr lang="en-US" smtClean="0"/>
+              <a:rPr lang="en-US"/>
               <a:t>Fifth level</a:t>
             </a:r>
-            <a:endParaRPr lang="en-US"/>
           </a:p>
         </p:txBody>
       </p:sp>
@@ -463,7 +944,7 @@
           <a:p>
             <a:fld id="{5BCAD085-E8A6-8845-BD4E-CB4CCA059FC4}" type="datetimeFigureOut">
               <a:rPr lang="en-US" smtClean="0"/>
-              <a:t>1/27/13</a:t>
+              <a:t>4/15/26</a:t>
             </a:fld>
             <a:endParaRPr lang="en-US"/>
           </a:p>
@@ -562,10 +1043,9 @@
           <a:lstStyle/>
           <a:p>
             <a:r>
-              <a:rPr lang="en-US" smtClean="0"/>
+              <a:rPr lang="en-US"/>
               <a:t>Click to edit Master title style</a:t>
             </a:r>
-            <a:endParaRPr lang="en-US"/>
           </a:p>
         </p:txBody>
       </p:sp>
@@ -591,38 +1071,37 @@
           <a:p>
             <a:pPr lvl="0"/>
             <a:r>
-              <a:rPr lang="en-US" smtClean="0"/>
+              <a:rPr lang="en-US"/>
               <a:t>Click to edit Master text styles</a:t>
             </a:r>
           </a:p>
           <a:p>
             <a:pPr lvl="1"/>
             <a:r>
-              <a:rPr lang="en-US" smtClean="0"/>
+              <a:rPr lang="en-US"/>
               <a:t>Second level</a:t>
             </a:r>
           </a:p>
           <a:p>
             <a:pPr lvl="2"/>
             <a:r>
-              <a:rPr lang="en-US" smtClean="0"/>
+              <a:rPr lang="en-US"/>
               <a:t>Third level</a:t>
             </a:r>
           </a:p>
           <a:p>
             <a:pPr lvl="3"/>
             <a:r>
-              <a:rPr lang="en-US" smtClean="0"/>
+              <a:rPr lang="en-US"/>
               <a:t>Fourth level</a:t>
             </a:r>
           </a:p>
           <a:p>
             <a:pPr lvl="4"/>
             <a:r>
-              <a:rPr lang="en-US" smtClean="0"/>
+              <a:rPr lang="en-US"/>
               <a:t>Fifth level</a:t>
             </a:r>
-            <a:endParaRPr lang="en-US"/>
           </a:p>
         </p:txBody>
       </p:sp>
@@ -643,7 +1122,7 @@
           <a:p>
             <a:fld id="{5BCAD085-E8A6-8845-BD4E-CB4CCA059FC4}" type="datetimeFigureOut">
               <a:rPr lang="en-US" smtClean="0"/>
-              <a:t>1/27/13</a:t>
+              <a:t>4/15/26</a:t>
             </a:fld>
             <a:endParaRPr lang="en-US"/>
           </a:p>
@@ -737,10 +1216,9 @@
           <a:lstStyle/>
           <a:p>
             <a:r>
-              <a:rPr lang="en-US" smtClean="0"/>
+              <a:rPr lang="en-US"/>
               <a:t>Click to edit Master title style</a:t>
             </a:r>
-            <a:endParaRPr lang="en-US"/>
           </a:p>
         </p:txBody>
       </p:sp>
@@ -761,38 +1239,37 @@
           <a:p>
             <a:pPr lvl="0"/>
             <a:r>
-              <a:rPr lang="en-US" smtClean="0"/>
+              <a:rPr lang="en-US"/>
               <a:t>Click to edit Master text styles</a:t>
             </a:r>
           </a:p>
           <a:p>
             <a:pPr lvl="1"/>
             <a:r>
-              <a:rPr lang="en-US" smtClean="0"/>
+              <a:rPr lang="en-US"/>
               <a:t>Second level</a:t>
             </a:r>
           </a:p>
           <a:p>
             <a:pPr lvl="2"/>
             <a:r>
-              <a:rPr lang="en-US" smtClean="0"/>
+              <a:rPr lang="en-US"/>
               <a:t>Third level</a:t>
             </a:r>
           </a:p>
           <a:p>
             <a:pPr lvl="3"/>
             <a:r>
-              <a:rPr lang="en-US" smtClean="0"/>
+              <a:rPr lang="en-US"/>
               <a:t>Fourth level</a:t>
             </a:r>
           </a:p>
           <a:p>
             <a:pPr lvl="4"/>
             <a:r>
-              <a:rPr lang="en-US" smtClean="0"/>
+              <a:rPr lang="en-US"/>
               <a:t>Fifth level</a:t>
             </a:r>
-            <a:endParaRPr lang="en-US"/>
           </a:p>
         </p:txBody>
       </p:sp>
@@ -813,7 +1290,7 @@
           <a:p>
             <a:fld id="{5BCAD085-E8A6-8845-BD4E-CB4CCA059FC4}" type="datetimeFigureOut">
               <a:rPr lang="en-US" smtClean="0"/>
-              <a:t>1/27/13</a:t>
+              <a:t>4/15/26</a:t>
             </a:fld>
             <a:endParaRPr lang="en-US"/>
           </a:p>
@@ -916,10 +1393,9 @@
           </a:lstStyle>
           <a:p>
             <a:r>
-              <a:rPr lang="en-US" smtClean="0"/>
+              <a:rPr lang="en-US"/>
               <a:t>Click to edit Master title style</a:t>
             </a:r>
-            <a:endParaRPr lang="en-US"/>
           </a:p>
         </p:txBody>
       </p:sp>
@@ -1036,7 +1512,7 @@
           <a:p>
             <a:pPr lvl="0"/>
             <a:r>
-              <a:rPr lang="en-US" smtClean="0"/>
+              <a:rPr lang="en-US"/>
               <a:t>Click to edit Master text styles</a:t>
             </a:r>
           </a:p>
@@ -1059,7 +1535,7 @@
           <a:p>
             <a:fld id="{5BCAD085-E8A6-8845-BD4E-CB4CCA059FC4}" type="datetimeFigureOut">
               <a:rPr lang="en-US" smtClean="0"/>
-              <a:t>1/27/13</a:t>
+              <a:t>4/15/26</a:t>
             </a:fld>
             <a:endParaRPr lang="en-US"/>
           </a:p>
@@ -1153,10 +1629,9 @@
           <a:lstStyle/>
           <a:p>
             <a:r>
-              <a:rPr lang="en-US" smtClean="0"/>
+              <a:rPr lang="en-US"/>
               <a:t>Click to edit Master title style</a:t>
             </a:r>
-            <a:endParaRPr lang="en-US"/>
           </a:p>
         </p:txBody>
       </p:sp>
@@ -1210,38 +1685,37 @@
           <a:p>
             <a:pPr lvl="0"/>
             <a:r>
-              <a:rPr lang="en-US" smtClean="0"/>
+              <a:rPr lang="en-US"/>
               <a:t>Click to edit Master text styles</a:t>
             </a:r>
           </a:p>
           <a:p>
             <a:pPr lvl="1"/>
             <a:r>
-              <a:rPr lang="en-US" smtClean="0"/>
+              <a:rPr lang="en-US"/>
               <a:t>Second level</a:t>
             </a:r>
           </a:p>
           <a:p>
             <a:pPr lvl="2"/>
             <a:r>
-              <a:rPr lang="en-US" smtClean="0"/>
+              <a:rPr lang="en-US"/>
               <a:t>Third level</a:t>
             </a:r>
           </a:p>
           <a:p>
             <a:pPr lvl="3"/>
             <a:r>
-              <a:rPr lang="en-US" smtClean="0"/>
+              <a:rPr lang="en-US"/>
               <a:t>Fourth level</a:t>
             </a:r>
           </a:p>
           <a:p>
             <a:pPr lvl="4"/>
             <a:r>
-              <a:rPr lang="en-US" smtClean="0"/>
+              <a:rPr lang="en-US"/>
               <a:t>Fifth level</a:t>
             </a:r>
-            <a:endParaRPr lang="en-US"/>
           </a:p>
         </p:txBody>
       </p:sp>
@@ -1295,38 +1769,37 @@
           <a:p>
             <a:pPr lvl="0"/>
             <a:r>
-              <a:rPr lang="en-US" smtClean="0"/>
+              <a:rPr lang="en-US"/>
               <a:t>Click to edit Master text styles</a:t>
             </a:r>
           </a:p>
           <a:p>
             <a:pPr lvl="1"/>
             <a:r>
-              <a:rPr lang="en-US" smtClean="0"/>
+              <a:rPr lang="en-US"/>
               <a:t>Second level</a:t>
             </a:r>
           </a:p>
           <a:p>
             <a:pPr lvl="2"/>
             <a:r>
-              <a:rPr lang="en-US" smtClean="0"/>
+              <a:rPr lang="en-US"/>
               <a:t>Third level</a:t>
             </a:r>
           </a:p>
           <a:p>
             <a:pPr lvl="3"/>
             <a:r>
-              <a:rPr lang="en-US" smtClean="0"/>
+              <a:rPr lang="en-US"/>
               <a:t>Fourth level</a:t>
             </a:r>
           </a:p>
           <a:p>
             <a:pPr lvl="4"/>
             <a:r>
-              <a:rPr lang="en-US" smtClean="0"/>
+              <a:rPr lang="en-US"/>
               <a:t>Fifth level</a:t>
             </a:r>
-            <a:endParaRPr lang="en-US"/>
           </a:p>
         </p:txBody>
       </p:sp>
@@ -1347,7 +1820,7 @@
           <a:p>
             <a:fld id="{5BCAD085-E8A6-8845-BD4E-CB4CCA059FC4}" type="datetimeFigureOut">
               <a:rPr lang="en-US" smtClean="0"/>
-              <a:t>1/27/13</a:t>
+              <a:t>4/15/26</a:t>
             </a:fld>
             <a:endParaRPr lang="en-US"/>
           </a:p>
@@ -1445,10 +1918,9 @@
           </a:lstStyle>
           <a:p>
             <a:r>
-              <a:rPr lang="en-US" smtClean="0"/>
+              <a:rPr lang="en-US"/>
               <a:t>Click to edit Master title style</a:t>
             </a:r>
-            <a:endParaRPr lang="en-US"/>
           </a:p>
         </p:txBody>
       </p:sp>
@@ -1511,7 +1983,7 @@
           <a:p>
             <a:pPr lvl="0"/>
             <a:r>
-              <a:rPr lang="en-US" smtClean="0"/>
+              <a:rPr lang="en-US"/>
               <a:t>Click to edit Master text styles</a:t>
             </a:r>
           </a:p>
@@ -1567,38 +2039,37 @@
           <a:p>
             <a:pPr lvl="0"/>
             <a:r>
-              <a:rPr lang="en-US" smtClean="0"/>
+              <a:rPr lang="en-US"/>
               <a:t>Click to edit Master text styles</a:t>
             </a:r>
           </a:p>
           <a:p>
             <a:pPr lvl="1"/>
             <a:r>
-              <a:rPr lang="en-US" smtClean="0"/>
+              <a:rPr lang="en-US"/>
               <a:t>Second level</a:t>
             </a:r>
           </a:p>
           <a:p>
             <a:pPr lvl="2"/>
             <a:r>
-              <a:rPr lang="en-US" smtClean="0"/>
+              <a:rPr lang="en-US"/>
               <a:t>Third level</a:t>
             </a:r>
           </a:p>
           <a:p>
             <a:pPr lvl="3"/>
             <a:r>
-              <a:rPr lang="en-US" smtClean="0"/>
+              <a:rPr lang="en-US"/>
               <a:t>Fourth level</a:t>
             </a:r>
           </a:p>
           <a:p>
             <a:pPr lvl="4"/>
             <a:r>
-              <a:rPr lang="en-US" smtClean="0"/>
+              <a:rPr lang="en-US"/>
               <a:t>Fifth level</a:t>
             </a:r>
-            <a:endParaRPr lang="en-US"/>
           </a:p>
         </p:txBody>
       </p:sp>
@@ -1661,7 +2132,7 @@
           <a:p>
             <a:pPr lvl="0"/>
             <a:r>
-              <a:rPr lang="en-US" smtClean="0"/>
+              <a:rPr lang="en-US"/>
               <a:t>Click to edit Master text styles</a:t>
             </a:r>
           </a:p>
@@ -1717,38 +2188,37 @@
           <a:p>
             <a:pPr lvl="0"/>
             <a:r>
-              <a:rPr lang="en-US" smtClean="0"/>
+              <a:rPr lang="en-US"/>
               <a:t>Click to edit Master text styles</a:t>
             </a:r>
           </a:p>
           <a:p>
             <a:pPr lvl="1"/>
             <a:r>
-              <a:rPr lang="en-US" smtClean="0"/>
+              <a:rPr lang="en-US"/>
               <a:t>Second level</a:t>
             </a:r>
           </a:p>
           <a:p>
             <a:pPr lvl="2"/>
             <a:r>
-              <a:rPr lang="en-US" smtClean="0"/>
+              <a:rPr lang="en-US"/>
               <a:t>Third level</a:t>
             </a:r>
           </a:p>
           <a:p>
             <a:pPr lvl="3"/>
             <a:r>
-              <a:rPr lang="en-US" smtClean="0"/>
+              <a:rPr lang="en-US"/>
               <a:t>Fourth level</a:t>
             </a:r>
           </a:p>
           <a:p>
             <a:pPr lvl="4"/>
             <a:r>
-              <a:rPr lang="en-US" smtClean="0"/>
+              <a:rPr lang="en-US"/>
               <a:t>Fifth level</a:t>
             </a:r>
-            <a:endParaRPr lang="en-US"/>
           </a:p>
         </p:txBody>
       </p:sp>
@@ -1769,7 +2239,7 @@
           <a:p>
             <a:fld id="{5BCAD085-E8A6-8845-BD4E-CB4CCA059FC4}" type="datetimeFigureOut">
               <a:rPr lang="en-US" smtClean="0"/>
-              <a:t>1/27/13</a:t>
+              <a:t>4/15/26</a:t>
             </a:fld>
             <a:endParaRPr lang="en-US"/>
           </a:p>
@@ -1863,10 +2333,9 @@
           <a:lstStyle/>
           <a:p>
             <a:r>
-              <a:rPr lang="en-US" smtClean="0"/>
+              <a:rPr lang="en-US"/>
               <a:t>Click to edit Master title style</a:t>
             </a:r>
-            <a:endParaRPr lang="en-US"/>
           </a:p>
         </p:txBody>
       </p:sp>
@@ -1887,7 +2356,7 @@
           <a:p>
             <a:fld id="{5BCAD085-E8A6-8845-BD4E-CB4CCA059FC4}" type="datetimeFigureOut">
               <a:rPr lang="en-US" smtClean="0"/>
-              <a:t>1/27/13</a:t>
+              <a:t>4/15/26</a:t>
             </a:fld>
             <a:endParaRPr lang="en-US"/>
           </a:p>
@@ -1982,7 +2451,7 @@
           <a:p>
             <a:fld id="{5BCAD085-E8A6-8845-BD4E-CB4CCA059FC4}" type="datetimeFigureOut">
               <a:rPr lang="en-US" smtClean="0"/>
-              <a:t>1/27/13</a:t>
+              <a:t>4/15/26</a:t>
             </a:fld>
             <a:endParaRPr lang="en-US"/>
           </a:p>
@@ -2085,10 +2554,9 @@
           </a:lstStyle>
           <a:p>
             <a:r>
-              <a:rPr lang="en-US" smtClean="0"/>
+              <a:rPr lang="en-US"/>
               <a:t>Click to edit Master title style</a:t>
             </a:r>
-            <a:endParaRPr lang="en-US"/>
           </a:p>
         </p:txBody>
       </p:sp>
@@ -2142,38 +2610,37 @@
           <a:p>
             <a:pPr lvl="0"/>
             <a:r>
-              <a:rPr lang="en-US" smtClean="0"/>
+              <a:rPr lang="en-US"/>
               <a:t>Click to edit Master text styles</a:t>
             </a:r>
           </a:p>
           <a:p>
             <a:pPr lvl="1"/>
             <a:r>
-              <a:rPr lang="en-US" smtClean="0"/>
+              <a:rPr lang="en-US"/>
               <a:t>Second level</a:t>
             </a:r>
           </a:p>
           <a:p>
             <a:pPr lvl="2"/>
             <a:r>
-              <a:rPr lang="en-US" smtClean="0"/>
+              <a:rPr lang="en-US"/>
               <a:t>Third level</a:t>
             </a:r>
           </a:p>
           <a:p>
             <a:pPr lvl="3"/>
             <a:r>
-              <a:rPr lang="en-US" smtClean="0"/>
+              <a:rPr lang="en-US"/>
               <a:t>Fourth level</a:t>
             </a:r>
           </a:p>
           <a:p>
             <a:pPr lvl="4"/>
             <a:r>
-              <a:rPr lang="en-US" smtClean="0"/>
+              <a:rPr lang="en-US"/>
               <a:t>Fifth level</a:t>
             </a:r>
-            <a:endParaRPr lang="en-US"/>
           </a:p>
         </p:txBody>
       </p:sp>
@@ -2236,7 +2703,7 @@
           <a:p>
             <a:pPr lvl="0"/>
             <a:r>
-              <a:rPr lang="en-US" smtClean="0"/>
+              <a:rPr lang="en-US"/>
               <a:t>Click to edit Master text styles</a:t>
             </a:r>
           </a:p>
@@ -2259,7 +2726,7 @@
           <a:p>
             <a:fld id="{5BCAD085-E8A6-8845-BD4E-CB4CCA059FC4}" type="datetimeFigureOut">
               <a:rPr lang="en-US" smtClean="0"/>
-              <a:t>1/27/13</a:t>
+              <a:t>4/15/26</a:t>
             </a:fld>
             <a:endParaRPr lang="en-US"/>
           </a:p>
@@ -2362,10 +2829,9 @@
           </a:lstStyle>
           <a:p>
             <a:r>
-              <a:rPr lang="en-US" smtClean="0"/>
+              <a:rPr lang="en-US"/>
               <a:t>Click to edit Master title style</a:t>
             </a:r>
-            <a:endParaRPr lang="en-US"/>
           </a:p>
         </p:txBody>
       </p:sp>
@@ -2489,7 +2955,7 @@
           <a:p>
             <a:pPr lvl="0"/>
             <a:r>
-              <a:rPr lang="en-US" smtClean="0"/>
+              <a:rPr lang="en-US"/>
               <a:t>Click to edit Master text styles</a:t>
             </a:r>
           </a:p>
@@ -2512,7 +2978,7 @@
           <a:p>
             <a:fld id="{5BCAD085-E8A6-8845-BD4E-CB4CCA059FC4}" type="datetimeFigureOut">
               <a:rPr lang="en-US" smtClean="0"/>
-              <a:t>1/27/13</a:t>
+              <a:t>4/15/26</a:t>
             </a:fld>
             <a:endParaRPr lang="en-US"/>
           </a:p>
@@ -2621,10 +3087,9 @@
           <a:lstStyle/>
           <a:p>
             <a:r>
-              <a:rPr lang="en-US" smtClean="0"/>
+              <a:rPr lang="en-US"/>
               <a:t>Click to edit Master title style</a:t>
             </a:r>
-            <a:endParaRPr lang="en-US"/>
           </a:p>
         </p:txBody>
       </p:sp>
@@ -2655,38 +3120,37 @@
           <a:p>
             <a:pPr lvl="0"/>
             <a:r>
-              <a:rPr lang="en-US" smtClean="0"/>
+              <a:rPr lang="en-US"/>
               <a:t>Click to edit Master text styles</a:t>
             </a:r>
           </a:p>
           <a:p>
             <a:pPr lvl="1"/>
             <a:r>
-              <a:rPr lang="en-US" smtClean="0"/>
+              <a:rPr lang="en-US"/>
               <a:t>Second level</a:t>
             </a:r>
           </a:p>
           <a:p>
             <a:pPr lvl="2"/>
             <a:r>
-              <a:rPr lang="en-US" smtClean="0"/>
+              <a:rPr lang="en-US"/>
               <a:t>Third level</a:t>
             </a:r>
           </a:p>
           <a:p>
             <a:pPr lvl="3"/>
             <a:r>
-              <a:rPr lang="en-US" smtClean="0"/>
+              <a:rPr lang="en-US"/>
               <a:t>Fourth level</a:t>
             </a:r>
           </a:p>
           <a:p>
             <a:pPr lvl="4"/>
             <a:r>
-              <a:rPr lang="en-US" smtClean="0"/>
+              <a:rPr lang="en-US"/>
               <a:t>Fifth level</a:t>
             </a:r>
-            <a:endParaRPr lang="en-US"/>
           </a:p>
         </p:txBody>
       </p:sp>
@@ -2725,7 +3189,7 @@
           <a:p>
             <a:fld id="{5BCAD085-E8A6-8845-BD4E-CB4CCA059FC4}" type="datetimeFigureOut">
               <a:rPr lang="en-US" smtClean="0"/>
-              <a:t>1/27/13</a:t>
+              <a:t>4/15/26</a:t>
             </a:fld>
             <a:endParaRPr lang="en-US"/>
           </a:p>
@@ -3084,7 +3548,7 @@
 </file>
 
 <file path=ppt/slides/slide1.xml><?xml version="1.0" encoding="utf-8"?>
-<p:sld xmlns:a="http://schemas.openxmlformats.org/drawingml/2006/main" xmlns:p="http://schemas.openxmlformats.org/presentationml/2006/main" xmlns:r="http://schemas.openxmlformats.org/officeDocument/2006/relationships">
+<p:sld xmlns:a="http://schemas.openxmlformats.org/drawingml/2006/main" xmlns:r="http://schemas.openxmlformats.org/officeDocument/2006/relationships" xmlns:p="http://schemas.openxmlformats.org/presentationml/2006/main">
   <p:cSld>
     <p:spTree>
       <p:nvGrpSpPr>
@@ -3092,7 +3556,14 @@
         <p:cNvGrpSpPr/>
         <p:nvPr/>
       </p:nvGrpSpPr>
-      <p:grpSpPr/>
+      <p:grpSpPr>
+        <a:xfrm>
+          <a:off x="0" y="0"/>
+          <a:ext cx="0" cy="0"/>
+          <a:chOff x="0" y="0"/>
+          <a:chExt cx="0" cy="0"/>
+        </a:xfrm>
+      </p:grpSpPr>
       <p:sp>
         <p:nvSpPr>
           <p:cNvPr id="2" name="Rectangle 1"/>
@@ -3133,6 +3604,7 @@
           <a:lstStyle/>
           <a:p>
             <a:pPr algn="ctr"/>
+            <a:endParaRPr/>
           </a:p>
         </p:txBody>
       </p:sp>
@@ -3176,6 +3648,7 @@
           <a:lstStyle/>
           <a:p>
             <a:pPr algn="ctr"/>
+            <a:endParaRPr/>
           </a:p>
         </p:txBody>
       </p:sp>
@@ -3288,6 +3761,7 @@
           <a:lstStyle/>
           <a:p>
             <a:pPr algn="ctr"/>
+            <a:endParaRPr/>
           </a:p>
         </p:txBody>
       </p:sp>
@@ -3365,6 +3839,7 @@
           <a:lstStyle/>
           <a:p>
             <a:pPr algn="ctr"/>
+            <a:endParaRPr/>
           </a:p>
         </p:txBody>
       </p:sp>
@@ -3442,6 +3917,7 @@
           <a:lstStyle/>
           <a:p>
             <a:pPr algn="ctr"/>
+            <a:endParaRPr/>
           </a:p>
         </p:txBody>
       </p:sp>
@@ -3519,6 +3995,7 @@
           <a:lstStyle/>
           <a:p>
             <a:pPr algn="ctr"/>
+            <a:endParaRPr/>
           </a:p>
         </p:txBody>
       </p:sp>
@@ -3630,6 +4107,7 @@
           <a:lstStyle/>
           <a:p>
             <a:pPr algn="ctr"/>
+            <a:endParaRPr/>
           </a:p>
         </p:txBody>
       </p:sp>
@@ -3676,7 +4154,7 @@
 </file>
 
 <file path=ppt/slides/slide2.xml><?xml version="1.0" encoding="utf-8"?>
-<p:sld xmlns:a="http://schemas.openxmlformats.org/drawingml/2006/main" xmlns:p="http://schemas.openxmlformats.org/presentationml/2006/main" xmlns:r="http://schemas.openxmlformats.org/officeDocument/2006/relationships">
+<p:sld xmlns:a="http://schemas.openxmlformats.org/drawingml/2006/main" xmlns:r="http://schemas.openxmlformats.org/officeDocument/2006/relationships" xmlns:p="http://schemas.openxmlformats.org/presentationml/2006/main">
   <p:cSld>
     <p:spTree>
       <p:nvGrpSpPr>
@@ -3684,7 +4162,14 @@
         <p:cNvGrpSpPr/>
         <p:nvPr/>
       </p:nvGrpSpPr>
-      <p:grpSpPr/>
+      <p:grpSpPr>
+        <a:xfrm>
+          <a:off x="0" y="0"/>
+          <a:ext cx="0" cy="0"/>
+          <a:chOff x="0" y="0"/>
+          <a:chExt cx="0" cy="0"/>
+        </a:xfrm>
+      </p:grpSpPr>
       <p:sp>
         <p:nvSpPr>
           <p:cNvPr id="2" name="Rectangle 1"/>
@@ -3725,6 +4210,7 @@
           <a:lstStyle/>
           <a:p>
             <a:pPr algn="ctr"/>
+            <a:endParaRPr/>
           </a:p>
         </p:txBody>
       </p:sp>
@@ -3836,6 +4322,7 @@
           <a:lstStyle/>
           <a:p>
             <a:pPr algn="ctr"/>
+            <a:endParaRPr/>
           </a:p>
         </p:txBody>
       </p:sp>
@@ -3913,6 +4400,7 @@
           <a:lstStyle/>
           <a:p>
             <a:pPr algn="ctr"/>
+            <a:endParaRPr/>
           </a:p>
         </p:txBody>
       </p:sp>
@@ -4075,14 +4563,7 @@
           <a:lstStyle/>
           <a:p>
             <a:pPr algn="l"/>
-            <a:r>
-              <a:rPr sz="1300" b="0">
-                <a:solidFill>
-                  <a:srgbClr val="212121"/>
-                </a:solidFill>
-              </a:rPr>
-              <a:t/>
-            </a:r>
+            <a:endParaRPr/>
           </a:p>
         </p:txBody>
       </p:sp>
@@ -4245,14 +4726,7 @@
           <a:lstStyle/>
           <a:p>
             <a:pPr algn="l"/>
-            <a:r>
-              <a:rPr sz="1300" b="0">
-                <a:solidFill>
-                  <a:srgbClr val="212121"/>
-                </a:solidFill>
-              </a:rPr>
-              <a:t/>
-            </a:r>
+            <a:endParaRPr/>
           </a:p>
         </p:txBody>
       </p:sp>
@@ -4422,6 +4896,7 @@
           <a:lstStyle/>
           <a:p>
             <a:pPr algn="ctr"/>
+            <a:endParaRPr/>
           </a:p>
         </p:txBody>
       </p:sp>
@@ -4468,7 +4943,7 @@
 </file>
 
 <file path=ppt/slides/slide3.xml><?xml version="1.0" encoding="utf-8"?>
-<p:sld xmlns:a="http://schemas.openxmlformats.org/drawingml/2006/main" xmlns:p="http://schemas.openxmlformats.org/presentationml/2006/main" xmlns:r="http://schemas.openxmlformats.org/officeDocument/2006/relationships">
+<p:sld xmlns:a="http://schemas.openxmlformats.org/drawingml/2006/main" xmlns:r="http://schemas.openxmlformats.org/officeDocument/2006/relationships" xmlns:p="http://schemas.openxmlformats.org/presentationml/2006/main">
   <p:cSld>
     <p:spTree>
       <p:nvGrpSpPr>
@@ -4476,7 +4951,14 @@
         <p:cNvGrpSpPr/>
         <p:nvPr/>
       </p:nvGrpSpPr>
-      <p:grpSpPr/>
+      <p:grpSpPr>
+        <a:xfrm>
+          <a:off x="0" y="0"/>
+          <a:ext cx="0" cy="0"/>
+          <a:chOff x="0" y="0"/>
+          <a:chExt cx="0" cy="0"/>
+        </a:xfrm>
+      </p:grpSpPr>
       <p:sp>
         <p:nvSpPr>
           <p:cNvPr id="2" name="Rectangle 1"/>
@@ -4517,6 +4999,7 @@
           <a:lstStyle/>
           <a:p>
             <a:pPr algn="ctr"/>
+            <a:endParaRPr/>
           </a:p>
         </p:txBody>
       </p:sp>
@@ -4628,6 +5111,7 @@
           <a:lstStyle/>
           <a:p>
             <a:pPr algn="ctr"/>
+            <a:endParaRPr/>
           </a:p>
         </p:txBody>
       </p:sp>
@@ -4705,6 +5189,7 @@
           <a:lstStyle/>
           <a:p>
             <a:pPr algn="ctr"/>
+            <a:endParaRPr/>
           </a:p>
         </p:txBody>
       </p:sp>
@@ -4918,6 +5403,7 @@
           <a:lstStyle/>
           <a:p>
             <a:pPr algn="ctr"/>
+            <a:endParaRPr/>
           </a:p>
         </p:txBody>
       </p:sp>
@@ -4995,6 +5481,7 @@
           <a:lstStyle/>
           <a:p>
             <a:pPr algn="ctr"/>
+            <a:endParaRPr/>
           </a:p>
         </p:txBody>
       </p:sp>
@@ -5107,6 +5594,7 @@
           <a:lstStyle/>
           <a:p>
             <a:pPr algn="ctr"/>
+            <a:endParaRPr/>
           </a:p>
         </p:txBody>
       </p:sp>
@@ -5219,6 +5707,7 @@
           <a:lstStyle/>
           <a:p>
             <a:pPr algn="ctr"/>
+            <a:endParaRPr/>
           </a:p>
         </p:txBody>
       </p:sp>
@@ -5330,6 +5819,7 @@
           <a:lstStyle/>
           <a:p>
             <a:pPr algn="ctr"/>
+            <a:endParaRPr/>
           </a:p>
         </p:txBody>
       </p:sp>
@@ -5512,7 +6002,7 @@
 </file>
 
 <file path=ppt/slides/slide4.xml><?xml version="1.0" encoding="utf-8"?>
-<p:sld xmlns:a="http://schemas.openxmlformats.org/drawingml/2006/main" xmlns:p="http://schemas.openxmlformats.org/presentationml/2006/main" xmlns:r="http://schemas.openxmlformats.org/officeDocument/2006/relationships">
+<p:sld xmlns:a="http://schemas.openxmlformats.org/drawingml/2006/main" xmlns:r="http://schemas.openxmlformats.org/officeDocument/2006/relationships" xmlns:p="http://schemas.openxmlformats.org/presentationml/2006/main">
   <p:cSld>
     <p:spTree>
       <p:nvGrpSpPr>
@@ -5520,7 +6010,14 @@
         <p:cNvGrpSpPr/>
         <p:nvPr/>
       </p:nvGrpSpPr>
-      <p:grpSpPr/>
+      <p:grpSpPr>
+        <a:xfrm>
+          <a:off x="0" y="0"/>
+          <a:ext cx="0" cy="0"/>
+          <a:chOff x="0" y="0"/>
+          <a:chExt cx="0" cy="0"/>
+        </a:xfrm>
+      </p:grpSpPr>
       <p:sp>
         <p:nvSpPr>
           <p:cNvPr id="2" name="Rectangle 1"/>
@@ -5561,6 +6058,7 @@
           <a:lstStyle/>
           <a:p>
             <a:pPr algn="ctr"/>
+            <a:endParaRPr/>
           </a:p>
         </p:txBody>
       </p:sp>
@@ -5672,6 +6170,7 @@
           <a:lstStyle/>
           <a:p>
             <a:pPr algn="ctr"/>
+            <a:endParaRPr/>
           </a:p>
         </p:txBody>
       </p:sp>
@@ -5807,6 +6306,7 @@
           <a:lstStyle/>
           <a:p>
             <a:pPr algn="ctr"/>
+            <a:endParaRPr/>
           </a:p>
         </p:txBody>
       </p:sp>
@@ -6003,14 +6503,7 @@
           <a:lstStyle/>
           <a:p>
             <a:pPr algn="l"/>
-            <a:r>
-              <a:rPr sz="1300" b="0">
-                <a:solidFill>
-                  <a:srgbClr val="212121"/>
-                </a:solidFill>
-              </a:rPr>
-              <a:t/>
-            </a:r>
+            <a:endParaRPr/>
           </a:p>
         </p:txBody>
       </p:sp>
@@ -6088,6 +6581,7 @@
           <a:lstStyle/>
           <a:p>
             <a:pPr algn="ctr"/>
+            <a:endParaRPr/>
           </a:p>
         </p:txBody>
       </p:sp>
@@ -6133,7 +6627,7 @@
         </p:nvSpPr>
         <p:spPr>
           <a:xfrm>
-            <a:off x="6355080" y="5394960"/>
+            <a:off x="6355080" y="5202936"/>
             <a:ext cx="5303520" cy="594360"/>
           </a:xfrm>
           <a:prstGeom prst="rect">
@@ -6149,14 +6643,54 @@
           <a:p>
             <a:pPr algn="l"/>
             <a:r>
-              <a:rPr sz="1200" b="0">
+              <a:rPr sz="1200" b="0" dirty="0" err="1">
                 <a:solidFill>
                   <a:srgbClr val="212121"/>
                 </a:solidFill>
               </a:rPr>
-              <a:t>SEの非線形処理が「アーティファクト誤差」を生成。
-自然界に存在しない音響パターンがASRを混乱させる。
-STOI・PESQはこの誤差を検出できない。</a:t>
+              <a:t>SEの非線形処理が「アーティファクト誤差」を生成</a:t>
+            </a:r>
+            <a:r>
+              <a:rPr sz="1200" b="0" dirty="0">
+                <a:solidFill>
+                  <a:srgbClr val="212121"/>
+                </a:solidFill>
+              </a:rPr>
+              <a:t>。
+</a:t>
+            </a:r>
+            <a:r>
+              <a:rPr sz="1200" b="0" dirty="0" err="1">
+                <a:solidFill>
+                  <a:srgbClr val="212121"/>
+                </a:solidFill>
+              </a:rPr>
+              <a:t>自然界に存在しない音響パターンがASRを混乱させる</a:t>
+            </a:r>
+            <a:r>
+              <a:rPr sz="1200" b="0" dirty="0">
+                <a:solidFill>
+                  <a:srgbClr val="212121"/>
+                </a:solidFill>
+              </a:rPr>
+              <a:t>。
+</a:t>
+            </a:r>
+            <a:r>
+              <a:rPr sz="1200" b="0" dirty="0" err="1">
+                <a:solidFill>
+                  <a:srgbClr val="212121"/>
+                </a:solidFill>
+              </a:rPr>
+              <a:t>STOI・PESQはこの誤差を検出できない</a:t>
+            </a:r>
+            <a:r>
+              <a:rPr sz="1200" b="0" dirty="0">
+                <a:solidFill>
+                  <a:srgbClr val="212121"/>
+                </a:solidFill>
+              </a:rPr>
+              <a:t>。</a:t>
             </a:r>
           </a:p>
         </p:txBody>
@@ -6201,6 +6735,7 @@
           <a:lstStyle/>
           <a:p>
             <a:pPr algn="ctr"/>
+            <a:endParaRPr/>
           </a:p>
         </p:txBody>
       </p:sp>
@@ -6247,7 +6782,7 @@
 </file>
 
 <file path=ppt/slides/slide5.xml><?xml version="1.0" encoding="utf-8"?>
-<p:sld xmlns:a="http://schemas.openxmlformats.org/drawingml/2006/main" xmlns:p="http://schemas.openxmlformats.org/presentationml/2006/main" xmlns:r="http://schemas.openxmlformats.org/officeDocument/2006/relationships">
+<p:sld xmlns:a="http://schemas.openxmlformats.org/drawingml/2006/main" xmlns:r="http://schemas.openxmlformats.org/officeDocument/2006/relationships" xmlns:p="http://schemas.openxmlformats.org/presentationml/2006/main">
   <p:cSld>
     <p:spTree>
       <p:nvGrpSpPr>
@@ -6255,7 +6790,14 @@
         <p:cNvGrpSpPr/>
         <p:nvPr/>
       </p:nvGrpSpPr>
-      <p:grpSpPr/>
+      <p:grpSpPr>
+        <a:xfrm>
+          <a:off x="0" y="0"/>
+          <a:ext cx="0" cy="0"/>
+          <a:chOff x="0" y="0"/>
+          <a:chExt cx="0" cy="0"/>
+        </a:xfrm>
+      </p:grpSpPr>
       <p:sp>
         <p:nvSpPr>
           <p:cNvPr id="2" name="Rectangle 1"/>
@@ -6296,6 +6838,7 @@
           <a:lstStyle/>
           <a:p>
             <a:pPr algn="ctr"/>
+            <a:endParaRPr/>
           </a:p>
         </p:txBody>
       </p:sp>
@@ -6375,7 +6918,7 @@
         </p:nvSpPr>
         <p:spPr>
           <a:xfrm>
-            <a:off x="0" y="6583680"/>
+            <a:off x="0" y="6594831"/>
             <a:ext cx="12188952" cy="274320"/>
           </a:xfrm>
           <a:prstGeom prst="rect">
@@ -6407,6 +6950,7 @@
           <a:lstStyle/>
           <a:p>
             <a:pPr algn="ctr"/>
+            <a:endParaRPr/>
           </a:p>
         </p:txBody>
       </p:sp>
@@ -6453,15 +6997,15 @@
           <p:nvPr/>
         </p:nvPicPr>
         <p:blipFill>
-          <a:blip r:embed="rId2"/>
+          <a:blip r:embed="rId3"/>
           <a:stretch>
             <a:fillRect/>
           </a:stretch>
         </p:blipFill>
         <p:spPr>
           <a:xfrm>
-            <a:off x="274320" y="1325880"/>
-            <a:ext cx="7315200" cy="6013979"/>
+            <a:off x="685800" y="1302149"/>
+            <a:ext cx="6446520" cy="5299819"/>
           </a:xfrm>
           <a:prstGeom prst="rect">
             <a:avLst/>
@@ -6470,14 +7014,623 @@
       </p:pic>
       <p:sp>
         <p:nvSpPr>
-          <p:cNvPr id="8" name="Rectangle 7"/>
+          <p:cNvPr id="8" name="TextBox 7"/>
+          <p:cNvSpPr txBox="1"/>
+          <p:nvPr/>
+        </p:nvSpPr>
+        <p:spPr>
+          <a:xfrm>
+            <a:off x="7818120" y="1371600"/>
+            <a:ext cx="4160520" cy="347472"/>
+          </a:xfrm>
+          <a:prstGeom prst="rect">
+            <a:avLst/>
+          </a:prstGeom>
+          <a:noFill/>
+        </p:spPr>
+        <p:txBody>
+          <a:bodyPr wrap="square">
+            <a:spAutoFit/>
+          </a:bodyPr>
+          <a:lstStyle/>
+          <a:p>
+            <a:pPr algn="l"/>
+            <a:r>
+              <a:rPr sz="1300" b="1">
+                <a:solidFill>
+                  <a:srgbClr val="1A237E"/>
+                </a:solidFill>
+              </a:rPr>
+              <a:t>パネル(B)の差分グラフを読む</a:t>
+            </a:r>
+          </a:p>
+        </p:txBody>
+      </p:sp>
+      <p:sp>
+        <p:nvSpPr>
+          <p:cNvPr id="9" name="TextBox 8"/>
+          <p:cNvSpPr txBox="1"/>
+          <p:nvPr/>
+        </p:nvSpPr>
+        <p:spPr>
+          <a:xfrm>
+            <a:off x="7818120" y="1755648"/>
+            <a:ext cx="4160520" cy="411480"/>
+          </a:xfrm>
+          <a:prstGeom prst="rect">
+            <a:avLst/>
+          </a:prstGeom>
+          <a:noFill/>
+        </p:spPr>
+        <p:txBody>
+          <a:bodyPr wrap="square">
+            <a:spAutoFit/>
+          </a:bodyPr>
+          <a:lstStyle/>
+          <a:p>
+            <a:pPr algn="l"/>
+            <a:r>
+              <a:rPr sz="1200" b="0">
+                <a:solidFill>
+                  <a:srgbClr val="78909C"/>
+                </a:solidFill>
+              </a:rPr>
+              <a:t>赤塗り＝GTCRN がエネルギー追加
+青塗り＝削除</a:t>
+            </a:r>
+          </a:p>
+        </p:txBody>
+      </p:sp>
+      <p:sp>
+        <p:nvSpPr>
+          <p:cNvPr id="10" name="Rectangle 9"/>
           <p:cNvSpPr/>
           <p:nvPr/>
         </p:nvSpPr>
         <p:spPr>
           <a:xfrm>
-            <a:off x="8046720" y="1371600"/>
-            <a:ext cx="3840480" cy="5029200"/>
+            <a:off x="7818120" y="2286000"/>
+            <a:ext cx="4160520" cy="914400"/>
+          </a:xfrm>
+          <a:prstGeom prst="rect">
+            <a:avLst/>
+          </a:prstGeom>
+          <a:solidFill>
+            <a:srgbClr val="F5F5F5"/>
+          </a:solidFill>
+          <a:ln>
+            <a:noFill/>
+          </a:ln>
+        </p:spPr>
+        <p:style>
+          <a:lnRef idx="1">
+            <a:schemeClr val="accent1"/>
+          </a:lnRef>
+          <a:fillRef idx="3">
+            <a:schemeClr val="accent1"/>
+          </a:fillRef>
+          <a:effectRef idx="2">
+            <a:schemeClr val="accent1"/>
+          </a:effectRef>
+          <a:fontRef idx="minor">
+            <a:schemeClr val="lt1"/>
+          </a:fontRef>
+        </p:style>
+        <p:txBody>
+          <a:bodyPr rtlCol="0" anchor="ctr"/>
+          <a:lstStyle/>
+          <a:p>
+            <a:pPr algn="ctr"/>
+            <a:endParaRPr/>
+          </a:p>
+        </p:txBody>
+      </p:sp>
+      <p:sp>
+        <p:nvSpPr>
+          <p:cNvPr id="11" name="TextBox 10"/>
+          <p:cNvSpPr txBox="1"/>
+          <p:nvPr/>
+        </p:nvSpPr>
+        <p:spPr>
+          <a:xfrm>
+            <a:off x="7909560" y="2331720"/>
+            <a:ext cx="1005840" cy="292608"/>
+          </a:xfrm>
+          <a:prstGeom prst="rect">
+            <a:avLst/>
+          </a:prstGeom>
+          <a:noFill/>
+        </p:spPr>
+        <p:txBody>
+          <a:bodyPr wrap="square">
+            <a:spAutoFit/>
+          </a:bodyPr>
+          <a:lstStyle/>
+          <a:p>
+            <a:pPr algn="l"/>
+            <a:r>
+              <a:rPr sz="1100" b="1">
+                <a:solidFill>
+                  <a:srgbClr val="212121"/>
+                </a:solidFill>
+              </a:rPr>
+              <a:t>0–50 Hz</a:t>
+            </a:r>
+          </a:p>
+        </p:txBody>
+      </p:sp>
+      <p:sp>
+        <p:nvSpPr>
+          <p:cNvPr id="12" name="TextBox 11"/>
+          <p:cNvSpPr txBox="1"/>
+          <p:nvPr/>
+        </p:nvSpPr>
+        <p:spPr>
+          <a:xfrm>
+            <a:off x="8915400" y="2331720"/>
+            <a:ext cx="1097280" cy="292608"/>
+          </a:xfrm>
+          <a:prstGeom prst="rect">
+            <a:avLst/>
+          </a:prstGeom>
+          <a:noFill/>
+        </p:spPr>
+        <p:txBody>
+          <a:bodyPr wrap="square">
+            <a:spAutoFit/>
+          </a:bodyPr>
+          <a:lstStyle/>
+          <a:p>
+            <a:pPr algn="l"/>
+            <a:r>
+              <a:rPr sz="1300" b="1">
+                <a:solidFill>
+                  <a:srgbClr val="C62828"/>
+                </a:solidFill>
+              </a:rPr>
+              <a:t>+15 dB</a:t>
+            </a:r>
+          </a:p>
+        </p:txBody>
+      </p:sp>
+      <p:sp>
+        <p:nvSpPr>
+          <p:cNvPr id="13" name="TextBox 12"/>
+          <p:cNvSpPr txBox="1"/>
+          <p:nvPr/>
+        </p:nvSpPr>
+        <p:spPr>
+          <a:xfrm>
+            <a:off x="7909560" y="2633472"/>
+            <a:ext cx="3931920" cy="256032"/>
+          </a:xfrm>
+          <a:prstGeom prst="rect">
+            <a:avLst/>
+          </a:prstGeom>
+          <a:noFill/>
+        </p:spPr>
+        <p:txBody>
+          <a:bodyPr wrap="square">
+            <a:spAutoFit/>
+          </a:bodyPr>
+          <a:lstStyle/>
+          <a:p>
+            <a:pPr algn="l"/>
+            <a:r>
+              <a:rPr sz="1100" b="1">
+                <a:solidFill>
+                  <a:srgbClr val="C62828"/>
+                </a:solidFill>
+              </a:rPr>
+              <a:t>極低域にアーティファクト</a:t>
+            </a:r>
+          </a:p>
+        </p:txBody>
+      </p:sp>
+      <p:sp>
+        <p:nvSpPr>
+          <p:cNvPr id="14" name="TextBox 13"/>
+          <p:cNvSpPr txBox="1"/>
+          <p:nvPr/>
+        </p:nvSpPr>
+        <p:spPr>
+          <a:xfrm>
+            <a:off x="7909560" y="2889504"/>
+            <a:ext cx="3931920" cy="256032"/>
+          </a:xfrm>
+          <a:prstGeom prst="rect">
+            <a:avLst/>
+          </a:prstGeom>
+          <a:noFill/>
+        </p:spPr>
+        <p:txBody>
+          <a:bodyPr wrap="square">
+            <a:spAutoFit/>
+          </a:bodyPr>
+          <a:lstStyle/>
+          <a:p>
+            <a:pPr algn="l"/>
+            <a:r>
+              <a:rPr sz="1000" b="0">
+                <a:solidFill>
+                  <a:srgbClr val="78909C"/>
+                </a:solidFill>
+              </a:rPr>
+              <a:t>ASR の音韻識別には無関係な帯域</a:t>
+            </a:r>
+          </a:p>
+        </p:txBody>
+      </p:sp>
+      <p:sp>
+        <p:nvSpPr>
+          <p:cNvPr id="15" name="Rectangle 14"/>
+          <p:cNvSpPr/>
+          <p:nvPr/>
+        </p:nvSpPr>
+        <p:spPr>
+          <a:xfrm>
+            <a:off x="7818120" y="3291840"/>
+            <a:ext cx="4160520" cy="914400"/>
+          </a:xfrm>
+          <a:prstGeom prst="rect">
+            <a:avLst/>
+          </a:prstGeom>
+          <a:solidFill>
+            <a:srgbClr val="F5F5F5"/>
+          </a:solidFill>
+          <a:ln>
+            <a:noFill/>
+          </a:ln>
+        </p:spPr>
+        <p:style>
+          <a:lnRef idx="1">
+            <a:schemeClr val="accent1"/>
+          </a:lnRef>
+          <a:fillRef idx="3">
+            <a:schemeClr val="accent1"/>
+          </a:fillRef>
+          <a:effectRef idx="2">
+            <a:schemeClr val="accent1"/>
+          </a:effectRef>
+          <a:fontRef idx="minor">
+            <a:schemeClr val="lt1"/>
+          </a:fontRef>
+        </p:style>
+        <p:txBody>
+          <a:bodyPr rtlCol="0" anchor="ctr"/>
+          <a:lstStyle/>
+          <a:p>
+            <a:pPr algn="ctr"/>
+            <a:endParaRPr/>
+          </a:p>
+        </p:txBody>
+      </p:sp>
+      <p:sp>
+        <p:nvSpPr>
+          <p:cNvPr id="16" name="TextBox 15"/>
+          <p:cNvSpPr txBox="1"/>
+          <p:nvPr/>
+        </p:nvSpPr>
+        <p:spPr>
+          <a:xfrm>
+            <a:off x="7909560" y="3337560"/>
+            <a:ext cx="1005840" cy="292608"/>
+          </a:xfrm>
+          <a:prstGeom prst="rect">
+            <a:avLst/>
+          </a:prstGeom>
+          <a:noFill/>
+        </p:spPr>
+        <p:txBody>
+          <a:bodyPr wrap="square">
+            <a:spAutoFit/>
+          </a:bodyPr>
+          <a:lstStyle/>
+          <a:p>
+            <a:pPr algn="l"/>
+            <a:r>
+              <a:rPr sz="1100" b="1">
+                <a:solidFill>
+                  <a:srgbClr val="212121"/>
+                </a:solidFill>
+              </a:rPr>
+              <a:t>1–4 kHz</a:t>
+            </a:r>
+          </a:p>
+        </p:txBody>
+      </p:sp>
+      <p:sp>
+        <p:nvSpPr>
+          <p:cNvPr id="17" name="TextBox 16"/>
+          <p:cNvSpPr txBox="1"/>
+          <p:nvPr/>
+        </p:nvSpPr>
+        <p:spPr>
+          <a:xfrm>
+            <a:off x="8915400" y="3337560"/>
+            <a:ext cx="1097280" cy="292608"/>
+          </a:xfrm>
+          <a:prstGeom prst="rect">
+            <a:avLst/>
+          </a:prstGeom>
+          <a:noFill/>
+        </p:spPr>
+        <p:txBody>
+          <a:bodyPr wrap="square">
+            <a:spAutoFit/>
+          </a:bodyPr>
+          <a:lstStyle/>
+          <a:p>
+            <a:pPr algn="l"/>
+            <a:r>
+              <a:rPr sz="1300" b="1">
+                <a:solidFill>
+                  <a:srgbClr val="FF6F00"/>
+                </a:solidFill>
+              </a:rPr>
+              <a:t>−1〜2 dB</a:t>
+            </a:r>
+          </a:p>
+        </p:txBody>
+      </p:sp>
+      <p:sp>
+        <p:nvSpPr>
+          <p:cNvPr id="18" name="TextBox 17"/>
+          <p:cNvSpPr txBox="1"/>
+          <p:nvPr/>
+        </p:nvSpPr>
+        <p:spPr>
+          <a:xfrm>
+            <a:off x="7909560" y="3639312"/>
+            <a:ext cx="3931920" cy="256032"/>
+          </a:xfrm>
+          <a:prstGeom prst="rect">
+            <a:avLst/>
+          </a:prstGeom>
+          <a:noFill/>
+        </p:spPr>
+        <p:txBody>
+          <a:bodyPr wrap="square">
+            <a:spAutoFit/>
+          </a:bodyPr>
+          <a:lstStyle/>
+          <a:p>
+            <a:pPr algn="l"/>
+            <a:r>
+              <a:rPr sz="1100" b="1">
+                <a:solidFill>
+                  <a:srgbClr val="FF6F00"/>
+                </a:solidFill>
+              </a:rPr>
+              <a:t>フォルマント帯域を削減</a:t>
+            </a:r>
+          </a:p>
+        </p:txBody>
+      </p:sp>
+      <p:sp>
+        <p:nvSpPr>
+          <p:cNvPr id="19" name="TextBox 18"/>
+          <p:cNvSpPr txBox="1"/>
+          <p:nvPr/>
+        </p:nvSpPr>
+        <p:spPr>
+          <a:xfrm>
+            <a:off x="7909560" y="3895344"/>
+            <a:ext cx="3931920" cy="256032"/>
+          </a:xfrm>
+          <a:prstGeom prst="rect">
+            <a:avLst/>
+          </a:prstGeom>
+          <a:noFill/>
+        </p:spPr>
+        <p:txBody>
+          <a:bodyPr wrap="square">
+            <a:spAutoFit/>
+          </a:bodyPr>
+          <a:lstStyle/>
+          <a:p>
+            <a:pPr algn="l"/>
+            <a:r>
+              <a:rPr sz="1000" b="0">
+                <a:solidFill>
+                  <a:srgbClr val="78909C"/>
+                </a:solidFill>
+              </a:rPr>
+              <a:t>母音・子音の聞き分けに必要な成分</a:t>
+            </a:r>
+          </a:p>
+        </p:txBody>
+      </p:sp>
+      <p:sp>
+        <p:nvSpPr>
+          <p:cNvPr id="20" name="Rectangle 19"/>
+          <p:cNvSpPr/>
+          <p:nvPr/>
+        </p:nvSpPr>
+        <p:spPr>
+          <a:xfrm>
+            <a:off x="7818120" y="4297680"/>
+            <a:ext cx="4160520" cy="914400"/>
+          </a:xfrm>
+          <a:prstGeom prst="rect">
+            <a:avLst/>
+          </a:prstGeom>
+          <a:solidFill>
+            <a:srgbClr val="F5F5F5"/>
+          </a:solidFill>
+          <a:ln>
+            <a:noFill/>
+          </a:ln>
+        </p:spPr>
+        <p:style>
+          <a:lnRef idx="1">
+            <a:schemeClr val="accent1"/>
+          </a:lnRef>
+          <a:fillRef idx="3">
+            <a:schemeClr val="accent1"/>
+          </a:fillRef>
+          <a:effectRef idx="2">
+            <a:schemeClr val="accent1"/>
+          </a:effectRef>
+          <a:fontRef idx="minor">
+            <a:schemeClr val="lt1"/>
+          </a:fontRef>
+        </p:style>
+        <p:txBody>
+          <a:bodyPr rtlCol="0" anchor="ctr"/>
+          <a:lstStyle/>
+          <a:p>
+            <a:pPr algn="ctr"/>
+            <a:endParaRPr/>
+          </a:p>
+        </p:txBody>
+      </p:sp>
+      <p:sp>
+        <p:nvSpPr>
+          <p:cNvPr id="21" name="TextBox 20"/>
+          <p:cNvSpPr txBox="1"/>
+          <p:nvPr/>
+        </p:nvSpPr>
+        <p:spPr>
+          <a:xfrm>
+            <a:off x="7909560" y="4343400"/>
+            <a:ext cx="1005840" cy="292608"/>
+          </a:xfrm>
+          <a:prstGeom prst="rect">
+            <a:avLst/>
+          </a:prstGeom>
+          <a:noFill/>
+        </p:spPr>
+        <p:txBody>
+          <a:bodyPr wrap="square">
+            <a:spAutoFit/>
+          </a:bodyPr>
+          <a:lstStyle/>
+          <a:p>
+            <a:pPr algn="l"/>
+            <a:r>
+              <a:rPr sz="1100" b="1">
+                <a:solidFill>
+                  <a:srgbClr val="212121"/>
+                </a:solidFill>
+              </a:rPr>
+              <a:t>4–8 kHz</a:t>
+            </a:r>
+          </a:p>
+        </p:txBody>
+      </p:sp>
+      <p:sp>
+        <p:nvSpPr>
+          <p:cNvPr id="22" name="TextBox 21"/>
+          <p:cNvSpPr txBox="1"/>
+          <p:nvPr/>
+        </p:nvSpPr>
+        <p:spPr>
+          <a:xfrm>
+            <a:off x="8915400" y="4343400"/>
+            <a:ext cx="1097280" cy="292608"/>
+          </a:xfrm>
+          <a:prstGeom prst="rect">
+            <a:avLst/>
+          </a:prstGeom>
+          <a:noFill/>
+        </p:spPr>
+        <p:txBody>
+          <a:bodyPr wrap="square">
+            <a:spAutoFit/>
+          </a:bodyPr>
+          <a:lstStyle/>
+          <a:p>
+            <a:pPr algn="l"/>
+            <a:r>
+              <a:rPr sz="1300" b="1">
+                <a:solidFill>
+                  <a:srgbClr val="C62828"/>
+                </a:solidFill>
+              </a:rPr>
+              <a:t>−12.7 dB</a:t>
+            </a:r>
+          </a:p>
+        </p:txBody>
+      </p:sp>
+      <p:sp>
+        <p:nvSpPr>
+          <p:cNvPr id="23" name="TextBox 22"/>
+          <p:cNvSpPr txBox="1"/>
+          <p:nvPr/>
+        </p:nvSpPr>
+        <p:spPr>
+          <a:xfrm>
+            <a:off x="7909560" y="4645152"/>
+            <a:ext cx="3931920" cy="256032"/>
+          </a:xfrm>
+          <a:prstGeom prst="rect">
+            <a:avLst/>
+          </a:prstGeom>
+          <a:noFill/>
+        </p:spPr>
+        <p:txBody>
+          <a:bodyPr wrap="square">
+            <a:spAutoFit/>
+          </a:bodyPr>
+          <a:lstStyle/>
+          <a:p>
+            <a:pPr algn="l"/>
+            <a:r>
+              <a:rPr sz="1100" b="1">
+                <a:solidFill>
+                  <a:srgbClr val="C62828"/>
+                </a:solidFill>
+              </a:rPr>
+              <a:t>高域を壊滅的に削除</a:t>
+            </a:r>
+          </a:p>
+        </p:txBody>
+      </p:sp>
+      <p:sp>
+        <p:nvSpPr>
+          <p:cNvPr id="24" name="TextBox 23"/>
+          <p:cNvSpPr txBox="1"/>
+          <p:nvPr/>
+        </p:nvSpPr>
+        <p:spPr>
+          <a:xfrm>
+            <a:off x="7909560" y="4901184"/>
+            <a:ext cx="3931920" cy="256032"/>
+          </a:xfrm>
+          <a:prstGeom prst="rect">
+            <a:avLst/>
+          </a:prstGeom>
+          <a:noFill/>
+        </p:spPr>
+        <p:txBody>
+          <a:bodyPr wrap="square">
+            <a:spAutoFit/>
+          </a:bodyPr>
+          <a:lstStyle/>
+          <a:p>
+            <a:pPr algn="l"/>
+            <a:r>
+              <a:rPr sz="1000" b="0">
+                <a:solidFill>
+                  <a:srgbClr val="78909C"/>
+                </a:solidFill>
+              </a:rPr>
+              <a:t>喉マイクで既に欠落→さらに除去</a:t>
+            </a:r>
+          </a:p>
+        </p:txBody>
+      </p:sp>
+      <p:sp>
+        <p:nvSpPr>
+          <p:cNvPr id="25" name="Rectangle 24"/>
+          <p:cNvSpPr/>
+          <p:nvPr/>
+        </p:nvSpPr>
+        <p:spPr>
+          <a:xfrm>
+            <a:off x="7818120" y="5394960"/>
+            <a:ext cx="4160520" cy="1188720"/>
           </a:xfrm>
           <a:prstGeom prst="rect">
             <a:avLst/>
@@ -6508,19 +7661,20 @@
           <a:lstStyle/>
           <a:p>
             <a:pPr algn="ctr"/>
-          </a:p>
-        </p:txBody>
-      </p:sp>
-      <p:sp>
-        <p:nvSpPr>
-          <p:cNvPr id="9" name="TextBox 8"/>
-          <p:cNvSpPr txBox="1"/>
-          <p:nvPr/>
-        </p:nvSpPr>
-        <p:spPr>
-          <a:xfrm>
-            <a:off x="8183879" y="1463040"/>
-            <a:ext cx="3566160" cy="384048"/>
+            <a:endParaRPr/>
+          </a:p>
+        </p:txBody>
+      </p:sp>
+      <p:sp>
+        <p:nvSpPr>
+          <p:cNvPr id="26" name="TextBox 25"/>
+          <p:cNvSpPr txBox="1"/>
+          <p:nvPr/>
+        </p:nvSpPr>
+        <p:spPr>
+          <a:xfrm>
+            <a:off x="7955279" y="5440680"/>
+            <a:ext cx="3840480" cy="292608"/>
           </a:xfrm>
           <a:prstGeom prst="rect">
             <a:avLst/>
@@ -6535,69 +7689,26 @@
           <a:p>
             <a:pPr algn="l"/>
             <a:r>
-              <a:rPr sz="1500" b="1">
+              <a:rPr sz="1200" b="1">
                 <a:solidFill>
                   <a:srgbClr val="C62828"/>
                 </a:solidFill>
               </a:rPr>
-              <a:t>GTCRNが喉マイクに何をするか</a:t>
-            </a:r>
-          </a:p>
-        </p:txBody>
-      </p:sp>
-      <p:sp>
-        <p:nvSpPr>
-          <p:cNvPr id="10" name="Rectangle 9"/>
-          <p:cNvSpPr/>
-          <p:nvPr/>
-        </p:nvSpPr>
-        <p:spPr>
-          <a:xfrm>
-            <a:off x="8183879" y="1965960"/>
-            <a:ext cx="3566160" cy="731520"/>
-          </a:xfrm>
-          <a:prstGeom prst="rect">
-            <a:avLst/>
-          </a:prstGeom>
-          <a:solidFill>
-            <a:srgbClr val="FFFFFF"/>
-          </a:solidFill>
-          <a:ln>
-            <a:noFill/>
-          </a:ln>
-        </p:spPr>
-        <p:style>
-          <a:lnRef idx="1">
-            <a:schemeClr val="accent1"/>
-          </a:lnRef>
-          <a:fillRef idx="3">
-            <a:schemeClr val="accent1"/>
-          </a:fillRef>
-          <a:effectRef idx="2">
-            <a:schemeClr val="accent1"/>
-          </a:effectRef>
-          <a:fontRef idx="minor">
-            <a:schemeClr val="lt1"/>
-          </a:fontRef>
-        </p:style>
-        <p:txBody>
-          <a:bodyPr rtlCol="0" anchor="ctr"/>
-          <a:lstStyle/>
-          <a:p>
-            <a:pPr algn="ctr"/>
-          </a:p>
-        </p:txBody>
-      </p:sp>
-      <p:sp>
-        <p:nvSpPr>
-          <p:cNvPr id="11" name="TextBox 10"/>
-          <p:cNvSpPr txBox="1"/>
-          <p:nvPr/>
-        </p:nvSpPr>
-        <p:spPr>
-          <a:xfrm>
-            <a:off x="8275320" y="2011680"/>
-            <a:ext cx="1097280" cy="320040"/>
+              <a:t>本質的な問題</a:t>
+            </a:r>
+          </a:p>
+        </p:txBody>
+      </p:sp>
+      <p:sp>
+        <p:nvSpPr>
+          <p:cNvPr id="27" name="TextBox 26"/>
+          <p:cNvSpPr txBox="1"/>
+          <p:nvPr/>
+        </p:nvSpPr>
+        <p:spPr>
+          <a:xfrm>
+            <a:off x="7955279" y="5760720"/>
+            <a:ext cx="3840480" cy="777240"/>
           </a:xfrm>
           <a:prstGeom prst="rect">
             <a:avLst/>
@@ -6612,451 +7723,15 @@
           <a:p>
             <a:pPr algn="l"/>
             <a:r>
-              <a:rPr sz="1200" b="1">
-                <a:solidFill>
-                  <a:srgbClr val="212121"/>
-                </a:solidFill>
-              </a:rPr>
-              <a:t>0–0.5 kHz</a:t>
-            </a:r>
-          </a:p>
-        </p:txBody>
-      </p:sp>
-      <p:sp>
-        <p:nvSpPr>
-          <p:cNvPr id="12" name="TextBox 11"/>
-          <p:cNvSpPr txBox="1"/>
-          <p:nvPr/>
-        </p:nvSpPr>
-        <p:spPr>
-          <a:xfrm>
-            <a:off x="9372600" y="2011680"/>
-            <a:ext cx="1280160" cy="320040"/>
-          </a:xfrm>
-          <a:prstGeom prst="rect">
-            <a:avLst/>
-          </a:prstGeom>
-          <a:noFill/>
-        </p:spPr>
-        <p:txBody>
-          <a:bodyPr wrap="square">
-            <a:spAutoFit/>
-          </a:bodyPr>
-          <a:lstStyle/>
-          <a:p>
-            <a:pPr algn="l"/>
-            <a:r>
-              <a:rPr sz="1300" b="1">
-                <a:solidFill>
-                  <a:srgbClr val="C62828"/>
-                </a:solidFill>
-              </a:rPr>
-              <a:t>+1.6 dB</a:t>
-            </a:r>
-          </a:p>
-        </p:txBody>
-      </p:sp>
-      <p:sp>
-        <p:nvSpPr>
-          <p:cNvPr id="13" name="TextBox 12"/>
-          <p:cNvSpPr txBox="1"/>
-          <p:nvPr/>
-        </p:nvSpPr>
-        <p:spPr>
-          <a:xfrm>
-            <a:off x="8275320" y="2377440"/>
-            <a:ext cx="3383280" cy="274320"/>
-          </a:xfrm>
-          <a:prstGeom prst="rect">
-            <a:avLst/>
-          </a:prstGeom>
-          <a:noFill/>
-        </p:spPr>
-        <p:txBody>
-          <a:bodyPr wrap="square">
-            <a:spAutoFit/>
-          </a:bodyPr>
-          <a:lstStyle/>
-          <a:p>
-            <a:pPr algn="l"/>
-            <a:r>
               <a:rPr sz="1100" b="0">
                 <a:solidFill>
-                  <a:srgbClr val="78909C"/>
-                </a:solidFill>
-              </a:rPr>
-              <a:t>低域にノイズ追加</a:t>
-            </a:r>
-          </a:p>
-        </p:txBody>
-      </p:sp>
-      <p:sp>
-        <p:nvSpPr>
-          <p:cNvPr id="14" name="Rectangle 13"/>
-          <p:cNvSpPr/>
-          <p:nvPr/>
-        </p:nvSpPr>
-        <p:spPr>
-          <a:xfrm>
-            <a:off x="8183879" y="2788920"/>
-            <a:ext cx="3566160" cy="731520"/>
-          </a:xfrm>
-          <a:prstGeom prst="rect">
-            <a:avLst/>
-          </a:prstGeom>
-          <a:solidFill>
-            <a:srgbClr val="FFFFFF"/>
-          </a:solidFill>
-          <a:ln>
-            <a:noFill/>
-          </a:ln>
-        </p:spPr>
-        <p:style>
-          <a:lnRef idx="1">
-            <a:schemeClr val="accent1"/>
-          </a:lnRef>
-          <a:fillRef idx="3">
-            <a:schemeClr val="accent1"/>
-          </a:fillRef>
-          <a:effectRef idx="2">
-            <a:schemeClr val="accent1"/>
-          </a:effectRef>
-          <a:fontRef idx="minor">
-            <a:schemeClr val="lt1"/>
-          </a:fontRef>
-        </p:style>
-        <p:txBody>
-          <a:bodyPr rtlCol="0" anchor="ctr"/>
-          <a:lstStyle/>
-          <a:p>
-            <a:pPr algn="ctr"/>
-          </a:p>
-        </p:txBody>
-      </p:sp>
-      <p:sp>
-        <p:nvSpPr>
-          <p:cNvPr id="15" name="TextBox 14"/>
-          <p:cNvSpPr txBox="1"/>
-          <p:nvPr/>
-        </p:nvSpPr>
-        <p:spPr>
-          <a:xfrm>
-            <a:off x="8275320" y="2834640"/>
-            <a:ext cx="1097280" cy="320040"/>
-          </a:xfrm>
-          <a:prstGeom prst="rect">
-            <a:avLst/>
-          </a:prstGeom>
-          <a:noFill/>
-        </p:spPr>
-        <p:txBody>
-          <a:bodyPr wrap="square">
-            <a:spAutoFit/>
-          </a:bodyPr>
-          <a:lstStyle/>
-          <a:p>
-            <a:pPr algn="l"/>
-            <a:r>
-              <a:rPr sz="1200" b="1">
-                <a:solidFill>
-                  <a:srgbClr val="212121"/>
-                </a:solidFill>
-              </a:rPr>
-              <a:t>1–4 kHz</a:t>
-            </a:r>
-          </a:p>
-        </p:txBody>
-      </p:sp>
-      <p:sp>
-        <p:nvSpPr>
-          <p:cNvPr id="16" name="TextBox 15"/>
-          <p:cNvSpPr txBox="1"/>
-          <p:nvPr/>
-        </p:nvSpPr>
-        <p:spPr>
-          <a:xfrm>
-            <a:off x="9372600" y="2834640"/>
-            <a:ext cx="1280160" cy="320040"/>
-          </a:xfrm>
-          <a:prstGeom prst="rect">
-            <a:avLst/>
-          </a:prstGeom>
-          <a:noFill/>
-        </p:spPr>
-        <p:txBody>
-          <a:bodyPr wrap="square">
-            <a:spAutoFit/>
-          </a:bodyPr>
-          <a:lstStyle/>
-          <a:p>
-            <a:pPr algn="l"/>
-            <a:r>
-              <a:rPr sz="1300" b="1">
-                <a:solidFill>
-                  <a:srgbClr val="C62828"/>
-                </a:solidFill>
-              </a:rPr>
-              <a:t>−1〜2 dB</a:t>
-            </a:r>
-          </a:p>
-        </p:txBody>
-      </p:sp>
-      <p:sp>
-        <p:nvSpPr>
-          <p:cNvPr id="17" name="TextBox 16"/>
-          <p:cNvSpPr txBox="1"/>
-          <p:nvPr/>
-        </p:nvSpPr>
-        <p:spPr>
-          <a:xfrm>
-            <a:off x="8275320" y="3200400"/>
-            <a:ext cx="3383280" cy="274320"/>
-          </a:xfrm>
-          <a:prstGeom prst="rect">
-            <a:avLst/>
-          </a:prstGeom>
-          <a:noFill/>
-        </p:spPr>
-        <p:txBody>
-          <a:bodyPr wrap="square">
-            <a:spAutoFit/>
-          </a:bodyPr>
-          <a:lstStyle/>
-          <a:p>
-            <a:pPr algn="l"/>
-            <a:r>
-              <a:rPr sz="1100" b="0">
-                <a:solidFill>
-                  <a:srgbClr val="78909C"/>
-                </a:solidFill>
-              </a:rPr>
-              <a:t>フォルマント帯域を削除</a:t>
-            </a:r>
-          </a:p>
-        </p:txBody>
-      </p:sp>
-      <p:sp>
-        <p:nvSpPr>
-          <p:cNvPr id="18" name="Rectangle 17"/>
-          <p:cNvSpPr/>
-          <p:nvPr/>
-        </p:nvSpPr>
-        <p:spPr>
-          <a:xfrm>
-            <a:off x="8183879" y="3611880"/>
-            <a:ext cx="3566160" cy="731520"/>
-          </a:xfrm>
-          <a:prstGeom prst="rect">
-            <a:avLst/>
-          </a:prstGeom>
-          <a:solidFill>
-            <a:srgbClr val="FFFFFF"/>
-          </a:solidFill>
-          <a:ln>
-            <a:noFill/>
-          </a:ln>
-        </p:spPr>
-        <p:style>
-          <a:lnRef idx="1">
-            <a:schemeClr val="accent1"/>
-          </a:lnRef>
-          <a:fillRef idx="3">
-            <a:schemeClr val="accent1"/>
-          </a:fillRef>
-          <a:effectRef idx="2">
-            <a:schemeClr val="accent1"/>
-          </a:effectRef>
-          <a:fontRef idx="minor">
-            <a:schemeClr val="lt1"/>
-          </a:fontRef>
-        </p:style>
-        <p:txBody>
-          <a:bodyPr rtlCol="0" anchor="ctr"/>
-          <a:lstStyle/>
-          <a:p>
-            <a:pPr algn="ctr"/>
-          </a:p>
-        </p:txBody>
-      </p:sp>
-      <p:sp>
-        <p:nvSpPr>
-          <p:cNvPr id="19" name="TextBox 18"/>
-          <p:cNvSpPr txBox="1"/>
-          <p:nvPr/>
-        </p:nvSpPr>
-        <p:spPr>
-          <a:xfrm>
-            <a:off x="8275320" y="3657600"/>
-            <a:ext cx="1097280" cy="320040"/>
-          </a:xfrm>
-          <a:prstGeom prst="rect">
-            <a:avLst/>
-          </a:prstGeom>
-          <a:noFill/>
-        </p:spPr>
-        <p:txBody>
-          <a:bodyPr wrap="square">
-            <a:spAutoFit/>
-          </a:bodyPr>
-          <a:lstStyle/>
-          <a:p>
-            <a:pPr algn="l"/>
-            <a:r>
-              <a:rPr sz="1200" b="1">
-                <a:solidFill>
-                  <a:srgbClr val="212121"/>
-                </a:solidFill>
-              </a:rPr>
-              <a:t>4–8 kHz</a:t>
-            </a:r>
-          </a:p>
-        </p:txBody>
-      </p:sp>
-      <p:sp>
-        <p:nvSpPr>
-          <p:cNvPr id="20" name="TextBox 19"/>
-          <p:cNvSpPr txBox="1"/>
-          <p:nvPr/>
-        </p:nvSpPr>
-        <p:spPr>
-          <a:xfrm>
-            <a:off x="9372600" y="3657600"/>
-            <a:ext cx="1280160" cy="320040"/>
-          </a:xfrm>
-          <a:prstGeom prst="rect">
-            <a:avLst/>
-          </a:prstGeom>
-          <a:noFill/>
-        </p:spPr>
-        <p:txBody>
-          <a:bodyPr wrap="square">
-            <a:spAutoFit/>
-          </a:bodyPr>
-          <a:lstStyle/>
-          <a:p>
-            <a:pPr algn="l"/>
-            <a:r>
-              <a:rPr sz="1300" b="1">
-                <a:solidFill>
-                  <a:srgbClr val="C62828"/>
-                </a:solidFill>
-              </a:rPr>
-              <a:t>−12.7 dB</a:t>
-            </a:r>
-          </a:p>
-        </p:txBody>
-      </p:sp>
-      <p:sp>
-        <p:nvSpPr>
-          <p:cNvPr id="21" name="TextBox 20"/>
-          <p:cNvSpPr txBox="1"/>
-          <p:nvPr/>
-        </p:nvSpPr>
-        <p:spPr>
-          <a:xfrm>
-            <a:off x="8275320" y="4023360"/>
-            <a:ext cx="3383280" cy="274320"/>
-          </a:xfrm>
-          <a:prstGeom prst="rect">
-            <a:avLst/>
-          </a:prstGeom>
-          <a:noFill/>
-        </p:spPr>
-        <p:txBody>
-          <a:bodyPr wrap="square">
-            <a:spAutoFit/>
-          </a:bodyPr>
-          <a:lstStyle/>
-          <a:p>
-            <a:pPr algn="l"/>
-            <a:r>
-              <a:rPr sz="1100" b="0">
-                <a:solidFill>
-                  <a:srgbClr val="78909C"/>
-                </a:solidFill>
-              </a:rPr>
-              <a:t>高域を壊滅的に削除</a:t>
-            </a:r>
-          </a:p>
-        </p:txBody>
-      </p:sp>
-      <p:sp>
-        <p:nvSpPr>
-          <p:cNvPr id="22" name="Rectangle 21"/>
-          <p:cNvSpPr/>
-          <p:nvPr/>
-        </p:nvSpPr>
-        <p:spPr>
-          <a:xfrm>
-            <a:off x="8046720" y="4846320"/>
-            <a:ext cx="3840480" cy="1371600"/>
-          </a:xfrm>
-          <a:prstGeom prst="rect">
-            <a:avLst/>
-          </a:prstGeom>
-          <a:solidFill>
-            <a:srgbClr val="FFF9C4"/>
-          </a:solidFill>
-          <a:ln>
-            <a:noFill/>
-          </a:ln>
-        </p:spPr>
-        <p:style>
-          <a:lnRef idx="1">
-            <a:schemeClr val="accent1"/>
-          </a:lnRef>
-          <a:fillRef idx="3">
-            <a:schemeClr val="accent1"/>
-          </a:fillRef>
-          <a:effectRef idx="2">
-            <a:schemeClr val="accent1"/>
-          </a:effectRef>
-          <a:fontRef idx="minor">
-            <a:schemeClr val="lt1"/>
-          </a:fontRef>
-        </p:style>
-        <p:txBody>
-          <a:bodyPr rtlCol="0" anchor="ctr"/>
-          <a:lstStyle/>
-          <a:p>
-            <a:pPr algn="ctr"/>
-          </a:p>
-        </p:txBody>
-      </p:sp>
-      <p:sp>
-        <p:nvSpPr>
-          <p:cNvPr id="23" name="TextBox 22"/>
-          <p:cNvSpPr txBox="1"/>
-          <p:nvPr/>
-        </p:nvSpPr>
-        <p:spPr>
-          <a:xfrm>
-            <a:off x="8183879" y="4892040"/>
-            <a:ext cx="3566160" cy="1234440"/>
-          </a:xfrm>
-          <a:prstGeom prst="rect">
-            <a:avLst/>
-          </a:prstGeom>
-          <a:noFill/>
-        </p:spPr>
-        <p:txBody>
-          <a:bodyPr wrap="square">
-            <a:spAutoFit/>
-          </a:bodyPr>
-          <a:lstStyle/>
-          <a:p>
-            <a:pPr algn="l"/>
-            <a:r>
-              <a:rPr sz="1300" b="0">
-                <a:solidFill>
                   <a:srgbClr val="1A237E"/>
                 </a:solidFill>
               </a:rPr>
-              <a:t>喉マイクは元々
-高域が欠落している
-↓
-GTCRNがさらに除去
-= 逆方向の操作</a:t>
+              <a:t>喉マイクは元々 2 kHz 以上が欠落。
+GTCRN はそれを「ノイズ」と誤判定し
+さらに削除 → 逆方向の動作。
+STOI・PESQ はこの歪みを検出できない。</a:t>
             </a:r>
           </a:p>
         </p:txBody>
@@ -7070,7 +7745,7 @@
 </file>
 
 <file path=ppt/slides/slide6.xml><?xml version="1.0" encoding="utf-8"?>
-<p:sld xmlns:a="http://schemas.openxmlformats.org/drawingml/2006/main" xmlns:p="http://schemas.openxmlformats.org/presentationml/2006/main" xmlns:r="http://schemas.openxmlformats.org/officeDocument/2006/relationships">
+<p:sld xmlns:a="http://schemas.openxmlformats.org/drawingml/2006/main" xmlns:r="http://schemas.openxmlformats.org/officeDocument/2006/relationships" xmlns:p="http://schemas.openxmlformats.org/presentationml/2006/main">
   <p:cSld>
     <p:spTree>
       <p:nvGrpSpPr>
@@ -7078,7 +7753,14 @@
         <p:cNvGrpSpPr/>
         <p:nvPr/>
       </p:nvGrpSpPr>
-      <p:grpSpPr/>
+      <p:grpSpPr>
+        <a:xfrm>
+          <a:off x="0" y="0"/>
+          <a:ext cx="0" cy="0"/>
+          <a:chOff x="0" y="0"/>
+          <a:chExt cx="0" cy="0"/>
+        </a:xfrm>
+      </p:grpSpPr>
       <p:sp>
         <p:nvSpPr>
           <p:cNvPr id="2" name="Rectangle 1"/>
@@ -7119,6 +7801,7 @@
           <a:lstStyle/>
           <a:p>
             <a:pPr algn="ctr"/>
+            <a:endParaRPr/>
           </a:p>
         </p:txBody>
       </p:sp>
@@ -7230,6 +7913,7 @@
           <a:lstStyle/>
           <a:p>
             <a:pPr algn="ctr"/>
+            <a:endParaRPr/>
           </a:p>
         </p:txBody>
       </p:sp>
@@ -7307,6 +7991,7 @@
           <a:lstStyle/>
           <a:p>
             <a:pPr algn="ctr"/>
+            <a:endParaRPr/>
           </a:p>
         </p:txBody>
       </p:sp>
@@ -7395,8 +8080,8 @@
         </p:blipFill>
         <p:spPr>
           <a:xfrm>
-            <a:off x="457200" y="2468880"/>
-            <a:ext cx="5029200" cy="2664372"/>
+            <a:off x="457200" y="2423160"/>
+            <a:ext cx="4846320" cy="1963595"/>
           </a:xfrm>
           <a:prstGeom prst="rect">
             <a:avLst/>
@@ -7443,6 +8128,7 @@
           <a:lstStyle/>
           <a:p>
             <a:pPr algn="ctr"/>
+            <a:endParaRPr/>
           </a:p>
         </p:txBody>
       </p:sp>
@@ -7578,6 +8264,7 @@
           <a:lstStyle/>
           <a:p>
             <a:pPr algn="ctr"/>
+            <a:endParaRPr/>
           </a:p>
         </p:txBody>
       </p:sp>
@@ -7815,6 +8502,1703 @@
                 </a:solidFill>
               </a:rPr>
               <a:t>Whisper FTでCER 72.4%改善（0.544→0.150，10話者）—音声処理よりASR適応が根本解決</a:t>
+            </a:r>
+          </a:p>
+        </p:txBody>
+      </p:sp>
+    </p:spTree>
+  </p:cSld>
+  <p:clrMapOvr>
+    <a:masterClrMapping/>
+  </p:clrMapOvr>
+</p:sld>
+</file>
+
+<file path=ppt/slides/slide7.xml><?xml version="1.0" encoding="utf-8"?>
+<p:sld xmlns:a="http://schemas.openxmlformats.org/drawingml/2006/main" xmlns:r="http://schemas.openxmlformats.org/officeDocument/2006/relationships" xmlns:p="http://schemas.openxmlformats.org/presentationml/2006/main">
+  <p:cSld>
+    <p:spTree>
+      <p:nvGrpSpPr>
+        <p:cNvPr id="1" name=""/>
+        <p:cNvGrpSpPr/>
+        <p:nvPr/>
+      </p:nvGrpSpPr>
+      <p:grpSpPr>
+        <a:xfrm>
+          <a:off x="0" y="0"/>
+          <a:ext cx="0" cy="0"/>
+          <a:chOff x="0" y="0"/>
+          <a:chExt cx="0" cy="0"/>
+        </a:xfrm>
+      </p:grpSpPr>
+      <p:sp>
+        <p:nvSpPr>
+          <p:cNvPr id="2" name="Rectangle 1"/>
+          <p:cNvSpPr/>
+          <p:nvPr/>
+        </p:nvSpPr>
+        <p:spPr>
+          <a:xfrm>
+            <a:off x="0" y="0"/>
+            <a:ext cx="12188952" cy="1188720"/>
+          </a:xfrm>
+          <a:prstGeom prst="rect">
+            <a:avLst/>
+          </a:prstGeom>
+          <a:solidFill>
+            <a:srgbClr val="1A237E"/>
+          </a:solidFill>
+          <a:ln>
+            <a:noFill/>
+          </a:ln>
+        </p:spPr>
+        <p:style>
+          <a:lnRef idx="1">
+            <a:schemeClr val="accent1"/>
+          </a:lnRef>
+          <a:fillRef idx="3">
+            <a:schemeClr val="accent1"/>
+          </a:fillRef>
+          <a:effectRef idx="2">
+            <a:schemeClr val="accent1"/>
+          </a:effectRef>
+          <a:fontRef idx="minor">
+            <a:schemeClr val="lt1"/>
+          </a:fontRef>
+        </p:style>
+        <p:txBody>
+          <a:bodyPr rtlCol="0" anchor="ctr"/>
+          <a:lstStyle/>
+          <a:p>
+            <a:pPr algn="ctr"/>
+            <a:endParaRPr/>
+          </a:p>
+        </p:txBody>
+      </p:sp>
+      <p:sp>
+        <p:nvSpPr>
+          <p:cNvPr id="3" name="TextBox 2"/>
+          <p:cNvSpPr txBox="1"/>
+          <p:nvPr/>
+        </p:nvSpPr>
+        <p:spPr>
+          <a:xfrm>
+            <a:off x="411480" y="137160"/>
+            <a:ext cx="10789920" cy="777240"/>
+          </a:xfrm>
+          <a:prstGeom prst="rect">
+            <a:avLst/>
+          </a:prstGeom>
+          <a:noFill/>
+        </p:spPr>
+        <p:txBody>
+          <a:bodyPr wrap="square">
+            <a:spAutoFit/>
+          </a:bodyPr>
+          <a:lstStyle/>
+          <a:p>
+            <a:pPr algn="l"/>
+            <a:r>
+              <a:rPr sz="2600" b="1">
+                <a:solidFill>
+                  <a:srgbClr val="FFFFFF"/>
+                </a:solidFill>
+              </a:rPr>
+              <a:t>本研究の新規性・限界・今後の展望</a:t>
+            </a:r>
+          </a:p>
+        </p:txBody>
+      </p:sp>
+      <p:sp>
+        <p:nvSpPr>
+          <p:cNvPr id="4" name="TextBox 3"/>
+          <p:cNvSpPr txBox="1"/>
+          <p:nvPr/>
+        </p:nvSpPr>
+        <p:spPr>
+          <a:xfrm>
+            <a:off x="11247120" y="411480"/>
+            <a:ext cx="822960" cy="365760"/>
+          </a:xfrm>
+          <a:prstGeom prst="rect">
+            <a:avLst/>
+          </a:prstGeom>
+          <a:noFill/>
+        </p:spPr>
+        <p:txBody>
+          <a:bodyPr wrap="square">
+            <a:spAutoFit/>
+          </a:bodyPr>
+          <a:lstStyle/>
+          <a:p>
+            <a:pPr algn="r"/>
+            <a:r>
+              <a:rPr sz="1300" b="0">
+                <a:solidFill>
+                  <a:srgbClr val="78909C"/>
+                </a:solidFill>
+              </a:rPr>
+              <a:t>7 / 5</a:t>
+            </a:r>
+          </a:p>
+        </p:txBody>
+      </p:sp>
+      <p:sp>
+        <p:nvSpPr>
+          <p:cNvPr id="5" name="Rectangle 4"/>
+          <p:cNvSpPr/>
+          <p:nvPr/>
+        </p:nvSpPr>
+        <p:spPr>
+          <a:xfrm>
+            <a:off x="0" y="6583680"/>
+            <a:ext cx="12188952" cy="274320"/>
+          </a:xfrm>
+          <a:prstGeom prst="rect">
+            <a:avLst/>
+          </a:prstGeom>
+          <a:solidFill>
+            <a:srgbClr val="E8EAF6"/>
+          </a:solidFill>
+          <a:ln>
+            <a:noFill/>
+          </a:ln>
+        </p:spPr>
+        <p:style>
+          <a:lnRef idx="1">
+            <a:schemeClr val="accent1"/>
+          </a:lnRef>
+          <a:fillRef idx="3">
+            <a:schemeClr val="accent1"/>
+          </a:fillRef>
+          <a:effectRef idx="2">
+            <a:schemeClr val="accent1"/>
+          </a:effectRef>
+          <a:fontRef idx="minor">
+            <a:schemeClr val="lt1"/>
+          </a:fontRef>
+        </p:style>
+        <p:txBody>
+          <a:bodyPr rtlCol="0" anchor="ctr"/>
+          <a:lstStyle/>
+          <a:p>
+            <a:pPr algn="ctr"/>
+            <a:endParaRPr/>
+          </a:p>
+        </p:txBody>
+      </p:sp>
+      <p:sp>
+        <p:nvSpPr>
+          <p:cNvPr id="6" name="TextBox 5"/>
+          <p:cNvSpPr txBox="1"/>
+          <p:nvPr/>
+        </p:nvSpPr>
+        <p:spPr>
+          <a:xfrm>
+            <a:off x="274320" y="6601968"/>
+            <a:ext cx="11612880" cy="228600"/>
+          </a:xfrm>
+          <a:prstGeom prst="rect">
+            <a:avLst/>
+          </a:prstGeom>
+          <a:noFill/>
+        </p:spPr>
+        <p:txBody>
+          <a:bodyPr wrap="square">
+            <a:spAutoFit/>
+          </a:bodyPr>
+          <a:lstStyle/>
+          <a:p>
+            <a:pPr algn="l"/>
+            <a:r>
+              <a:rPr sz="900" b="0">
+                <a:solidFill>
+                  <a:srgbClr val="78909C"/>
+                </a:solidFill>
+              </a:rPr>
+              <a:t>骨伝導マイク音声認識研究 — 概要</a:t>
+            </a:r>
+          </a:p>
+        </p:txBody>
+      </p:sp>
+      <p:sp>
+        <p:nvSpPr>
+          <p:cNvPr id="7" name="Rectangle 6"/>
+          <p:cNvSpPr/>
+          <p:nvPr/>
+        </p:nvSpPr>
+        <p:spPr>
+          <a:xfrm>
+            <a:off x="274320" y="1325880"/>
+            <a:ext cx="3749039" cy="5212080"/>
+          </a:xfrm>
+          <a:prstGeom prst="rect">
+            <a:avLst/>
+          </a:prstGeom>
+          <a:solidFill>
+            <a:srgbClr val="E8F5E9"/>
+          </a:solidFill>
+          <a:ln>
+            <a:noFill/>
+          </a:ln>
+        </p:spPr>
+        <p:style>
+          <a:lnRef idx="1">
+            <a:schemeClr val="accent1"/>
+          </a:lnRef>
+          <a:fillRef idx="3">
+            <a:schemeClr val="accent1"/>
+          </a:fillRef>
+          <a:effectRef idx="2">
+            <a:schemeClr val="accent1"/>
+          </a:effectRef>
+          <a:fontRef idx="minor">
+            <a:schemeClr val="lt1"/>
+          </a:fontRef>
+        </p:style>
+        <p:txBody>
+          <a:bodyPr rtlCol="0" anchor="ctr"/>
+          <a:lstStyle/>
+          <a:p>
+            <a:pPr algn="ctr"/>
+            <a:endParaRPr/>
+          </a:p>
+        </p:txBody>
+      </p:sp>
+      <p:sp>
+        <p:nvSpPr>
+          <p:cNvPr id="8" name="TextBox 7"/>
+          <p:cNvSpPr txBox="1"/>
+          <p:nvPr/>
+        </p:nvSpPr>
+        <p:spPr>
+          <a:xfrm>
+            <a:off x="411480" y="1417320"/>
+            <a:ext cx="3474720" cy="347472"/>
+          </a:xfrm>
+          <a:prstGeom prst="rect">
+            <a:avLst/>
+          </a:prstGeom>
+          <a:noFill/>
+        </p:spPr>
+        <p:txBody>
+          <a:bodyPr wrap="square">
+            <a:spAutoFit/>
+          </a:bodyPr>
+          <a:lstStyle/>
+          <a:p>
+            <a:pPr algn="l"/>
+            <a:r>
+              <a:rPr sz="1400" b="1">
+                <a:solidFill>
+                  <a:srgbClr val="2E7D32"/>
+                </a:solidFill>
+              </a:rPr>
+              <a:t>本研究の新規性</a:t>
+            </a:r>
+          </a:p>
+        </p:txBody>
+      </p:sp>
+      <p:sp>
+        <p:nvSpPr>
+          <p:cNvPr id="9" name="Rectangle 8"/>
+          <p:cNvSpPr/>
+          <p:nvPr/>
+        </p:nvSpPr>
+        <p:spPr>
+          <a:xfrm>
+            <a:off x="411480" y="1874519"/>
+            <a:ext cx="3474720" cy="1371600"/>
+          </a:xfrm>
+          <a:prstGeom prst="rect">
+            <a:avLst/>
+          </a:prstGeom>
+          <a:solidFill>
+            <a:srgbClr val="C8E6C9"/>
+          </a:solidFill>
+          <a:ln>
+            <a:noFill/>
+          </a:ln>
+        </p:spPr>
+        <p:style>
+          <a:lnRef idx="1">
+            <a:schemeClr val="accent1"/>
+          </a:lnRef>
+          <a:fillRef idx="3">
+            <a:schemeClr val="accent1"/>
+          </a:fillRef>
+          <a:effectRef idx="2">
+            <a:schemeClr val="accent1"/>
+          </a:effectRef>
+          <a:fontRef idx="minor">
+            <a:schemeClr val="lt1"/>
+          </a:fontRef>
+        </p:style>
+        <p:txBody>
+          <a:bodyPr rtlCol="0" anchor="ctr"/>
+          <a:lstStyle/>
+          <a:p>
+            <a:pPr algn="ctr"/>
+            <a:endParaRPr/>
+          </a:p>
+        </p:txBody>
+      </p:sp>
+      <p:sp>
+        <p:nvSpPr>
+          <p:cNvPr id="10" name="TextBox 9"/>
+          <p:cNvSpPr txBox="1"/>
+          <p:nvPr/>
+        </p:nvSpPr>
+        <p:spPr>
+          <a:xfrm>
+            <a:off x="502920" y="1920239"/>
+            <a:ext cx="3291840" cy="502920"/>
+          </a:xfrm>
+          <a:prstGeom prst="rect">
+            <a:avLst/>
+          </a:prstGeom>
+          <a:noFill/>
+        </p:spPr>
+        <p:txBody>
+          <a:bodyPr wrap="square">
+            <a:spAutoFit/>
+          </a:bodyPr>
+          <a:lstStyle/>
+          <a:p>
+            <a:pPr algn="l"/>
+            <a:r>
+              <a:rPr sz="1200" b="1">
+                <a:solidFill>
+                  <a:srgbClr val="2E7D32"/>
+                </a:solidFill>
+              </a:rPr>
+              <a:t>● 喉マイク特有のドメインで
+SE逆効果を系統的に実証</a:t>
+            </a:r>
+          </a:p>
+        </p:txBody>
+      </p:sp>
+      <p:sp>
+        <p:nvSpPr>
+          <p:cNvPr id="11" name="TextBox 10"/>
+          <p:cNvSpPr txBox="1"/>
+          <p:nvPr/>
+        </p:nvSpPr>
+        <p:spPr>
+          <a:xfrm>
+            <a:off x="502920" y="2441447"/>
+            <a:ext cx="3291840" cy="731520"/>
+          </a:xfrm>
+          <a:prstGeom prst="rect">
+            <a:avLst/>
+          </a:prstGeom>
+          <a:noFill/>
+        </p:spPr>
+        <p:txBody>
+          <a:bodyPr wrap="square">
+            <a:spAutoFit/>
+          </a:bodyPr>
+          <a:lstStyle/>
+          <a:p>
+            <a:pPr algn="l"/>
+            <a:r>
+              <a:rPr sz="1100" b="0">
+                <a:solidFill>
+                  <a:srgbClr val="212121"/>
+                </a:solidFill>
+              </a:rPr>
+              <a:t>Ochiai・Mawalim は気導マイク対象。
+高周波が構造的に欠落したドメインでの
+検証は本研究が初。</a:t>
+            </a:r>
+          </a:p>
+        </p:txBody>
+      </p:sp>
+      <p:sp>
+        <p:nvSpPr>
+          <p:cNvPr id="12" name="Rectangle 11"/>
+          <p:cNvSpPr/>
+          <p:nvPr/>
+        </p:nvSpPr>
+        <p:spPr>
+          <a:xfrm>
+            <a:off x="411480" y="3383279"/>
+            <a:ext cx="3474720" cy="1371600"/>
+          </a:xfrm>
+          <a:prstGeom prst="rect">
+            <a:avLst/>
+          </a:prstGeom>
+          <a:solidFill>
+            <a:srgbClr val="C8E6C9"/>
+          </a:solidFill>
+          <a:ln>
+            <a:noFill/>
+          </a:ln>
+        </p:spPr>
+        <p:style>
+          <a:lnRef idx="1">
+            <a:schemeClr val="accent1"/>
+          </a:lnRef>
+          <a:fillRef idx="3">
+            <a:schemeClr val="accent1"/>
+          </a:fillRef>
+          <a:effectRef idx="2">
+            <a:schemeClr val="accent1"/>
+          </a:effectRef>
+          <a:fontRef idx="minor">
+            <a:schemeClr val="lt1"/>
+          </a:fontRef>
+        </p:style>
+        <p:txBody>
+          <a:bodyPr rtlCol="0" anchor="ctr"/>
+          <a:lstStyle/>
+          <a:p>
+            <a:pPr algn="ctr"/>
+            <a:endParaRPr/>
+          </a:p>
+        </p:txBody>
+      </p:sp>
+      <p:sp>
+        <p:nvSpPr>
+          <p:cNvPr id="13" name="TextBox 12"/>
+          <p:cNvSpPr txBox="1"/>
+          <p:nvPr/>
+        </p:nvSpPr>
+        <p:spPr>
+          <a:xfrm>
+            <a:off x="502920" y="3428999"/>
+            <a:ext cx="3291840" cy="502920"/>
+          </a:xfrm>
+          <a:prstGeom prst="rect">
+            <a:avLst/>
+          </a:prstGeom>
+          <a:noFill/>
+        </p:spPr>
+        <p:txBody>
+          <a:bodyPr wrap="square">
+            <a:spAutoFit/>
+          </a:bodyPr>
+          <a:lstStyle/>
+          <a:p>
+            <a:pPr algn="l"/>
+            <a:r>
+              <a:rPr sz="1200" b="1">
+                <a:solidFill>
+                  <a:srgbClr val="2E7D32"/>
+                </a:solidFill>
+              </a:rPr>
+              <a:t>● 三重パラドックスの定量化</a:t>
+            </a:r>
+          </a:p>
+        </p:txBody>
+      </p:sp>
+      <p:sp>
+        <p:nvSpPr>
+          <p:cNvPr id="14" name="TextBox 13"/>
+          <p:cNvSpPr txBox="1"/>
+          <p:nvPr/>
+        </p:nvSpPr>
+        <p:spPr>
+          <a:xfrm>
+            <a:off x="502920" y="3950207"/>
+            <a:ext cx="3291840" cy="731520"/>
+          </a:xfrm>
+          <a:prstGeom prst="rect">
+            <a:avLst/>
+          </a:prstGeom>
+          <a:noFill/>
+        </p:spPr>
+        <p:txBody>
+          <a:bodyPr wrap="square">
+            <a:spAutoFit/>
+          </a:bodyPr>
+          <a:lstStyle/>
+          <a:p>
+            <a:pPr algn="l"/>
+            <a:r>
+              <a:rPr sz="1100" b="0">
+                <a:solidFill>
+                  <a:srgbClr val="212121"/>
+                </a:solidFill>
+              </a:rPr>
+              <a:t>STOI↑PESQ↑CER↑が全ノイズ条件で
+一貫することを30条件・統計検定で示した。</a:t>
+            </a:r>
+          </a:p>
+        </p:txBody>
+      </p:sp>
+      <p:sp>
+        <p:nvSpPr>
+          <p:cNvPr id="15" name="Rectangle 14"/>
+          <p:cNvSpPr/>
+          <p:nvPr/>
+        </p:nvSpPr>
+        <p:spPr>
+          <a:xfrm>
+            <a:off x="411480" y="4892039"/>
+            <a:ext cx="3474720" cy="1371600"/>
+          </a:xfrm>
+          <a:prstGeom prst="rect">
+            <a:avLst/>
+          </a:prstGeom>
+          <a:solidFill>
+            <a:srgbClr val="C8E6C9"/>
+          </a:solidFill>
+          <a:ln>
+            <a:noFill/>
+          </a:ln>
+        </p:spPr>
+        <p:style>
+          <a:lnRef idx="1">
+            <a:schemeClr val="accent1"/>
+          </a:lnRef>
+          <a:fillRef idx="3">
+            <a:schemeClr val="accent1"/>
+          </a:fillRef>
+          <a:effectRef idx="2">
+            <a:schemeClr val="accent1"/>
+          </a:effectRef>
+          <a:fontRef idx="minor">
+            <a:schemeClr val="lt1"/>
+          </a:fontRef>
+        </p:style>
+        <p:txBody>
+          <a:bodyPr rtlCol="0" anchor="ctr"/>
+          <a:lstStyle/>
+          <a:p>
+            <a:pPr algn="ctr"/>
+            <a:endParaRPr/>
+          </a:p>
+        </p:txBody>
+      </p:sp>
+      <p:sp>
+        <p:nvSpPr>
+          <p:cNvPr id="16" name="TextBox 15"/>
+          <p:cNvSpPr txBox="1"/>
+          <p:nvPr/>
+        </p:nvSpPr>
+        <p:spPr>
+          <a:xfrm>
+            <a:off x="502920" y="4937759"/>
+            <a:ext cx="3291840" cy="502920"/>
+          </a:xfrm>
+          <a:prstGeom prst="rect">
+            <a:avLst/>
+          </a:prstGeom>
+          <a:noFill/>
+        </p:spPr>
+        <p:txBody>
+          <a:bodyPr wrap="square">
+            <a:spAutoFit/>
+          </a:bodyPr>
+          <a:lstStyle/>
+          <a:p>
+            <a:pPr algn="l"/>
+            <a:r>
+              <a:rPr sz="1200" b="1">
+                <a:solidFill>
+                  <a:srgbClr val="2E7D32"/>
+                </a:solidFill>
+              </a:rPr>
+              <a:t>● スペクトル分析による
+メカニズムの可視化</a:t>
+            </a:r>
+          </a:p>
+        </p:txBody>
+      </p:sp>
+      <p:sp>
+        <p:nvSpPr>
+          <p:cNvPr id="17" name="TextBox 16"/>
+          <p:cNvSpPr txBox="1"/>
+          <p:nvPr/>
+        </p:nvSpPr>
+        <p:spPr>
+          <a:xfrm>
+            <a:off x="502920" y="5458967"/>
+            <a:ext cx="3291840" cy="731520"/>
+          </a:xfrm>
+          <a:prstGeom prst="rect">
+            <a:avLst/>
+          </a:prstGeom>
+          <a:noFill/>
+        </p:spPr>
+        <p:txBody>
+          <a:bodyPr wrap="square">
+            <a:spAutoFit/>
+          </a:bodyPr>
+          <a:lstStyle/>
+          <a:p>
+            <a:pPr algn="l"/>
+            <a:r>
+              <a:rPr sz="1100" b="0">
+                <a:solidFill>
+                  <a:srgbClr val="212121"/>
+                </a:solidFill>
+              </a:rPr>
+              <a:t>4–8 kHz での −12.7 dB 削除という
+具体的な原因を実測で特定。</a:t>
+            </a:r>
+          </a:p>
+        </p:txBody>
+      </p:sp>
+      <p:sp>
+        <p:nvSpPr>
+          <p:cNvPr id="18" name="Rectangle 17"/>
+          <p:cNvSpPr/>
+          <p:nvPr/>
+        </p:nvSpPr>
+        <p:spPr>
+          <a:xfrm>
+            <a:off x="4206240" y="1325880"/>
+            <a:ext cx="3749039" cy="5212080"/>
+          </a:xfrm>
+          <a:prstGeom prst="rect">
+            <a:avLst/>
+          </a:prstGeom>
+          <a:solidFill>
+            <a:srgbClr val="FFF9C4"/>
+          </a:solidFill>
+          <a:ln>
+            <a:noFill/>
+          </a:ln>
+        </p:spPr>
+        <p:style>
+          <a:lnRef idx="1">
+            <a:schemeClr val="accent1"/>
+          </a:lnRef>
+          <a:fillRef idx="3">
+            <a:schemeClr val="accent1"/>
+          </a:fillRef>
+          <a:effectRef idx="2">
+            <a:schemeClr val="accent1"/>
+          </a:effectRef>
+          <a:fontRef idx="minor">
+            <a:schemeClr val="lt1"/>
+          </a:fontRef>
+        </p:style>
+        <p:txBody>
+          <a:bodyPr rtlCol="0" anchor="ctr"/>
+          <a:lstStyle/>
+          <a:p>
+            <a:pPr algn="ctr"/>
+            <a:endParaRPr/>
+          </a:p>
+        </p:txBody>
+      </p:sp>
+      <p:sp>
+        <p:nvSpPr>
+          <p:cNvPr id="19" name="TextBox 18"/>
+          <p:cNvSpPr txBox="1"/>
+          <p:nvPr/>
+        </p:nvSpPr>
+        <p:spPr>
+          <a:xfrm>
+            <a:off x="4343400" y="1417320"/>
+            <a:ext cx="3474720" cy="347472"/>
+          </a:xfrm>
+          <a:prstGeom prst="rect">
+            <a:avLst/>
+          </a:prstGeom>
+          <a:noFill/>
+        </p:spPr>
+        <p:txBody>
+          <a:bodyPr wrap="square">
+            <a:spAutoFit/>
+          </a:bodyPr>
+          <a:lstStyle/>
+          <a:p>
+            <a:pPr algn="l"/>
+            <a:r>
+              <a:rPr sz="1400" b="1">
+                <a:solidFill>
+                  <a:srgbClr val="FF6F00"/>
+                </a:solidFill>
+              </a:rPr>
+              <a:t>現状の限界</a:t>
+            </a:r>
+          </a:p>
+        </p:txBody>
+      </p:sp>
+      <p:sp>
+        <p:nvSpPr>
+          <p:cNvPr id="20" name="Rectangle 19"/>
+          <p:cNvSpPr/>
+          <p:nvPr/>
+        </p:nvSpPr>
+        <p:spPr>
+          <a:xfrm>
+            <a:off x="4343400" y="1874519"/>
+            <a:ext cx="3474720" cy="1005840"/>
+          </a:xfrm>
+          <a:prstGeom prst="rect">
+            <a:avLst/>
+          </a:prstGeom>
+          <a:solidFill>
+            <a:srgbClr val="FFF0B0"/>
+          </a:solidFill>
+          <a:ln>
+            <a:noFill/>
+          </a:ln>
+        </p:spPr>
+        <p:style>
+          <a:lnRef idx="1">
+            <a:schemeClr val="accent1"/>
+          </a:lnRef>
+          <a:fillRef idx="3">
+            <a:schemeClr val="accent1"/>
+          </a:fillRef>
+          <a:effectRef idx="2">
+            <a:schemeClr val="accent1"/>
+          </a:effectRef>
+          <a:fontRef idx="minor">
+            <a:schemeClr val="lt1"/>
+          </a:fontRef>
+        </p:style>
+        <p:txBody>
+          <a:bodyPr rtlCol="0" anchor="ctr"/>
+          <a:lstStyle/>
+          <a:p>
+            <a:pPr algn="ctr"/>
+            <a:endParaRPr/>
+          </a:p>
+        </p:txBody>
+      </p:sp>
+      <p:sp>
+        <p:nvSpPr>
+          <p:cNvPr id="21" name="TextBox 20"/>
+          <p:cNvSpPr txBox="1"/>
+          <p:nvPr/>
+        </p:nvSpPr>
+        <p:spPr>
+          <a:xfrm>
+            <a:off x="4434840" y="1920239"/>
+            <a:ext cx="3291840" cy="292608"/>
+          </a:xfrm>
+          <a:prstGeom prst="rect">
+            <a:avLst/>
+          </a:prstGeom>
+          <a:noFill/>
+        </p:spPr>
+        <p:txBody>
+          <a:bodyPr wrap="square">
+            <a:spAutoFit/>
+          </a:bodyPr>
+          <a:lstStyle/>
+          <a:p>
+            <a:pPr algn="l"/>
+            <a:r>
+              <a:rPr sz="1200" b="1">
+                <a:solidFill>
+                  <a:srgbClr val="FF6F00"/>
+                </a:solidFill>
+              </a:rPr>
+              <a:t>▲ 既存モデルの組み合わせ</a:t>
+            </a:r>
+          </a:p>
+        </p:txBody>
+      </p:sp>
+      <p:sp>
+        <p:nvSpPr>
+          <p:cNvPr id="22" name="TextBox 21"/>
+          <p:cNvSpPr txBox="1"/>
+          <p:nvPr/>
+        </p:nvSpPr>
+        <p:spPr>
+          <a:xfrm>
+            <a:off x="4434840" y="2240279"/>
+            <a:ext cx="3291840" cy="594360"/>
+          </a:xfrm>
+          <a:prstGeom prst="rect">
+            <a:avLst/>
+          </a:prstGeom>
+          <a:noFill/>
+        </p:spPr>
+        <p:txBody>
+          <a:bodyPr wrap="square">
+            <a:spAutoFit/>
+          </a:bodyPr>
+          <a:lstStyle/>
+          <a:p>
+            <a:pPr algn="l"/>
+            <a:r>
+              <a:rPr sz="1100" b="0">
+                <a:solidFill>
+                  <a:srgbClr val="212121"/>
+                </a:solidFill>
+              </a:rPr>
+              <a:t>GTCRN も Whisper も既存モデルの
+適用のみ。SE の喉マイク向け
+再設計はしていない。</a:t>
+            </a:r>
+          </a:p>
+        </p:txBody>
+      </p:sp>
+      <p:sp>
+        <p:nvSpPr>
+          <p:cNvPr id="23" name="Rectangle 22"/>
+          <p:cNvSpPr/>
+          <p:nvPr/>
+        </p:nvSpPr>
+        <p:spPr>
+          <a:xfrm>
+            <a:off x="4343400" y="2990087"/>
+            <a:ext cx="3474720" cy="1005840"/>
+          </a:xfrm>
+          <a:prstGeom prst="rect">
+            <a:avLst/>
+          </a:prstGeom>
+          <a:solidFill>
+            <a:srgbClr val="FFF0B0"/>
+          </a:solidFill>
+          <a:ln>
+            <a:noFill/>
+          </a:ln>
+        </p:spPr>
+        <p:style>
+          <a:lnRef idx="1">
+            <a:schemeClr val="accent1"/>
+          </a:lnRef>
+          <a:fillRef idx="3">
+            <a:schemeClr val="accent1"/>
+          </a:fillRef>
+          <a:effectRef idx="2">
+            <a:schemeClr val="accent1"/>
+          </a:effectRef>
+          <a:fontRef idx="minor">
+            <a:schemeClr val="lt1"/>
+          </a:fontRef>
+        </p:style>
+        <p:txBody>
+          <a:bodyPr rtlCol="0" anchor="ctr"/>
+          <a:lstStyle/>
+          <a:p>
+            <a:pPr algn="ctr"/>
+            <a:endParaRPr/>
+          </a:p>
+        </p:txBody>
+      </p:sp>
+      <p:sp>
+        <p:nvSpPr>
+          <p:cNvPr id="24" name="TextBox 23"/>
+          <p:cNvSpPr txBox="1"/>
+          <p:nvPr/>
+        </p:nvSpPr>
+        <p:spPr>
+          <a:xfrm>
+            <a:off x="4434840" y="3035807"/>
+            <a:ext cx="3291840" cy="292608"/>
+          </a:xfrm>
+          <a:prstGeom prst="rect">
+            <a:avLst/>
+          </a:prstGeom>
+          <a:noFill/>
+        </p:spPr>
+        <p:txBody>
+          <a:bodyPr wrap="square">
+            <a:spAutoFit/>
+          </a:bodyPr>
+          <a:lstStyle/>
+          <a:p>
+            <a:pPr algn="l"/>
+            <a:r>
+              <a:rPr sz="1200" b="1">
+                <a:solidFill>
+                  <a:srgbClr val="FF6F00"/>
+                </a:solidFill>
+              </a:rPr>
+              <a:t>▲ 韓国語・単一データセット</a:t>
+            </a:r>
+          </a:p>
+        </p:txBody>
+      </p:sp>
+      <p:sp>
+        <p:nvSpPr>
+          <p:cNvPr id="25" name="TextBox 24"/>
+          <p:cNvSpPr txBox="1"/>
+          <p:nvPr/>
+        </p:nvSpPr>
+        <p:spPr>
+          <a:xfrm>
+            <a:off x="4434840" y="3355847"/>
+            <a:ext cx="3291840" cy="594360"/>
+          </a:xfrm>
+          <a:prstGeom prst="rect">
+            <a:avLst/>
+          </a:prstGeom>
+          <a:noFill/>
+        </p:spPr>
+        <p:txBody>
+          <a:bodyPr wrap="square">
+            <a:spAutoFit/>
+          </a:bodyPr>
+          <a:lstStyle/>
+          <a:p>
+            <a:pPr algn="l"/>
+            <a:r>
+              <a:rPr sz="1100" b="0">
+                <a:solidFill>
+                  <a:srgbClr val="212121"/>
+                </a:solidFill>
+              </a:rPr>
+              <a:t>TAPS のみ使用。他言語・他データへの
+汎化性は未検証。</a:t>
+            </a:r>
+          </a:p>
+        </p:txBody>
+      </p:sp>
+      <p:sp>
+        <p:nvSpPr>
+          <p:cNvPr id="26" name="Rectangle 25"/>
+          <p:cNvSpPr/>
+          <p:nvPr/>
+        </p:nvSpPr>
+        <p:spPr>
+          <a:xfrm>
+            <a:off x="4343400" y="4105655"/>
+            <a:ext cx="3474720" cy="1005840"/>
+          </a:xfrm>
+          <a:prstGeom prst="rect">
+            <a:avLst/>
+          </a:prstGeom>
+          <a:solidFill>
+            <a:srgbClr val="FFF0B0"/>
+          </a:solidFill>
+          <a:ln>
+            <a:noFill/>
+          </a:ln>
+        </p:spPr>
+        <p:style>
+          <a:lnRef idx="1">
+            <a:schemeClr val="accent1"/>
+          </a:lnRef>
+          <a:fillRef idx="3">
+            <a:schemeClr val="accent1"/>
+          </a:fillRef>
+          <a:effectRef idx="2">
+            <a:schemeClr val="accent1"/>
+          </a:effectRef>
+          <a:fontRef idx="minor">
+            <a:schemeClr val="lt1"/>
+          </a:fontRef>
+        </p:style>
+        <p:txBody>
+          <a:bodyPr rtlCol="0" anchor="ctr"/>
+          <a:lstStyle/>
+          <a:p>
+            <a:pPr algn="ctr"/>
+            <a:endParaRPr/>
+          </a:p>
+        </p:txBody>
+      </p:sp>
+      <p:sp>
+        <p:nvSpPr>
+          <p:cNvPr id="27" name="TextBox 26"/>
+          <p:cNvSpPr txBox="1"/>
+          <p:nvPr/>
+        </p:nvSpPr>
+        <p:spPr>
+          <a:xfrm>
+            <a:off x="4434840" y="4151375"/>
+            <a:ext cx="3291840" cy="292608"/>
+          </a:xfrm>
+          <a:prstGeom prst="rect">
+            <a:avLst/>
+          </a:prstGeom>
+          <a:noFill/>
+        </p:spPr>
+        <p:txBody>
+          <a:bodyPr wrap="square">
+            <a:spAutoFit/>
+          </a:bodyPr>
+          <a:lstStyle/>
+          <a:p>
+            <a:pPr algn="l"/>
+            <a:r>
+              <a:rPr sz="1200" b="1">
+                <a:solidFill>
+                  <a:srgbClr val="FF6F00"/>
+                </a:solidFill>
+              </a:rPr>
+              <a:t>▲ クリーン条件でのFT</a:t>
+            </a:r>
+          </a:p>
+        </p:txBody>
+      </p:sp>
+      <p:sp>
+        <p:nvSpPr>
+          <p:cNvPr id="28" name="TextBox 27"/>
+          <p:cNvSpPr txBox="1"/>
+          <p:nvPr/>
+        </p:nvSpPr>
+        <p:spPr>
+          <a:xfrm>
+            <a:off x="4434840" y="4471415"/>
+            <a:ext cx="3291840" cy="594360"/>
+          </a:xfrm>
+          <a:prstGeom prst="rect">
+            <a:avLst/>
+          </a:prstGeom>
+          <a:noFill/>
+        </p:spPr>
+        <p:txBody>
+          <a:bodyPr wrap="square">
+            <a:spAutoFit/>
+          </a:bodyPr>
+          <a:lstStyle/>
+          <a:p>
+            <a:pPr algn="l"/>
+            <a:r>
+              <a:rPr sz="1100" b="0">
+                <a:solidFill>
+                  <a:srgbClr val="212121"/>
+                </a:solidFill>
+              </a:rPr>
+              <a:t>FT はクリーン音声のみ。
+ノイズ下での頑健性評価が不足。</a:t>
+            </a:r>
+          </a:p>
+        </p:txBody>
+      </p:sp>
+      <p:sp>
+        <p:nvSpPr>
+          <p:cNvPr id="29" name="Rectangle 28"/>
+          <p:cNvSpPr/>
+          <p:nvPr/>
+        </p:nvSpPr>
+        <p:spPr>
+          <a:xfrm>
+            <a:off x="4343400" y="5221223"/>
+            <a:ext cx="3474720" cy="1005840"/>
+          </a:xfrm>
+          <a:prstGeom prst="rect">
+            <a:avLst/>
+          </a:prstGeom>
+          <a:solidFill>
+            <a:srgbClr val="FFF0B0"/>
+          </a:solidFill>
+          <a:ln>
+            <a:noFill/>
+          </a:ln>
+        </p:spPr>
+        <p:style>
+          <a:lnRef idx="1">
+            <a:schemeClr val="accent1"/>
+          </a:lnRef>
+          <a:fillRef idx="3">
+            <a:schemeClr val="accent1"/>
+          </a:fillRef>
+          <a:effectRef idx="2">
+            <a:schemeClr val="accent1"/>
+          </a:effectRef>
+          <a:fontRef idx="minor">
+            <a:schemeClr val="lt1"/>
+          </a:fontRef>
+        </p:style>
+        <p:txBody>
+          <a:bodyPr rtlCol="0" anchor="ctr"/>
+          <a:lstStyle/>
+          <a:p>
+            <a:pPr algn="ctr"/>
+            <a:endParaRPr/>
+          </a:p>
+        </p:txBody>
+      </p:sp>
+      <p:sp>
+        <p:nvSpPr>
+          <p:cNvPr id="30" name="TextBox 29"/>
+          <p:cNvSpPr txBox="1"/>
+          <p:nvPr/>
+        </p:nvSpPr>
+        <p:spPr>
+          <a:xfrm>
+            <a:off x="4434840" y="5266943"/>
+            <a:ext cx="3291840" cy="292608"/>
+          </a:xfrm>
+          <a:prstGeom prst="rect">
+            <a:avLst/>
+          </a:prstGeom>
+          <a:noFill/>
+        </p:spPr>
+        <p:txBody>
+          <a:bodyPr wrap="square">
+            <a:spAutoFit/>
+          </a:bodyPr>
+          <a:lstStyle/>
+          <a:p>
+            <a:pPr algn="l"/>
+            <a:r>
+              <a:rPr sz="1200" b="1">
+                <a:solidFill>
+                  <a:srgbClr val="FF6F00"/>
+                </a:solidFill>
+              </a:rPr>
+              <a:t>▲ 音素レベルの分析なし</a:t>
+            </a:r>
+          </a:p>
+        </p:txBody>
+      </p:sp>
+      <p:sp>
+        <p:nvSpPr>
+          <p:cNvPr id="31" name="TextBox 30"/>
+          <p:cNvSpPr txBox="1"/>
+          <p:nvPr/>
+        </p:nvSpPr>
+        <p:spPr>
+          <a:xfrm>
+            <a:off x="4434840" y="5586983"/>
+            <a:ext cx="3291840" cy="594360"/>
+          </a:xfrm>
+          <a:prstGeom prst="rect">
+            <a:avLst/>
+          </a:prstGeom>
+          <a:noFill/>
+        </p:spPr>
+        <p:txBody>
+          <a:bodyPr wrap="square">
+            <a:spAutoFit/>
+          </a:bodyPr>
+          <a:lstStyle/>
+          <a:p>
+            <a:pPr algn="l"/>
+            <a:r>
+              <a:rPr sz="1100" b="0">
+                <a:solidFill>
+                  <a:srgbClr val="212121"/>
+                </a:solidFill>
+              </a:rPr>
+              <a:t>どの音素が特に誤認識されるかの
+詳細分析は未実施。</a:t>
+            </a:r>
+          </a:p>
+        </p:txBody>
+      </p:sp>
+      <p:sp>
+        <p:nvSpPr>
+          <p:cNvPr id="32" name="Rectangle 31"/>
+          <p:cNvSpPr/>
+          <p:nvPr/>
+        </p:nvSpPr>
+        <p:spPr>
+          <a:xfrm>
+            <a:off x="8138160" y="1325880"/>
+            <a:ext cx="3749039" cy="5212080"/>
+          </a:xfrm>
+          <a:prstGeom prst="rect">
+            <a:avLst/>
+          </a:prstGeom>
+          <a:solidFill>
+            <a:srgbClr val="E3F2FD"/>
+          </a:solidFill>
+          <a:ln>
+            <a:noFill/>
+          </a:ln>
+        </p:spPr>
+        <p:style>
+          <a:lnRef idx="1">
+            <a:schemeClr val="accent1"/>
+          </a:lnRef>
+          <a:fillRef idx="3">
+            <a:schemeClr val="accent1"/>
+          </a:fillRef>
+          <a:effectRef idx="2">
+            <a:schemeClr val="accent1"/>
+          </a:effectRef>
+          <a:fontRef idx="minor">
+            <a:schemeClr val="lt1"/>
+          </a:fontRef>
+        </p:style>
+        <p:txBody>
+          <a:bodyPr rtlCol="0" anchor="ctr"/>
+          <a:lstStyle/>
+          <a:p>
+            <a:pPr algn="ctr"/>
+            <a:endParaRPr/>
+          </a:p>
+        </p:txBody>
+      </p:sp>
+      <p:sp>
+        <p:nvSpPr>
+          <p:cNvPr id="33" name="TextBox 32"/>
+          <p:cNvSpPr txBox="1"/>
+          <p:nvPr/>
+        </p:nvSpPr>
+        <p:spPr>
+          <a:xfrm>
+            <a:off x="8275320" y="1417320"/>
+            <a:ext cx="3474720" cy="347472"/>
+          </a:xfrm>
+          <a:prstGeom prst="rect">
+            <a:avLst/>
+          </a:prstGeom>
+          <a:noFill/>
+        </p:spPr>
+        <p:txBody>
+          <a:bodyPr wrap="square">
+            <a:spAutoFit/>
+          </a:bodyPr>
+          <a:lstStyle/>
+          <a:p>
+            <a:pPr algn="l"/>
+            <a:r>
+              <a:rPr sz="1400" b="1">
+                <a:solidFill>
+                  <a:srgbClr val="1A237E"/>
+                </a:solidFill>
+              </a:rPr>
+              <a:t>今後の展望</a:t>
+            </a:r>
+          </a:p>
+        </p:txBody>
+      </p:sp>
+      <p:sp>
+        <p:nvSpPr>
+          <p:cNvPr id="34" name="Rectangle 33"/>
+          <p:cNvSpPr/>
+          <p:nvPr/>
+        </p:nvSpPr>
+        <p:spPr>
+          <a:xfrm>
+            <a:off x="8275320" y="1874519"/>
+            <a:ext cx="3474720" cy="1005840"/>
+          </a:xfrm>
+          <a:prstGeom prst="rect">
+            <a:avLst/>
+          </a:prstGeom>
+          <a:solidFill>
+            <a:srgbClr val="BBDEFB"/>
+          </a:solidFill>
+          <a:ln>
+            <a:noFill/>
+          </a:ln>
+        </p:spPr>
+        <p:style>
+          <a:lnRef idx="1">
+            <a:schemeClr val="accent1"/>
+          </a:lnRef>
+          <a:fillRef idx="3">
+            <a:schemeClr val="accent1"/>
+          </a:fillRef>
+          <a:effectRef idx="2">
+            <a:schemeClr val="accent1"/>
+          </a:effectRef>
+          <a:fontRef idx="minor">
+            <a:schemeClr val="lt1"/>
+          </a:fontRef>
+        </p:style>
+        <p:txBody>
+          <a:bodyPr rtlCol="0" anchor="ctr"/>
+          <a:lstStyle/>
+          <a:p>
+            <a:pPr algn="ctr"/>
+            <a:endParaRPr/>
+          </a:p>
+        </p:txBody>
+      </p:sp>
+      <p:sp>
+        <p:nvSpPr>
+          <p:cNvPr id="35" name="TextBox 34"/>
+          <p:cNvSpPr txBox="1"/>
+          <p:nvPr/>
+        </p:nvSpPr>
+        <p:spPr>
+          <a:xfrm>
+            <a:off x="8366760" y="1920239"/>
+            <a:ext cx="3291840" cy="292608"/>
+          </a:xfrm>
+          <a:prstGeom prst="rect">
+            <a:avLst/>
+          </a:prstGeom>
+          <a:noFill/>
+        </p:spPr>
+        <p:txBody>
+          <a:bodyPr wrap="square">
+            <a:spAutoFit/>
+          </a:bodyPr>
+          <a:lstStyle/>
+          <a:p>
+            <a:pPr algn="l"/>
+            <a:r>
+              <a:rPr sz="1200" b="1">
+                <a:solidFill>
+                  <a:srgbClr val="1A237E"/>
+                </a:solidFill>
+              </a:rPr>
+              <a:t>→ ドメイン適合型 SE の開発</a:t>
+            </a:r>
+          </a:p>
+        </p:txBody>
+      </p:sp>
+      <p:sp>
+        <p:nvSpPr>
+          <p:cNvPr id="36" name="TextBox 35"/>
+          <p:cNvSpPr txBox="1"/>
+          <p:nvPr/>
+        </p:nvSpPr>
+        <p:spPr>
+          <a:xfrm>
+            <a:off x="8366760" y="2240279"/>
+            <a:ext cx="3291840" cy="594360"/>
+          </a:xfrm>
+          <a:prstGeom prst="rect">
+            <a:avLst/>
+          </a:prstGeom>
+          <a:noFill/>
+        </p:spPr>
+        <p:txBody>
+          <a:bodyPr wrap="square">
+            <a:spAutoFit/>
+          </a:bodyPr>
+          <a:lstStyle/>
+          <a:p>
+            <a:pPr algn="l"/>
+            <a:r>
+              <a:rPr sz="1100" b="0">
+                <a:solidFill>
+                  <a:srgbClr val="212121"/>
+                </a:solidFill>
+              </a:rPr>
+              <a:t>TAPS で学習した SE-conformer
+（Kim et al. 2025）との組み合わせ。
+FT × 適合型SE で CER がどこまで下がるか。</a:t>
+            </a:r>
+          </a:p>
+        </p:txBody>
+      </p:sp>
+      <p:sp>
+        <p:nvSpPr>
+          <p:cNvPr id="37" name="Rectangle 36"/>
+          <p:cNvSpPr/>
+          <p:nvPr/>
+        </p:nvSpPr>
+        <p:spPr>
+          <a:xfrm>
+            <a:off x="8275320" y="2990087"/>
+            <a:ext cx="3474720" cy="1005840"/>
+          </a:xfrm>
+          <a:prstGeom prst="rect">
+            <a:avLst/>
+          </a:prstGeom>
+          <a:solidFill>
+            <a:srgbClr val="BBDEFB"/>
+          </a:solidFill>
+          <a:ln>
+            <a:noFill/>
+          </a:ln>
+        </p:spPr>
+        <p:style>
+          <a:lnRef idx="1">
+            <a:schemeClr val="accent1"/>
+          </a:lnRef>
+          <a:fillRef idx="3">
+            <a:schemeClr val="accent1"/>
+          </a:fillRef>
+          <a:effectRef idx="2">
+            <a:schemeClr val="accent1"/>
+          </a:effectRef>
+          <a:fontRef idx="minor">
+            <a:schemeClr val="lt1"/>
+          </a:fontRef>
+        </p:style>
+        <p:txBody>
+          <a:bodyPr rtlCol="0" anchor="ctr"/>
+          <a:lstStyle/>
+          <a:p>
+            <a:pPr algn="ctr"/>
+            <a:endParaRPr/>
+          </a:p>
+        </p:txBody>
+      </p:sp>
+      <p:sp>
+        <p:nvSpPr>
+          <p:cNvPr id="38" name="TextBox 37"/>
+          <p:cNvSpPr txBox="1"/>
+          <p:nvPr/>
+        </p:nvSpPr>
+        <p:spPr>
+          <a:xfrm>
+            <a:off x="8366760" y="3035807"/>
+            <a:ext cx="3291840" cy="292608"/>
+          </a:xfrm>
+          <a:prstGeom prst="rect">
+            <a:avLst/>
+          </a:prstGeom>
+          <a:noFill/>
+        </p:spPr>
+        <p:txBody>
+          <a:bodyPr wrap="square">
+            <a:spAutoFit/>
+          </a:bodyPr>
+          <a:lstStyle/>
+          <a:p>
+            <a:pPr algn="l"/>
+            <a:r>
+              <a:rPr sz="1200" b="1">
+                <a:solidFill>
+                  <a:srgbClr val="1A237E"/>
+                </a:solidFill>
+              </a:rPr>
+              <a:t>→ ノイズ下での FT 評価</a:t>
+            </a:r>
+          </a:p>
+        </p:txBody>
+      </p:sp>
+      <p:sp>
+        <p:nvSpPr>
+          <p:cNvPr id="39" name="TextBox 38"/>
+          <p:cNvSpPr txBox="1"/>
+          <p:nvPr/>
+        </p:nvSpPr>
+        <p:spPr>
+          <a:xfrm>
+            <a:off x="8366760" y="3355847"/>
+            <a:ext cx="3291840" cy="594360"/>
+          </a:xfrm>
+          <a:prstGeom prst="rect">
+            <a:avLst/>
+          </a:prstGeom>
+          <a:noFill/>
+        </p:spPr>
+        <p:txBody>
+          <a:bodyPr wrap="square">
+            <a:spAutoFit/>
+          </a:bodyPr>
+          <a:lstStyle/>
+          <a:p>
+            <a:pPr algn="l"/>
+            <a:r>
+              <a:rPr sz="1100" b="0">
+                <a:solidFill>
+                  <a:srgbClr val="212121"/>
+                </a:solidFill>
+              </a:rPr>
+              <a:t>実環境ノイズ（MUSAN・DEMAND）を
+使った頑健な学習と評価。</a:t>
+            </a:r>
+          </a:p>
+        </p:txBody>
+      </p:sp>
+      <p:sp>
+        <p:nvSpPr>
+          <p:cNvPr id="40" name="Rectangle 39"/>
+          <p:cNvSpPr/>
+          <p:nvPr/>
+        </p:nvSpPr>
+        <p:spPr>
+          <a:xfrm>
+            <a:off x="8275320" y="4105655"/>
+            <a:ext cx="3474720" cy="1005840"/>
+          </a:xfrm>
+          <a:prstGeom prst="rect">
+            <a:avLst/>
+          </a:prstGeom>
+          <a:solidFill>
+            <a:srgbClr val="BBDEFB"/>
+          </a:solidFill>
+          <a:ln>
+            <a:noFill/>
+          </a:ln>
+        </p:spPr>
+        <p:style>
+          <a:lnRef idx="1">
+            <a:schemeClr val="accent1"/>
+          </a:lnRef>
+          <a:fillRef idx="3">
+            <a:schemeClr val="accent1"/>
+          </a:fillRef>
+          <a:effectRef idx="2">
+            <a:schemeClr val="accent1"/>
+          </a:effectRef>
+          <a:fontRef idx="minor">
+            <a:schemeClr val="lt1"/>
+          </a:fontRef>
+        </p:style>
+        <p:txBody>
+          <a:bodyPr rtlCol="0" anchor="ctr"/>
+          <a:lstStyle/>
+          <a:p>
+            <a:pPr algn="ctr"/>
+            <a:endParaRPr/>
+          </a:p>
+        </p:txBody>
+      </p:sp>
+      <p:sp>
+        <p:nvSpPr>
+          <p:cNvPr id="41" name="TextBox 40"/>
+          <p:cNvSpPr txBox="1"/>
+          <p:nvPr/>
+        </p:nvSpPr>
+        <p:spPr>
+          <a:xfrm>
+            <a:off x="8366760" y="4151375"/>
+            <a:ext cx="3291840" cy="292608"/>
+          </a:xfrm>
+          <a:prstGeom prst="rect">
+            <a:avLst/>
+          </a:prstGeom>
+          <a:noFill/>
+        </p:spPr>
+        <p:txBody>
+          <a:bodyPr wrap="square">
+            <a:spAutoFit/>
+          </a:bodyPr>
+          <a:lstStyle/>
+          <a:p>
+            <a:pPr algn="l"/>
+            <a:r>
+              <a:rPr sz="1200" b="1">
+                <a:solidFill>
+                  <a:srgbClr val="1A237E"/>
+                </a:solidFill>
+              </a:rPr>
+              <a:t>→ 音素誤認識の分析</a:t>
+            </a:r>
+          </a:p>
+        </p:txBody>
+      </p:sp>
+      <p:sp>
+        <p:nvSpPr>
+          <p:cNvPr id="42" name="TextBox 41"/>
+          <p:cNvSpPr txBox="1"/>
+          <p:nvPr/>
+        </p:nvSpPr>
+        <p:spPr>
+          <a:xfrm>
+            <a:off x="8366760" y="4471415"/>
+            <a:ext cx="3291840" cy="594360"/>
+          </a:xfrm>
+          <a:prstGeom prst="rect">
+            <a:avLst/>
+          </a:prstGeom>
+          <a:noFill/>
+        </p:spPr>
+        <p:txBody>
+          <a:bodyPr wrap="square">
+            <a:spAutoFit/>
+          </a:bodyPr>
+          <a:lstStyle/>
+          <a:p>
+            <a:pPr algn="l"/>
+            <a:r>
+              <a:rPr sz="1100" b="0">
+                <a:solidFill>
+                  <a:srgbClr val="212121"/>
+                </a:solidFill>
+              </a:rPr>
+              <a:t>喉マイクで特に苦手な音素を特定し
+データ収集・学習戦略に活かす。</a:t>
+            </a:r>
+          </a:p>
+        </p:txBody>
+      </p:sp>
+      <p:sp>
+        <p:nvSpPr>
+          <p:cNvPr id="43" name="Rectangle 42"/>
+          <p:cNvSpPr/>
+          <p:nvPr/>
+        </p:nvSpPr>
+        <p:spPr>
+          <a:xfrm>
+            <a:off x="8275320" y="5221223"/>
+            <a:ext cx="3474720" cy="1005840"/>
+          </a:xfrm>
+          <a:prstGeom prst="rect">
+            <a:avLst/>
+          </a:prstGeom>
+          <a:solidFill>
+            <a:srgbClr val="BBDEFB"/>
+          </a:solidFill>
+          <a:ln>
+            <a:noFill/>
+          </a:ln>
+        </p:spPr>
+        <p:style>
+          <a:lnRef idx="1">
+            <a:schemeClr val="accent1"/>
+          </a:lnRef>
+          <a:fillRef idx="3">
+            <a:schemeClr val="accent1"/>
+          </a:fillRef>
+          <a:effectRef idx="2">
+            <a:schemeClr val="accent1"/>
+          </a:effectRef>
+          <a:fontRef idx="minor">
+            <a:schemeClr val="lt1"/>
+          </a:fontRef>
+        </p:style>
+        <p:txBody>
+          <a:bodyPr rtlCol="0" anchor="ctr"/>
+          <a:lstStyle/>
+          <a:p>
+            <a:pPr algn="ctr"/>
+            <a:endParaRPr/>
+          </a:p>
+        </p:txBody>
+      </p:sp>
+      <p:sp>
+        <p:nvSpPr>
+          <p:cNvPr id="44" name="TextBox 43"/>
+          <p:cNvSpPr txBox="1"/>
+          <p:nvPr/>
+        </p:nvSpPr>
+        <p:spPr>
+          <a:xfrm>
+            <a:off x="8366760" y="5266943"/>
+            <a:ext cx="3291840" cy="292608"/>
+          </a:xfrm>
+          <a:prstGeom prst="rect">
+            <a:avLst/>
+          </a:prstGeom>
+          <a:noFill/>
+        </p:spPr>
+        <p:txBody>
+          <a:bodyPr wrap="square">
+            <a:spAutoFit/>
+          </a:bodyPr>
+          <a:lstStyle/>
+          <a:p>
+            <a:pPr algn="l"/>
+            <a:r>
+              <a:rPr sz="1200" b="1">
+                <a:solidFill>
+                  <a:srgbClr val="1A237E"/>
+                </a:solidFill>
+              </a:rPr>
+              <a:t>→ Whisper large-v3 との比較</a:t>
+            </a:r>
+          </a:p>
+        </p:txBody>
+      </p:sp>
+      <p:sp>
+        <p:nvSpPr>
+          <p:cNvPr id="45" name="TextBox 44"/>
+          <p:cNvSpPr txBox="1"/>
+          <p:nvPr/>
+        </p:nvSpPr>
+        <p:spPr>
+          <a:xfrm>
+            <a:off x="8366760" y="5586983"/>
+            <a:ext cx="3291840" cy="594360"/>
+          </a:xfrm>
+          <a:prstGeom prst="rect">
+            <a:avLst/>
+          </a:prstGeom>
+          <a:noFill/>
+        </p:spPr>
+        <p:txBody>
+          <a:bodyPr wrap="square">
+            <a:spAutoFit/>
+          </a:bodyPr>
+          <a:lstStyle/>
+          <a:p>
+            <a:pPr algn="l"/>
+            <a:r>
+              <a:rPr sz="1100" b="0">
+                <a:solidFill>
+                  <a:srgbClr val="212121"/>
+                </a:solidFill>
+              </a:rPr>
+              <a:t>モデルサイズとドメイン適応効果
+のトレードオフを定量化。</a:t>
             </a:r>
           </a:p>
         </p:txBody>
@@ -8145,4 +10529,319 @@
   </a:objectDefaults>
   <a:extraClrSchemeLst/>
 </a:theme>
+</file>
+
+<file path=ppt/theme/theme2.xml><?xml version="1.0" encoding="utf-8"?>
+<a:theme xmlns:a="http://schemas.openxmlformats.org/drawingml/2006/main" name="Office テーマ">
+  <a:themeElements>
+    <a:clrScheme name="Office">
+      <a:dk1>
+        <a:sysClr val="windowText" lastClr="000000"/>
+      </a:dk1>
+      <a:lt1>
+        <a:sysClr val="window" lastClr="FFFFFF"/>
+      </a:lt1>
+      <a:dk2>
+        <a:srgbClr val="0E2841"/>
+      </a:dk2>
+      <a:lt2>
+        <a:srgbClr val="E8E8E8"/>
+      </a:lt2>
+      <a:accent1>
+        <a:srgbClr val="156082"/>
+      </a:accent1>
+      <a:accent2>
+        <a:srgbClr val="E97132"/>
+      </a:accent2>
+      <a:accent3>
+        <a:srgbClr val="196B24"/>
+      </a:accent3>
+      <a:accent4>
+        <a:srgbClr val="0F9ED5"/>
+      </a:accent4>
+      <a:accent5>
+        <a:srgbClr val="A02B93"/>
+      </a:accent5>
+      <a:accent6>
+        <a:srgbClr val="4EA72E"/>
+      </a:accent6>
+      <a:hlink>
+        <a:srgbClr val="467886"/>
+      </a:hlink>
+      <a:folHlink>
+        <a:srgbClr val="96607D"/>
+      </a:folHlink>
+    </a:clrScheme>
+    <a:fontScheme name="Office">
+      <a:majorFont>
+        <a:latin typeface="游ゴシック Light" panose="02110004020202020204"/>
+        <a:ea typeface=""/>
+        <a:cs typeface=""/>
+        <a:font script="Jpan" typeface="游ゴシック Light"/>
+        <a:font script="Hang" typeface="맑은 고딕"/>
+        <a:font script="Hans" typeface="等线 Light"/>
+        <a:font script="Hant" typeface="新細明體"/>
+        <a:font script="Arab" typeface="Times New Roman"/>
+        <a:font script="Hebr" typeface="Times New Roman"/>
+        <a:font script="Thai" typeface="Angsana New"/>
+        <a:font script="Ethi" typeface="Nyala"/>
+        <a:font script="Beng" typeface="Vrinda"/>
+        <a:font script="Gujr" typeface="Shruti"/>
+        <a:font script="Khmr" typeface="MoolBoran"/>
+        <a:font script="Knda" typeface="Tunga"/>
+        <a:font script="Guru" typeface="Raavi"/>
+        <a:font script="Cans" typeface="Euphemia"/>
+        <a:font script="Cher" typeface="Plantagenet Cherokee"/>
+        <a:font script="Yiii" typeface="Microsoft Yi Baiti"/>
+        <a:font script="Tibt" typeface="Microsoft Himalaya"/>
+        <a:font script="Thaa" typeface="MV Boli"/>
+        <a:font script="Deva" typeface="Mangal"/>
+        <a:font script="Telu" typeface="Gautami"/>
+        <a:font script="Taml" typeface="Latha"/>
+        <a:font script="Syrc" typeface="Estrangelo Edessa"/>
+        <a:font script="Orya" typeface="Kalinga"/>
+        <a:font script="Mlym" typeface="Kartika"/>
+        <a:font script="Laoo" typeface="DokChampa"/>
+        <a:font script="Sinh" typeface="Iskoola Pota"/>
+        <a:font script="Mong" typeface="Mongolian Baiti"/>
+        <a:font script="Viet" typeface="Times New Roman"/>
+        <a:font script="Uigh" typeface="Microsoft Uighur"/>
+        <a:font script="Geor" typeface="Sylfaen"/>
+        <a:font script="Armn" typeface="Arial"/>
+        <a:font script="Bugi" typeface="Leelawadee UI"/>
+        <a:font script="Bopo" typeface="Microsoft JhengHei"/>
+        <a:font script="Java" typeface="Javanese Text"/>
+        <a:font script="Lisu" typeface="Segoe UI"/>
+        <a:font script="Mymr" typeface="Myanmar Text"/>
+        <a:font script="Nkoo" typeface="Ebrima"/>
+        <a:font script="Olck" typeface="Nirmala UI"/>
+        <a:font script="Osma" typeface="Ebrima"/>
+        <a:font script="Phag" typeface="Phagspa"/>
+        <a:font script="Syrn" typeface="Estrangelo Edessa"/>
+        <a:font script="Syrj" typeface="Estrangelo Edessa"/>
+        <a:font script="Syre" typeface="Estrangelo Edessa"/>
+        <a:font script="Sora" typeface="Nirmala UI"/>
+        <a:font script="Tale" typeface="Microsoft Tai Le"/>
+        <a:font script="Talu" typeface="Microsoft New Tai Lue"/>
+        <a:font script="Tfng" typeface="Ebrima"/>
+      </a:majorFont>
+      <a:minorFont>
+        <a:latin typeface="游ゴシック" panose="02110004020202020204"/>
+        <a:ea typeface=""/>
+        <a:cs typeface=""/>
+        <a:font script="Jpan" typeface="游ゴシック"/>
+        <a:font script="Hang" typeface="맑은 고딕"/>
+        <a:font script="Hans" typeface="等线"/>
+        <a:font script="Hant" typeface="新細明體"/>
+        <a:font script="Arab" typeface="Arial"/>
+        <a:font script="Hebr" typeface="Arial"/>
+        <a:font script="Thai" typeface="Cordia New"/>
+        <a:font script="Ethi" typeface="Nyala"/>
+        <a:font script="Beng" typeface="Vrinda"/>
+        <a:font script="Gujr" typeface="Shruti"/>
+        <a:font script="Khmr" typeface="DaunPenh"/>
+        <a:font script="Knda" typeface="Tunga"/>
+        <a:font script="Guru" typeface="Raavi"/>
+        <a:font script="Cans" typeface="Euphemia"/>
+        <a:font script="Cher" typeface="Plantagenet Cherokee"/>
+        <a:font script="Yiii" typeface="Microsoft Yi Baiti"/>
+        <a:font script="Tibt" typeface="Microsoft Himalaya"/>
+        <a:font script="Thaa" typeface="MV Boli"/>
+        <a:font script="Deva" typeface="Mangal"/>
+        <a:font script="Telu" typeface="Gautami"/>
+        <a:font script="Taml" typeface="Latha"/>
+        <a:font script="Syrc" typeface="Estrangelo Edessa"/>
+        <a:font script="Orya" typeface="Kalinga"/>
+        <a:font script="Mlym" typeface="Kartika"/>
+        <a:font script="Laoo" typeface="DokChampa"/>
+        <a:font script="Sinh" typeface="Iskoola Pota"/>
+        <a:font script="Mong" typeface="Mongolian Baiti"/>
+        <a:font script="Viet" typeface="Arial"/>
+        <a:font script="Uigh" typeface="Microsoft Uighur"/>
+        <a:font script="Geor" typeface="Sylfaen"/>
+        <a:font script="Armn" typeface="Arial"/>
+        <a:font script="Bugi" typeface="Leelawadee UI"/>
+        <a:font script="Bopo" typeface="Microsoft JhengHei"/>
+        <a:font script="Java" typeface="Javanese Text"/>
+        <a:font script="Lisu" typeface="Segoe UI"/>
+        <a:font script="Mymr" typeface="Myanmar Text"/>
+        <a:font script="Nkoo" typeface="Ebrima"/>
+        <a:font script="Olck" typeface="Nirmala UI"/>
+        <a:font script="Osma" typeface="Ebrima"/>
+        <a:font script="Phag" typeface="Phagspa"/>
+        <a:font script="Syrn" typeface="Estrangelo Edessa"/>
+        <a:font script="Syrj" typeface="Estrangelo Edessa"/>
+        <a:font script="Syre" typeface="Estrangelo Edessa"/>
+        <a:font script="Sora" typeface="Nirmala UI"/>
+        <a:font script="Tale" typeface="Microsoft Tai Le"/>
+        <a:font script="Talu" typeface="Microsoft New Tai Lue"/>
+        <a:font script="Tfng" typeface="Ebrima"/>
+      </a:minorFont>
+    </a:fontScheme>
+    <a:fmtScheme name="Office">
+      <a:fillStyleLst>
+        <a:solidFill>
+          <a:schemeClr val="phClr"/>
+        </a:solidFill>
+        <a:gradFill rotWithShape="1">
+          <a:gsLst>
+            <a:gs pos="0">
+              <a:schemeClr val="phClr">
+                <a:lumMod val="110000"/>
+                <a:satMod val="105000"/>
+                <a:tint val="67000"/>
+              </a:schemeClr>
+            </a:gs>
+            <a:gs pos="50000">
+              <a:schemeClr val="phClr">
+                <a:lumMod val="105000"/>
+                <a:satMod val="103000"/>
+                <a:tint val="73000"/>
+              </a:schemeClr>
+            </a:gs>
+            <a:gs pos="100000">
+              <a:schemeClr val="phClr">
+                <a:lumMod val="105000"/>
+                <a:satMod val="109000"/>
+                <a:tint val="81000"/>
+              </a:schemeClr>
+            </a:gs>
+          </a:gsLst>
+          <a:lin ang="5400000" scaled="0"/>
+        </a:gradFill>
+        <a:gradFill rotWithShape="1">
+          <a:gsLst>
+            <a:gs pos="0">
+              <a:schemeClr val="phClr">
+                <a:satMod val="103000"/>
+                <a:lumMod val="102000"/>
+                <a:tint val="94000"/>
+              </a:schemeClr>
+            </a:gs>
+            <a:gs pos="50000">
+              <a:schemeClr val="phClr">
+                <a:satMod val="110000"/>
+                <a:lumMod val="100000"/>
+                <a:shade val="100000"/>
+              </a:schemeClr>
+            </a:gs>
+            <a:gs pos="100000">
+              <a:schemeClr val="phClr">
+                <a:lumMod val="99000"/>
+                <a:satMod val="120000"/>
+                <a:shade val="78000"/>
+              </a:schemeClr>
+            </a:gs>
+          </a:gsLst>
+          <a:lin ang="5400000" scaled="0"/>
+        </a:gradFill>
+      </a:fillStyleLst>
+      <a:lnStyleLst>
+        <a:ln w="12700" cap="flat" cmpd="sng" algn="ctr">
+          <a:solidFill>
+            <a:schemeClr val="phClr"/>
+          </a:solidFill>
+          <a:prstDash val="solid"/>
+          <a:miter lim="800000"/>
+        </a:ln>
+        <a:ln w="19050" cap="flat" cmpd="sng" algn="ctr">
+          <a:solidFill>
+            <a:schemeClr val="phClr"/>
+          </a:solidFill>
+          <a:prstDash val="solid"/>
+          <a:miter lim="800000"/>
+        </a:ln>
+        <a:ln w="25400" cap="flat" cmpd="sng" algn="ctr">
+          <a:solidFill>
+            <a:schemeClr val="phClr"/>
+          </a:solidFill>
+          <a:prstDash val="solid"/>
+          <a:miter lim="800000"/>
+        </a:ln>
+      </a:lnStyleLst>
+      <a:effectStyleLst>
+        <a:effectStyle>
+          <a:effectLst/>
+        </a:effectStyle>
+        <a:effectStyle>
+          <a:effectLst/>
+        </a:effectStyle>
+        <a:effectStyle>
+          <a:effectLst>
+            <a:outerShdw blurRad="57150" dist="19050" dir="5400000" algn="ctr" rotWithShape="0">
+              <a:srgbClr val="000000">
+                <a:alpha val="63000"/>
+              </a:srgbClr>
+            </a:outerShdw>
+          </a:effectLst>
+        </a:effectStyle>
+      </a:effectStyleLst>
+      <a:bgFillStyleLst>
+        <a:solidFill>
+          <a:schemeClr val="phClr"/>
+        </a:solidFill>
+        <a:solidFill>
+          <a:schemeClr val="phClr">
+            <a:tint val="95000"/>
+            <a:satMod val="170000"/>
+          </a:schemeClr>
+        </a:solidFill>
+        <a:gradFill rotWithShape="1">
+          <a:gsLst>
+            <a:gs pos="0">
+              <a:schemeClr val="phClr">
+                <a:tint val="93000"/>
+                <a:satMod val="150000"/>
+                <a:shade val="98000"/>
+                <a:lumMod val="102000"/>
+              </a:schemeClr>
+            </a:gs>
+            <a:gs pos="50000">
+              <a:schemeClr val="phClr">
+                <a:tint val="98000"/>
+                <a:satMod val="130000"/>
+                <a:shade val="90000"/>
+                <a:lumMod val="103000"/>
+              </a:schemeClr>
+            </a:gs>
+            <a:gs pos="100000">
+              <a:schemeClr val="phClr">
+                <a:shade val="63000"/>
+                <a:satMod val="120000"/>
+              </a:schemeClr>
+            </a:gs>
+          </a:gsLst>
+          <a:lin ang="5400000" scaled="0"/>
+        </a:gradFill>
+      </a:bgFillStyleLst>
+    </a:fmtScheme>
+  </a:themeElements>
+  <a:objectDefaults>
+    <a:lnDef>
+      <a:spPr/>
+      <a:bodyPr/>
+      <a:lstStyle/>
+      <a:style>
+        <a:lnRef idx="2">
+          <a:schemeClr val="accent1"/>
+        </a:lnRef>
+        <a:fillRef idx="0">
+          <a:schemeClr val="accent1"/>
+        </a:fillRef>
+        <a:effectRef idx="1">
+          <a:schemeClr val="accent1"/>
+        </a:effectRef>
+        <a:fontRef idx="minor">
+          <a:schemeClr val="tx1"/>
+        </a:fontRef>
+      </a:style>
+    </a:lnDef>
+  </a:objectDefaults>
+  <a:extraClrSchemeLst/>
+  <a:extLst>
+    <a:ext uri="{05A4C25C-085E-4340-85A3-A5531E510DB2}">
+      <thm15:themeFamily xmlns:thm15="http://schemas.microsoft.com/office/thememl/2012/main" name="Office Theme" id="{2E142A2C-CD16-42D6-873A-C26D2A0506FA}" vid="{1BDDFF52-6CD6-40A5-AB3C-68EB2F1E4D0A}"/>
+    </a:ext>
+  </a:extLst>
+</a:theme>
 </file>
</xml_diff>

<commit_message>
Add Phase 3 research plan, fix TAPS terminology, add overview slides (9 slides)
- CLAUDE.md: Add Phase 3 Minimum Intervention Learning Framework (MILF) section
  - Adapter + Knowledge Distillation architecture details
  - Noise Immunity Retention (NIR) metric proposal
  - Experimental roadmap for DNN PC
  - Fix terminology: 4kHz以上は「欠落」ではなく「収録時点から不在」(8kHz recording)
  - Add TAPS paper confirmation (arXiv:2502.11478 p.3) of 8kHz sampling rate
  - Add TAPS citation status (5 papers, mainly POSTECH group)
  - Add note on Whisper FT early stopping (epoch 3 = convergence, not overfitting)
- results/overview_slides.pptx: 7→9 slides
  - Slide 6: TAPS dataset structure and Fine-tuning design
  - Slide 9: TAPS dataset usage in other research (citation landscape)
- scripts/27_spectrum_analysis.py: minor update

Co-Authored-By: Claude Sonnet 4.6 <noreply@anthropic.com>
</commit_message>
<xml_diff>
--- a/results/overview_slides.pptx
+++ b/results/overview_slides.pptx
@@ -5,7 +5,7 @@
     <p:sldMasterId id="2147483648" r:id="rId1"/>
   </p:sldMasterIdLst>
   <p:notesMasterIdLst>
-    <p:notesMasterId r:id="rId9"/>
+    <p:notesMasterId r:id="rId11"/>
   </p:notesMasterIdLst>
   <p:sldIdLst>
     <p:sldId id="256" r:id="rId2"/>
@@ -13,8 +13,10 @@
     <p:sldId id="258" r:id="rId4"/>
     <p:sldId id="259" r:id="rId5"/>
     <p:sldId id="260" r:id="rId6"/>
-    <p:sldId id="261" r:id="rId7"/>
-    <p:sldId id="262" r:id="rId8"/>
+    <p:sldId id="263" r:id="rId7"/>
+    <p:sldId id="264" r:id="rId8"/>
+    <p:sldId id="261" r:id="rId9"/>
+    <p:sldId id="262" r:id="rId10"/>
   </p:sldIdLst>
   <p:sldSz cx="12188825" cy="6858000"/>
   <p:notesSz cx="6858000" cy="9144000"/>
@@ -214,7 +216,7 @@
           <a:p>
             <a:fld id="{84453EA3-22D2-3A49-9DD1-F001874AB3A2}" type="datetimeFigureOut">
               <a:rPr kumimoji="1" lang="ja-JP" altLang="en-US" smtClean="0"/>
-              <a:t>2026/4/15</a:t>
+              <a:t>2026/4/29</a:t>
             </a:fld>
             <a:endParaRPr kumimoji="1" lang="ja-JP" altLang="en-US"/>
           </a:p>
@@ -557,6 +559,114 @@
           <a:bodyPr/>
           <a:lstStyle/>
           <a:p>
+            <a:r>
+              <a:rPr kumimoji="1" lang="ja-JP" altLang="en-US"/>
+              <a:t> まとめ                                                                                                     </a:t>
+            </a:r>
+          </a:p>
+          <a:p>
+            <a:r>
+              <a:rPr kumimoji="1" lang="ja-JP" altLang="en-US"/>
+              <a:t>                  </a:t>
+            </a:r>
+          </a:p>
+          <a:p>
+            <a:r>
+              <a:rPr kumimoji="1" lang="ja-JP" altLang="en-US"/>
+              <a:t>  喉マイクの収録が</a:t>
+            </a:r>
+            <a:r>
+              <a:rPr kumimoji="1" lang="en-US" altLang="ja-JP" dirty="0"/>
+              <a:t>8kHz</a:t>
+            </a:r>
+            <a:r>
+              <a:rPr kumimoji="1" lang="ja-JP" altLang="en-US"/>
+              <a:t>で行われ、配布時に</a:t>
+            </a:r>
+            <a:r>
+              <a:rPr kumimoji="1" lang="en-US" altLang="ja-JP" dirty="0"/>
+              <a:t>16kHz</a:t>
+            </a:r>
+            <a:r>
+              <a:rPr kumimoji="1" lang="ja-JP" altLang="en-US"/>
+              <a:t>に水増しされた</a:t>
+            </a:r>
+          </a:p>
+          <a:p>
+            <a:r>
+              <a:rPr kumimoji="1" lang="ja-JP" altLang="en-US"/>
+              <a:t>  　→ </a:t>
+            </a:r>
+            <a:r>
+              <a:rPr kumimoji="1" lang="en-US" altLang="ja-JP" dirty="0"/>
+              <a:t>4kHz</a:t>
+            </a:r>
+            <a:r>
+              <a:rPr kumimoji="1" lang="ja-JP" altLang="en-US"/>
+              <a:t>以上は構造的に空っぽ                                                                               </a:t>
+            </a:r>
+          </a:p>
+          <a:p>
+            <a:r>
+              <a:rPr kumimoji="1" lang="ja-JP" altLang="en-US"/>
+              <a:t>  </a:t>
+            </a:r>
+            <a:r>
+              <a:rPr kumimoji="1" lang="en-US" altLang="ja-JP" dirty="0"/>
+              <a:t>   </a:t>
+            </a:r>
+            <a:r>
+              <a:rPr kumimoji="1" lang="ja-JP" altLang="en-US"/>
+              <a:t> → </a:t>
+            </a:r>
+            <a:r>
+              <a:rPr kumimoji="1" lang="en-US" altLang="ja-JP" dirty="0"/>
+              <a:t>GTCRN</a:t>
+            </a:r>
+            <a:r>
+              <a:rPr kumimoji="1" lang="ja-JP" altLang="en-US"/>
+              <a:t>がその空白を「処理すべき何か」と誤認識して逆効果の動作をした  </a:t>
+            </a:r>
+            <a:endParaRPr kumimoji="1" lang="en-US" altLang="ja-JP" dirty="0"/>
+          </a:p>
+          <a:p>
+            <a:endParaRPr kumimoji="1" lang="en-US" altLang="ja-JP" dirty="0"/>
+          </a:p>
+          <a:p>
+            <a:pPr marL="0" marR="0" lvl="0" indent="0" algn="l" defTabSz="914400" rtl="0" eaLnBrk="1" fontAlgn="auto" latinLnBrk="0" hangingPunct="1">
+              <a:lnSpc>
+                <a:spcPct val="100000"/>
+              </a:lnSpc>
+              <a:spcBef>
+                <a:spcPts val="0"/>
+              </a:spcBef>
+              <a:spcAft>
+                <a:spcPts val="0"/>
+              </a:spcAft>
+              <a:buClrTx/>
+              <a:buSzTx/>
+              <a:buFontTx/>
+              <a:buNone/>
+              <a:tabLst/>
+              <a:defRPr/>
+            </a:pPr>
+            <a:r>
+              <a:rPr kumimoji="1" lang="ja-JP" altLang="en-US" sz="1200" kern="1200">
+                <a:solidFill>
+                  <a:schemeClr val="tx1"/>
+                </a:solidFill>
+                <a:effectLst/>
+                <a:latin typeface="+mn-lt"/>
+                <a:ea typeface="+mn-ea"/>
+                <a:cs typeface="+mn-cs"/>
+              </a:rPr>
+              <a:t> これが「三重パラドックスの機構」の核心部分です。 </a:t>
+            </a:r>
+          </a:p>
+          <a:p>
+            <a:endParaRPr kumimoji="1" lang="ja-JP" altLang="en-US"/>
+          </a:p>
+          <a:p>
             <a:endParaRPr kumimoji="1" lang="ja-JP" altLang="en-US"/>
           </a:p>
         </p:txBody>
@@ -588,6 +698,450 @@
     <p:extLst>
       <p:ext uri="{BB962C8B-B14F-4D97-AF65-F5344CB8AC3E}">
         <p14:creationId xmlns:p14="http://schemas.microsoft.com/office/powerpoint/2010/main" val="1796751383"/>
+      </p:ext>
+    </p:extLst>
+  </p:cSld>
+  <p:clrMapOvr>
+    <a:masterClrMapping/>
+  </p:clrMapOvr>
+</p:notes>
+</file>
+
+<file path=ppt/notesSlides/notesSlide2.xml><?xml version="1.0" encoding="utf-8"?>
+<p:notes xmlns:a="http://schemas.openxmlformats.org/drawingml/2006/main" xmlns:r="http://schemas.openxmlformats.org/officeDocument/2006/relationships" xmlns:p="http://schemas.openxmlformats.org/presentationml/2006/main">
+  <p:cSld>
+    <p:spTree>
+      <p:nvGrpSpPr>
+        <p:cNvPr id="1" name=""/>
+        <p:cNvGrpSpPr/>
+        <p:nvPr/>
+      </p:nvGrpSpPr>
+      <p:grpSpPr>
+        <a:xfrm>
+          <a:off x="0" y="0"/>
+          <a:ext cx="0" cy="0"/>
+          <a:chOff x="0" y="0"/>
+          <a:chExt cx="0" cy="0"/>
+        </a:xfrm>
+      </p:grpSpPr>
+      <p:sp>
+        <p:nvSpPr>
+          <p:cNvPr id="2" name="スライド イメージ プレースホルダー 1"/>
+          <p:cNvSpPr>
+            <a:spLocks noGrp="1" noRot="1" noChangeAspect="1"/>
+          </p:cNvSpPr>
+          <p:nvPr>
+            <p:ph type="sldImg"/>
+          </p:nvPr>
+        </p:nvSpPr>
+        <p:spPr/>
+      </p:sp>
+      <p:sp>
+        <p:nvSpPr>
+          <p:cNvPr id="3" name="ノート プレースホルダー 2"/>
+          <p:cNvSpPr>
+            <a:spLocks noGrp="1"/>
+          </p:cNvSpPr>
+          <p:nvPr>
+            <p:ph type="body" idx="1"/>
+          </p:nvPr>
+        </p:nvSpPr>
+        <p:spPr/>
+        <p:txBody>
+          <a:bodyPr/>
+          <a:lstStyle/>
+          <a:p>
+            <a:r>
+              <a:rPr kumimoji="1" lang="ja-JP" altLang="en-US" sz="1200" b="1" kern="1200">
+                <a:solidFill>
+                  <a:schemeClr val="tx1"/>
+                </a:solidFill>
+                <a:effectLst/>
+                <a:latin typeface="+mn-lt"/>
+                <a:ea typeface="+mn-ea"/>
+                <a:cs typeface="+mn-cs"/>
+              </a:rPr>
+              <a:t>今回の</a:t>
+            </a:r>
+            <a:r>
+              <a:rPr kumimoji="1" lang="en-US" altLang="ja-JP" sz="1200" b="1" kern="1200" dirty="0">
+                <a:solidFill>
+                  <a:schemeClr val="tx1"/>
+                </a:solidFill>
+                <a:effectLst/>
+                <a:latin typeface="+mn-lt"/>
+                <a:ea typeface="+mn-ea"/>
+                <a:cs typeface="+mn-cs"/>
+              </a:rPr>
+              <a:t>FT</a:t>
+            </a:r>
+            <a:r>
+              <a:rPr kumimoji="1" lang="ja-JP" altLang="en-US" sz="1200" b="1" kern="1200">
+                <a:solidFill>
+                  <a:schemeClr val="tx1"/>
+                </a:solidFill>
+                <a:effectLst/>
+                <a:latin typeface="+mn-lt"/>
+                <a:ea typeface="+mn-ea"/>
+                <a:cs typeface="+mn-cs"/>
+              </a:rPr>
+              <a:t>の学習設定</a:t>
+            </a:r>
+            <a:endParaRPr kumimoji="1" lang="ja-JP" altLang="en-US" sz="1200" kern="1200">
+              <a:solidFill>
+                <a:schemeClr val="tx1"/>
+              </a:solidFill>
+              <a:effectLst/>
+              <a:latin typeface="+mn-lt"/>
+              <a:ea typeface="+mn-ea"/>
+              <a:cs typeface="+mn-cs"/>
+            </a:endParaRPr>
+          </a:p>
+          <a:p>
+            <a:br>
+              <a:rPr kumimoji="1" lang="ja-JP" altLang="en-US" sz="1200" kern="1200">
+                <a:solidFill>
+                  <a:schemeClr val="tx1"/>
+                </a:solidFill>
+                <a:effectLst/>
+                <a:latin typeface="+mn-lt"/>
+                <a:ea typeface="+mn-ea"/>
+                <a:cs typeface="+mn-cs"/>
+              </a:rPr>
+            </a:br>
+            <a:endParaRPr kumimoji="1" lang="ja-JP" altLang="en-US" sz="1200" kern="1200">
+              <a:solidFill>
+                <a:schemeClr val="tx1"/>
+              </a:solidFill>
+              <a:effectLst/>
+              <a:latin typeface="+mn-lt"/>
+              <a:ea typeface="+mn-ea"/>
+              <a:cs typeface="+mn-cs"/>
+            </a:endParaRPr>
+          </a:p>
+          <a:p>
+            <a:r>
+              <a:rPr kumimoji="1" lang="ja-JP" altLang="en-US" sz="1200" kern="1200">
+                <a:solidFill>
+                  <a:schemeClr val="tx1"/>
+                </a:solidFill>
+                <a:effectLst/>
+                <a:latin typeface="+mn-lt"/>
+                <a:ea typeface="+mn-ea"/>
+                <a:cs typeface="+mn-cs"/>
+              </a:rPr>
+              <a:t>  入力</a:t>
+            </a:r>
+            <a:r>
+              <a:rPr kumimoji="1" lang="en-US" altLang="ja-JP" sz="1200" kern="1200" dirty="0">
+                <a:solidFill>
+                  <a:schemeClr val="tx1"/>
+                </a:solidFill>
+                <a:effectLst/>
+                <a:latin typeface="+mn-lt"/>
+                <a:ea typeface="+mn-ea"/>
+                <a:cs typeface="+mn-cs"/>
+              </a:rPr>
+              <a:t>: </a:t>
+            </a:r>
+            <a:r>
+              <a:rPr kumimoji="1" lang="ja-JP" altLang="en-US" sz="1200" kern="1200">
+                <a:solidFill>
+                  <a:schemeClr val="tx1"/>
+                </a:solidFill>
+                <a:effectLst/>
+                <a:latin typeface="+mn-lt"/>
+                <a:ea typeface="+mn-ea"/>
+                <a:cs typeface="+mn-cs"/>
+              </a:rPr>
+              <a:t>喉マイク音声</a:t>
+            </a:r>
+          </a:p>
+          <a:p>
+            <a:r>
+              <a:rPr kumimoji="1" lang="ja-JP" altLang="en-US" sz="1200" kern="1200">
+                <a:solidFill>
+                  <a:schemeClr val="tx1"/>
+                </a:solidFill>
+                <a:effectLst/>
+                <a:latin typeface="+mn-lt"/>
+                <a:ea typeface="+mn-ea"/>
+                <a:cs typeface="+mn-cs"/>
+              </a:rPr>
+              <a:t>  正解ラベル</a:t>
+            </a:r>
+            <a:r>
+              <a:rPr kumimoji="1" lang="en-US" altLang="ja-JP" sz="1200" kern="1200" dirty="0">
+                <a:solidFill>
+                  <a:schemeClr val="tx1"/>
+                </a:solidFill>
+                <a:effectLst/>
+                <a:latin typeface="+mn-lt"/>
+                <a:ea typeface="+mn-ea"/>
+                <a:cs typeface="+mn-cs"/>
+              </a:rPr>
+              <a:t>: </a:t>
+            </a:r>
+            <a:r>
+              <a:rPr kumimoji="1" lang="ja-JP" altLang="en-US" sz="1200" kern="1200">
+                <a:solidFill>
+                  <a:schemeClr val="tx1"/>
+                </a:solidFill>
+                <a:effectLst/>
+                <a:latin typeface="+mn-lt"/>
+                <a:ea typeface="+mn-ea"/>
+                <a:cs typeface="+mn-cs"/>
+              </a:rPr>
+              <a:t>韓国語テキスト（</a:t>
+            </a:r>
+            <a:r>
+              <a:rPr kumimoji="1" lang="en-US" altLang="ja-JP" sz="1200" kern="1200" dirty="0" err="1">
+                <a:solidFill>
+                  <a:schemeClr val="tx1"/>
+                </a:solidFill>
+                <a:effectLst/>
+                <a:latin typeface="+mn-lt"/>
+                <a:ea typeface="+mn-ea"/>
+                <a:cs typeface="+mn-cs"/>
+              </a:rPr>
+              <a:t>metadata_train.csv</a:t>
+            </a:r>
+            <a:r>
+              <a:rPr kumimoji="1" lang="ja-JP" altLang="en-US" sz="1200" kern="1200">
+                <a:solidFill>
+                  <a:schemeClr val="tx1"/>
+                </a:solidFill>
+                <a:effectLst/>
+                <a:latin typeface="+mn-lt"/>
+                <a:ea typeface="+mn-ea"/>
+                <a:cs typeface="+mn-cs"/>
+              </a:rPr>
+              <a:t>の</a:t>
+            </a:r>
+            <a:r>
+              <a:rPr kumimoji="1" lang="en-US" altLang="ja-JP" sz="1200" kern="1200" dirty="0">
+                <a:solidFill>
+                  <a:schemeClr val="tx1"/>
+                </a:solidFill>
+                <a:effectLst/>
+                <a:latin typeface="+mn-lt"/>
+                <a:ea typeface="+mn-ea"/>
+                <a:cs typeface="+mn-cs"/>
+              </a:rPr>
+              <a:t>text</a:t>
+            </a:r>
+            <a:r>
+              <a:rPr kumimoji="1" lang="ja-JP" altLang="en-US" sz="1200" kern="1200">
+                <a:solidFill>
+                  <a:schemeClr val="tx1"/>
+                </a:solidFill>
+                <a:effectLst/>
+                <a:latin typeface="+mn-lt"/>
+                <a:ea typeface="+mn-ea"/>
+                <a:cs typeface="+mn-cs"/>
+              </a:rPr>
+              <a:t>列）</a:t>
+            </a:r>
+          </a:p>
+          <a:p>
+            <a:r>
+              <a:rPr kumimoji="1" lang="ja-JP" altLang="en-US" sz="1200" kern="1200">
+                <a:solidFill>
+                  <a:schemeClr val="tx1"/>
+                </a:solidFill>
+                <a:effectLst/>
+                <a:latin typeface="+mn-lt"/>
+                <a:ea typeface="+mn-ea"/>
+                <a:cs typeface="+mn-cs"/>
+              </a:rPr>
+              <a:t>  損失</a:t>
+            </a:r>
+            <a:r>
+              <a:rPr kumimoji="1" lang="en-US" altLang="ja-JP" sz="1200" kern="1200" dirty="0">
+                <a:solidFill>
+                  <a:schemeClr val="tx1"/>
+                </a:solidFill>
+                <a:effectLst/>
+                <a:latin typeface="+mn-lt"/>
+                <a:ea typeface="+mn-ea"/>
+                <a:cs typeface="+mn-cs"/>
+              </a:rPr>
+              <a:t>: Cross-entropy loss</a:t>
+            </a:r>
+            <a:r>
+              <a:rPr kumimoji="1" lang="ja-JP" altLang="en-US" sz="1200" kern="1200">
+                <a:solidFill>
+                  <a:schemeClr val="tx1"/>
+                </a:solidFill>
+                <a:effectLst/>
+                <a:latin typeface="+mn-lt"/>
+                <a:ea typeface="+mn-ea"/>
+                <a:cs typeface="+mn-cs"/>
+              </a:rPr>
+              <a:t>（予測トークン </a:t>
+            </a:r>
+            <a:r>
+              <a:rPr kumimoji="1" lang="en-US" altLang="ja-JP" sz="1200" kern="1200" dirty="0">
+                <a:solidFill>
+                  <a:schemeClr val="tx1"/>
+                </a:solidFill>
+                <a:effectLst/>
+                <a:latin typeface="+mn-lt"/>
+                <a:ea typeface="+mn-ea"/>
+                <a:cs typeface="+mn-cs"/>
+              </a:rPr>
+              <a:t>vs </a:t>
+            </a:r>
+            <a:r>
+              <a:rPr kumimoji="1" lang="ja-JP" altLang="en-US" sz="1200" kern="1200">
+                <a:solidFill>
+                  <a:schemeClr val="tx1"/>
+                </a:solidFill>
+                <a:effectLst/>
+                <a:latin typeface="+mn-lt"/>
+                <a:ea typeface="+mn-ea"/>
+                <a:cs typeface="+mn-cs"/>
+              </a:rPr>
+              <a:t>正解トークン）</a:t>
+            </a:r>
+          </a:p>
+          <a:p>
+            <a:br>
+              <a:rPr kumimoji="1" lang="ja-JP" altLang="en-US" sz="1200" kern="1200">
+                <a:solidFill>
+                  <a:schemeClr val="tx1"/>
+                </a:solidFill>
+                <a:effectLst/>
+                <a:latin typeface="+mn-lt"/>
+                <a:ea typeface="+mn-ea"/>
+                <a:cs typeface="+mn-cs"/>
+              </a:rPr>
+            </a:br>
+            <a:endParaRPr kumimoji="1" lang="ja-JP" altLang="en-US" sz="1200" kern="1200">
+              <a:solidFill>
+                <a:schemeClr val="tx1"/>
+              </a:solidFill>
+              <a:effectLst/>
+              <a:latin typeface="+mn-lt"/>
+              <a:ea typeface="+mn-ea"/>
+              <a:cs typeface="+mn-cs"/>
+            </a:endParaRPr>
+          </a:p>
+          <a:p>
+            <a:r>
+              <a:rPr kumimoji="1" lang="ja-JP" altLang="en-US" sz="1200" kern="1200">
+                <a:solidFill>
+                  <a:schemeClr val="tx1"/>
+                </a:solidFill>
+                <a:effectLst/>
+                <a:latin typeface="+mn-lt"/>
+                <a:ea typeface="+mn-ea"/>
+                <a:cs typeface="+mn-cs"/>
+              </a:rPr>
+              <a:t>  </a:t>
+            </a:r>
+            <a:r>
+              <a:rPr kumimoji="1" lang="ja-JP" altLang="en-US" sz="1200" b="1" kern="1200">
+                <a:solidFill>
+                  <a:schemeClr val="tx1"/>
+                </a:solidFill>
+                <a:effectLst/>
+                <a:latin typeface="+mn-lt"/>
+                <a:ea typeface="+mn-ea"/>
+                <a:cs typeface="+mn-cs"/>
+              </a:rPr>
+              <a:t>入力・正解ラベルのペアが存在する</a:t>
+            </a:r>
+            <a:r>
+              <a:rPr kumimoji="1" lang="ja-JP" altLang="en-US" sz="1200" kern="1200">
+                <a:solidFill>
+                  <a:schemeClr val="tx1"/>
+                </a:solidFill>
+                <a:effectLst/>
+                <a:latin typeface="+mn-lt"/>
+                <a:ea typeface="+mn-ea"/>
+                <a:cs typeface="+mn-cs"/>
+              </a:rPr>
+              <a:t> </a:t>
+            </a:r>
+            <a:r>
+              <a:rPr kumimoji="1" lang="ja-JP" altLang="en-US" sz="1200" b="1" kern="1200">
+                <a:solidFill>
+                  <a:schemeClr val="tx1"/>
+                </a:solidFill>
+                <a:effectLst/>
+                <a:latin typeface="+mn-lt"/>
+                <a:ea typeface="+mn-ea"/>
+                <a:cs typeface="+mn-cs"/>
+              </a:rPr>
+              <a:t>→</a:t>
+            </a:r>
+            <a:r>
+              <a:rPr kumimoji="1" lang="ja-JP" altLang="en-US" sz="1200" kern="1200">
+                <a:solidFill>
+                  <a:schemeClr val="tx1"/>
+                </a:solidFill>
+                <a:effectLst/>
+                <a:latin typeface="+mn-lt"/>
+                <a:ea typeface="+mn-ea"/>
+                <a:cs typeface="+mn-cs"/>
+              </a:rPr>
+              <a:t> </a:t>
+            </a:r>
+            <a:r>
+              <a:rPr kumimoji="1" lang="ja-JP" altLang="en-US" sz="1200" b="1" kern="1200">
+                <a:solidFill>
+                  <a:schemeClr val="tx1"/>
+                </a:solidFill>
+                <a:effectLst/>
+                <a:latin typeface="+mn-lt"/>
+                <a:ea typeface="+mn-ea"/>
+                <a:cs typeface="+mn-cs"/>
+              </a:rPr>
+              <a:t>教師あり学習</a:t>
+            </a:r>
+            <a:r>
+              <a:rPr kumimoji="1" lang="ja-JP" altLang="en-US" sz="1200" kern="1200">
+                <a:solidFill>
+                  <a:schemeClr val="tx1"/>
+                </a:solidFill>
+                <a:effectLst/>
+                <a:latin typeface="+mn-lt"/>
+                <a:ea typeface="+mn-ea"/>
+                <a:cs typeface="+mn-cs"/>
+              </a:rPr>
+              <a:t>です。</a:t>
+            </a:r>
+          </a:p>
+        </p:txBody>
+      </p:sp>
+      <p:sp>
+        <p:nvSpPr>
+          <p:cNvPr id="4" name="スライド番号プレースホルダー 3"/>
+          <p:cNvSpPr>
+            <a:spLocks noGrp="1"/>
+          </p:cNvSpPr>
+          <p:nvPr>
+            <p:ph type="sldNum" sz="quarter" idx="5"/>
+          </p:nvPr>
+        </p:nvSpPr>
+        <p:spPr/>
+        <p:txBody>
+          <a:bodyPr/>
+          <a:lstStyle/>
+          <a:p>
+            <a:fld id="{599649C3-9C0A-BE4B-BB26-BD3C227AA350}" type="slidenum">
+              <a:rPr kumimoji="1" lang="ja-JP" altLang="en-US" smtClean="0"/>
+              <a:t>6</a:t>
+            </a:fld>
+            <a:endParaRPr kumimoji="1" lang="ja-JP" altLang="en-US"/>
+          </a:p>
+        </p:txBody>
+      </p:sp>
+    </p:spTree>
+    <p:extLst>
+      <p:ext uri="{BB962C8B-B14F-4D97-AF65-F5344CB8AC3E}">
+        <p14:creationId xmlns:p14="http://schemas.microsoft.com/office/powerpoint/2010/main" val="2757556457"/>
       </p:ext>
     </p:extLst>
   </p:cSld>
@@ -776,7 +1330,7 @@
           <a:p>
             <a:fld id="{5BCAD085-E8A6-8845-BD4E-CB4CCA059FC4}" type="datetimeFigureOut">
               <a:rPr lang="en-US" smtClean="0"/>
-              <a:t>4/15/26</a:t>
+              <a:t>4/29/26</a:t>
             </a:fld>
             <a:endParaRPr lang="en-US"/>
           </a:p>
@@ -944,7 +1498,7 @@
           <a:p>
             <a:fld id="{5BCAD085-E8A6-8845-BD4E-CB4CCA059FC4}" type="datetimeFigureOut">
               <a:rPr lang="en-US" smtClean="0"/>
-              <a:t>4/15/26</a:t>
+              <a:t>4/29/26</a:t>
             </a:fld>
             <a:endParaRPr lang="en-US"/>
           </a:p>
@@ -1122,7 +1676,7 @@
           <a:p>
             <a:fld id="{5BCAD085-E8A6-8845-BD4E-CB4CCA059FC4}" type="datetimeFigureOut">
               <a:rPr lang="en-US" smtClean="0"/>
-              <a:t>4/15/26</a:t>
+              <a:t>4/29/26</a:t>
             </a:fld>
             <a:endParaRPr lang="en-US"/>
           </a:p>
@@ -1290,7 +1844,7 @@
           <a:p>
             <a:fld id="{5BCAD085-E8A6-8845-BD4E-CB4CCA059FC4}" type="datetimeFigureOut">
               <a:rPr lang="en-US" smtClean="0"/>
-              <a:t>4/15/26</a:t>
+              <a:t>4/29/26</a:t>
             </a:fld>
             <a:endParaRPr lang="en-US"/>
           </a:p>
@@ -1535,7 +2089,7 @@
           <a:p>
             <a:fld id="{5BCAD085-E8A6-8845-BD4E-CB4CCA059FC4}" type="datetimeFigureOut">
               <a:rPr lang="en-US" smtClean="0"/>
-              <a:t>4/15/26</a:t>
+              <a:t>4/29/26</a:t>
             </a:fld>
             <a:endParaRPr lang="en-US"/>
           </a:p>
@@ -1820,7 +2374,7 @@
           <a:p>
             <a:fld id="{5BCAD085-E8A6-8845-BD4E-CB4CCA059FC4}" type="datetimeFigureOut">
               <a:rPr lang="en-US" smtClean="0"/>
-              <a:t>4/15/26</a:t>
+              <a:t>4/29/26</a:t>
             </a:fld>
             <a:endParaRPr lang="en-US"/>
           </a:p>
@@ -2239,7 +2793,7 @@
           <a:p>
             <a:fld id="{5BCAD085-E8A6-8845-BD4E-CB4CCA059FC4}" type="datetimeFigureOut">
               <a:rPr lang="en-US" smtClean="0"/>
-              <a:t>4/15/26</a:t>
+              <a:t>4/29/26</a:t>
             </a:fld>
             <a:endParaRPr lang="en-US"/>
           </a:p>
@@ -2356,7 +2910,7 @@
           <a:p>
             <a:fld id="{5BCAD085-E8A6-8845-BD4E-CB4CCA059FC4}" type="datetimeFigureOut">
               <a:rPr lang="en-US" smtClean="0"/>
-              <a:t>4/15/26</a:t>
+              <a:t>4/29/26</a:t>
             </a:fld>
             <a:endParaRPr lang="en-US"/>
           </a:p>
@@ -2451,7 +3005,7 @@
           <a:p>
             <a:fld id="{5BCAD085-E8A6-8845-BD4E-CB4CCA059FC4}" type="datetimeFigureOut">
               <a:rPr lang="en-US" smtClean="0"/>
-              <a:t>4/15/26</a:t>
+              <a:t>4/29/26</a:t>
             </a:fld>
             <a:endParaRPr lang="en-US"/>
           </a:p>
@@ -2726,7 +3280,7 @@
           <a:p>
             <a:fld id="{5BCAD085-E8A6-8845-BD4E-CB4CCA059FC4}" type="datetimeFigureOut">
               <a:rPr lang="en-US" smtClean="0"/>
-              <a:t>4/15/26</a:t>
+              <a:t>4/29/26</a:t>
             </a:fld>
             <a:endParaRPr lang="en-US"/>
           </a:p>
@@ -2978,7 +3532,7 @@
           <a:p>
             <a:fld id="{5BCAD085-E8A6-8845-BD4E-CB4CCA059FC4}" type="datetimeFigureOut">
               <a:rPr lang="en-US" smtClean="0"/>
-              <a:t>4/15/26</a:t>
+              <a:t>4/29/26</a:t>
             </a:fld>
             <a:endParaRPr lang="en-US"/>
           </a:p>
@@ -3189,7 +3743,7 @@
           <a:p>
             <a:fld id="{5BCAD085-E8A6-8845-BD4E-CB4CCA059FC4}" type="datetimeFigureOut">
               <a:rPr lang="en-US" smtClean="0"/>
-              <a:t>4/15/26</a:t>
+              <a:t>4/29/26</a:t>
             </a:fld>
             <a:endParaRPr lang="en-US"/>
           </a:p>
@@ -7834,7 +8388,7 @@
                   <a:srgbClr val="FFFFFF"/>
                 </a:solidFill>
               </a:rPr>
-              <a:t>解決策と結論：「音声を直す」より「ASRを慣れさせる」</a:t>
+              <a:t>TAPSデータセット構造とFine-tuning設計</a:t>
             </a:r>
           </a:p>
         </p:txBody>
@@ -7847,8 +8401,8 @@
         </p:nvSpPr>
         <p:spPr>
           <a:xfrm>
-            <a:off x="11247120" y="411480"/>
-            <a:ext cx="822960" cy="365760"/>
+            <a:off x="11100000" y="411480"/>
+            <a:ext cx="900000" cy="365760"/>
           </a:xfrm>
           <a:prstGeom prst="rect">
             <a:avLst/>
@@ -7868,7 +8422,7 @@
                   <a:srgbClr val="78909C"/>
                 </a:solidFill>
               </a:rPr>
-              <a:t>6 / 5</a:t>
+              <a:t>補足</a:t>
             </a:r>
           </a:p>
         </p:txBody>
@@ -7960,7 +8514,51 @@
         <p:spPr>
           <a:xfrm>
             <a:off x="365760" y="1325880"/>
-            <a:ext cx="5394960" cy="3200400"/>
+            <a:ext cx="5486400" cy="4389120"/>
+          </a:xfrm>
+          <a:prstGeom prst="rect">
+            <a:avLst/>
+          </a:prstGeom>
+          <a:solidFill>
+            <a:srgbClr val="E3F2FD"/>
+          </a:solidFill>
+          <a:ln>
+            <a:noFill/>
+          </a:ln>
+        </p:spPr>
+        <p:style>
+          <a:lnRef idx="1">
+            <a:schemeClr val="accent1"/>
+          </a:lnRef>
+          <a:fillRef idx="3">
+            <a:schemeClr val="accent1"/>
+          </a:fillRef>
+          <a:effectRef idx="2">
+            <a:schemeClr val="accent1"/>
+          </a:effectRef>
+          <a:fontRef idx="minor">
+            <a:schemeClr val="lt1"/>
+          </a:fontRef>
+        </p:style>
+        <p:txBody>
+          <a:bodyPr rtlCol="0" anchor="ctr"/>
+          <a:lstStyle/>
+          <a:p>
+            <a:pPr algn="ctr"/>
+            <a:endParaRPr/>
+          </a:p>
+        </p:txBody>
+      </p:sp>
+      <p:sp>
+        <p:nvSpPr>
+          <p:cNvPr id="8" name="Rectangle 7"/>
+          <p:cNvSpPr/>
+          <p:nvPr/>
+        </p:nvSpPr>
+        <p:spPr>
+          <a:xfrm>
+            <a:off x="6336792" y="1325880"/>
+            <a:ext cx="5486400" cy="4389120"/>
           </a:xfrm>
           <a:prstGeom prst="rect">
             <a:avLst/>
@@ -7997,97 +8595,72 @@
       </p:sp>
       <p:sp>
         <p:nvSpPr>
-          <p:cNvPr id="8" name="TextBox 7"/>
+          <p:cNvPr id="9" name="TextBox 8"/>
           <p:cNvSpPr txBox="1"/>
           <p:nvPr/>
         </p:nvSpPr>
         <p:spPr>
           <a:xfrm>
             <a:off x="502920" y="1417320"/>
-            <a:ext cx="5120640" cy="365760"/>
-          </a:xfrm>
-          <a:prstGeom prst="rect">
-            <a:avLst/>
-          </a:prstGeom>
-          <a:noFill/>
-        </p:spPr>
-        <p:txBody>
-          <a:bodyPr wrap="square">
-            <a:spAutoFit/>
-          </a:bodyPr>
-          <a:lstStyle/>
-          <a:p>
-            <a:pPr algn="l"/>
-            <a:r>
-              <a:rPr sz="1400" b="1">
-                <a:solidFill>
-                  <a:srgbClr val="2E7D32"/>
-                </a:solidFill>
-              </a:rPr>
-              <a:t>解決策：Whisper ファインチューニング（FT）</a:t>
-            </a:r>
-          </a:p>
-        </p:txBody>
-      </p:sp>
-      <p:sp>
-        <p:nvSpPr>
-          <p:cNvPr id="9" name="TextBox 8"/>
-          <p:cNvSpPr txBox="1"/>
-          <p:nvPr/>
-        </p:nvSpPr>
-        <p:spPr>
-          <a:xfrm>
-            <a:off x="548640" y="1874519"/>
-            <a:ext cx="5120640" cy="502920"/>
-          </a:xfrm>
-          <a:prstGeom prst="rect">
-            <a:avLst/>
-          </a:prstGeom>
-          <a:noFill/>
-        </p:spPr>
-        <p:txBody>
-          <a:bodyPr wrap="square">
-            <a:spAutoFit/>
-          </a:bodyPr>
-          <a:lstStyle/>
-          <a:p>
-            <a:pPr algn="l"/>
-            <a:r>
-              <a:rPr sz="1300" b="0">
-                <a:solidFill>
-                  <a:srgbClr val="212121"/>
-                </a:solidFill>
-              </a:rPr>
-              <a:t>喉マイク音声 4,000発話でWhisper smallを再学習
-→ ASRモデルが喉マイクの音響特性を直接学習</a:t>
-            </a:r>
-          </a:p>
-        </p:txBody>
-      </p:sp>
-      <p:pic>
-        <p:nvPicPr>
-          <p:cNvPr id="10" name="Picture 9" descr="image.png"/>
-          <p:cNvPicPr>
-            <a:picLocks noChangeAspect="1"/>
-          </p:cNvPicPr>
-          <p:nvPr/>
-        </p:nvPicPr>
-        <p:blipFill>
-          <a:blip r:embed="rId2"/>
-          <a:stretch>
-            <a:fillRect/>
-          </a:stretch>
-        </p:blipFill>
-        <p:spPr>
-          <a:xfrm>
-            <a:off x="457200" y="2423160"/>
-            <a:ext cx="4846320" cy="1963595"/>
-          </a:xfrm>
-          <a:prstGeom prst="rect">
-            <a:avLst/>
-          </a:prstGeom>
-        </p:spPr>
-      </p:pic>
+            <a:ext cx="5212080" cy="411480"/>
+          </a:xfrm>
+          <a:prstGeom prst="rect">
+            <a:avLst/>
+          </a:prstGeom>
+          <a:noFill/>
+        </p:spPr>
+        <p:txBody>
+          <a:bodyPr wrap="square">
+            <a:spAutoFit/>
+          </a:bodyPr>
+          <a:lstStyle/>
+          <a:p>
+            <a:pPr algn="l"/>
+            <a:r>
+              <a:rPr sz="1500" b="1">
+                <a:solidFill>
+                  <a:srgbClr val="1A237E"/>
+                </a:solidFill>
+              </a:rPr>
+              <a:t>TAPSデータセット構造</a:t>
+            </a:r>
+          </a:p>
+        </p:txBody>
+      </p:sp>
+      <p:sp>
+        <p:nvSpPr>
+          <p:cNvPr id="10" name="TextBox 9"/>
+          <p:cNvSpPr txBox="1"/>
+          <p:nvPr/>
+        </p:nvSpPr>
+        <p:spPr>
+          <a:xfrm>
+            <a:off x="502920" y="1828800"/>
+            <a:ext cx="5212080" cy="274320"/>
+          </a:xfrm>
+          <a:prstGeom prst="rect">
+            <a:avLst/>
+          </a:prstGeom>
+          <a:noFill/>
+        </p:spPr>
+        <p:txBody>
+          <a:bodyPr wrap="square">
+            <a:spAutoFit/>
+          </a:bodyPr>
+          <a:lstStyle/>
+          <a:p>
+            <a:pPr algn="l"/>
+            <a:r>
+              <a:rPr sz="1000" b="0">
+                <a:solidFill>
+                  <a:srgbClr val="546E7A"/>
+                </a:solidFill>
+              </a:rPr>
+              <a:t>Throat and Acoustic Pairing Speech Dataset（韓国語・60名・6,000発話）</a:t>
+            </a:r>
+          </a:p>
+        </p:txBody>
+      </p:sp>
       <p:sp>
         <p:nvSpPr>
           <p:cNvPr id="11" name="Rectangle 10"/>
@@ -8096,14 +8669,14 @@
         </p:nvSpPr>
         <p:spPr>
           <a:xfrm>
-            <a:off x="6126480" y="1325880"/>
-            <a:ext cx="5669280" cy="3200400"/>
+            <a:off x="502920" y="2194560"/>
+            <a:ext cx="548640" cy="685800"/>
           </a:xfrm>
           <a:prstGeom prst="rect">
             <a:avLst/>
           </a:prstGeom>
           <a:solidFill>
-            <a:srgbClr val="F5F5F5"/>
+            <a:srgbClr val="1565C0"/>
           </a:solidFill>
           <a:ln>
             <a:noFill/>
@@ -8128,7 +8701,14 @@
           <a:lstStyle/>
           <a:p>
             <a:pPr algn="ctr"/>
-            <a:endParaRPr/>
+            <a:r>
+              <a:rPr sz="1200" b="1">
+                <a:solidFill>
+                  <a:srgbClr val="FFFFFF"/>
+                </a:solidFill>
+              </a:rPr>
+              <a:t>train</a:t>
+            </a:r>
           </a:p>
         </p:txBody>
       </p:sp>
@@ -8140,106 +8720,59 @@
         </p:nvSpPr>
         <p:spPr>
           <a:xfrm>
-            <a:off x="6263640" y="1417320"/>
-            <a:ext cx="5394960" cy="365760"/>
-          </a:xfrm>
-          <a:prstGeom prst="rect">
-            <a:avLst/>
-          </a:prstGeom>
-          <a:noFill/>
-        </p:spPr>
-        <p:txBody>
-          <a:bodyPr wrap="square">
-            <a:spAutoFit/>
-          </a:bodyPr>
-          <a:lstStyle/>
-          <a:p>
-            <a:pPr algn="l"/>
-            <a:r>
-              <a:rPr sz="1400" b="1">
-                <a:solidFill>
-                  <a:srgbClr val="1A237E"/>
-                </a:solidFill>
-              </a:rPr>
-              <a:t>補足：SE × FT の組み合わせ比較</a:t>
-            </a:r>
-          </a:p>
-        </p:txBody>
-      </p:sp>
-      <p:pic>
-        <p:nvPicPr>
-          <p:cNvPr id="13" name="Picture 12" descr="image.png"/>
-          <p:cNvPicPr>
-            <a:picLocks noChangeAspect="1"/>
-          </p:cNvPicPr>
-          <p:nvPr/>
-        </p:nvPicPr>
-        <p:blipFill>
-          <a:blip r:embed="rId3"/>
-          <a:stretch>
-            <a:fillRect/>
-          </a:stretch>
-        </p:blipFill>
-        <p:spPr>
-          <a:xfrm>
-            <a:off x="6217920" y="1874519"/>
-            <a:ext cx="5394960" cy="3146361"/>
-          </a:xfrm>
-          <a:prstGeom prst="rect">
-            <a:avLst/>
-          </a:prstGeom>
-        </p:spPr>
-      </p:pic>
-      <p:sp>
-        <p:nvSpPr>
-          <p:cNvPr id="14" name="TextBox 13"/>
-          <p:cNvSpPr txBox="1"/>
-          <p:nvPr/>
-        </p:nvSpPr>
-        <p:spPr>
-          <a:xfrm>
-            <a:off x="6263640" y="4206240"/>
-            <a:ext cx="5394960" cy="274320"/>
-          </a:xfrm>
-          <a:prstGeom prst="rect">
-            <a:avLst/>
-          </a:prstGeom>
-          <a:noFill/>
-        </p:spPr>
-        <p:txBody>
-          <a:bodyPr wrap="square">
-            <a:spAutoFit/>
-          </a:bodyPr>
-          <a:lstStyle/>
-          <a:p>
-            <a:pPr algn="l"/>
-            <a:r>
-              <a:rPr sz="1200" b="0">
-                <a:solidFill>
-                  <a:srgbClr val="78909C"/>
-                </a:solidFill>
-              </a:rPr>
-              <a:t>FT後もSEの逆効果は残るが悪影響は縮小（+0.091→+0.036）</a:t>
-            </a:r>
-          </a:p>
-        </p:txBody>
-      </p:sp>
-      <p:sp>
-        <p:nvSpPr>
-          <p:cNvPr id="15" name="Rectangle 14"/>
+            <a:off x="1097280" y="2194560"/>
+            <a:ext cx="4617720" cy="685800"/>
+          </a:xfrm>
+          <a:prstGeom prst="rect">
+            <a:avLst/>
+          </a:prstGeom>
+          <a:noFill/>
+        </p:spPr>
+        <p:txBody>
+          <a:bodyPr wrap="square" anchor="ctr">
+            <a:spAutoFit/>
+          </a:bodyPr>
+          <a:lstStyle/>
+          <a:p>
+            <a:pPr algn="l"/>
+            <a:r>
+              <a:rPr sz="1200" b="1">
+                <a:solidFill>
+                  <a:srgbClr val="212121"/>
+                </a:solidFill>
+              </a:rPr>
+              <a:t>40名・4,000発話・10.2時間</a:t>
+            </a:r>
+          </a:p>
+          <a:p>
+            <a:pPr algn="l"/>
+            <a:r>
+              <a:rPr sz="1100" b="0">
+                <a:solidFill>
+                  <a:srgbClr val="1565C0"/>
+                </a:solidFill>
+              </a:rPr>
+              <a:t>▶ Fine-tuning 学習データ</a:t>
+            </a:r>
+          </a:p>
+        </p:txBody>
+      </p:sp>
+      <p:sp>
+        <p:nvSpPr>
+          <p:cNvPr id="13" name="Rectangle 12"/>
           <p:cNvSpPr/>
           <p:nvPr/>
         </p:nvSpPr>
         <p:spPr>
           <a:xfrm>
-            <a:off x="365760" y="4663440"/>
-            <a:ext cx="11430000" cy="1874519"/>
+            <a:off x="502920" y="2972880"/>
+            <a:ext cx="548640" cy="685800"/>
           </a:xfrm>
           <a:prstGeom prst="rect">
             <a:avLst/>
           </a:prstGeom>
           <a:solidFill>
-            <a:srgbClr val="FFF9C4"/>
+            <a:srgbClr val="6A1B9A"/>
           </a:solidFill>
           <a:ln>
             <a:noFill/>
@@ -8264,244 +8797,556 @@
           <a:lstStyle/>
           <a:p>
             <a:pPr algn="ctr"/>
+            <a:r>
+              <a:rPr sz="1200" b="1">
+                <a:solidFill>
+                  <a:srgbClr val="FFFFFF"/>
+                </a:solidFill>
+              </a:rPr>
+              <a:t>dev</a:t>
+            </a:r>
+          </a:p>
+        </p:txBody>
+      </p:sp>
+      <p:sp>
+        <p:nvSpPr>
+          <p:cNvPr id="14" name="TextBox 13"/>
+          <p:cNvSpPr txBox="1"/>
+          <p:nvPr/>
+        </p:nvSpPr>
+        <p:spPr>
+          <a:xfrm>
+            <a:off x="1097280" y="2972880"/>
+            <a:ext cx="4617720" cy="685800"/>
+          </a:xfrm>
+          <a:prstGeom prst="rect">
+            <a:avLst/>
+          </a:prstGeom>
+          <a:noFill/>
+        </p:spPr>
+        <p:txBody>
+          <a:bodyPr wrap="square" anchor="ctr">
+            <a:spAutoFit/>
+          </a:bodyPr>
+          <a:lstStyle/>
+          <a:p>
+            <a:pPr algn="l"/>
+            <a:r>
+              <a:rPr sz="1200" b="1">
+                <a:solidFill>
+                  <a:srgbClr val="212121"/>
+                </a:solidFill>
+              </a:rPr>
+              <a:t>10名・1,000発話</a:t>
+            </a:r>
+          </a:p>
+          <a:p>
+            <a:pPr algn="l"/>
+            <a:r>
+              <a:rPr sz="1100" b="0">
+                <a:solidFill>
+                  <a:srgbClr val="6A1B9A"/>
+                </a:solidFill>
+              </a:rPr>
+              <a:t>▶ エポックごとにCER検証（Early stopping）</a:t>
+            </a:r>
+          </a:p>
+        </p:txBody>
+      </p:sp>
+      <p:sp>
+        <p:nvSpPr>
+          <p:cNvPr id="15" name="Rectangle 14"/>
+          <p:cNvSpPr/>
+          <p:nvPr/>
+        </p:nvSpPr>
+        <p:spPr>
+          <a:xfrm>
+            <a:off x="502920" y="3751200"/>
+            <a:ext cx="548640" cy="685800"/>
+          </a:xfrm>
+          <a:prstGeom prst="rect">
+            <a:avLst/>
+          </a:prstGeom>
+          <a:solidFill>
+            <a:srgbClr val="1B5E20"/>
+          </a:solidFill>
+          <a:ln>
+            <a:noFill/>
+          </a:ln>
+        </p:spPr>
+        <p:style>
+          <a:lnRef idx="1">
+            <a:schemeClr val="accent1"/>
+          </a:lnRef>
+          <a:fillRef idx="3">
+            <a:schemeClr val="accent1"/>
+          </a:fillRef>
+          <a:effectRef idx="2">
+            <a:schemeClr val="accent1"/>
+          </a:effectRef>
+          <a:fontRef idx="minor">
+            <a:schemeClr val="lt1"/>
+          </a:fontRef>
+        </p:style>
+        <p:txBody>
+          <a:bodyPr rtlCol="0" anchor="ctr"/>
+          <a:lstStyle/>
+          <a:p>
+            <a:pPr algn="ctr"/>
+            <a:r>
+              <a:rPr sz="1200" b="1">
+                <a:solidFill>
+                  <a:srgbClr val="FFFFFF"/>
+                </a:solidFill>
+              </a:rPr>
+              <a:t>test</a:t>
+            </a:r>
+          </a:p>
+        </p:txBody>
+      </p:sp>
+      <p:sp>
+        <p:nvSpPr>
+          <p:cNvPr id="16" name="TextBox 15"/>
+          <p:cNvSpPr txBox="1"/>
+          <p:nvPr/>
+        </p:nvSpPr>
+        <p:spPr>
+          <a:xfrm>
+            <a:off x="1097280" y="3751200"/>
+            <a:ext cx="4617720" cy="685800"/>
+          </a:xfrm>
+          <a:prstGeom prst="rect">
+            <a:avLst/>
+          </a:prstGeom>
+          <a:noFill/>
+        </p:spPr>
+        <p:txBody>
+          <a:bodyPr wrap="square" anchor="ctr">
+            <a:spAutoFit/>
+          </a:bodyPr>
+          <a:lstStyle/>
+          <a:p>
+            <a:pPr algn="l"/>
+            <a:r>
+              <a:rPr sz="1200" b="1">
+                <a:solidFill>
+                  <a:srgbClr val="212121"/>
+                </a:solidFill>
+              </a:rPr>
+              <a:t>10名・1,000発話・2.6時間</a:t>
+            </a:r>
+          </a:p>
+          <a:p>
+            <a:pPr algn="l"/>
+            <a:r>
+              <a:rPr sz="1100" b="0">
+                <a:solidFill>
+                  <a:srgbClr val="1B5E20"/>
+                </a:solidFill>
+              </a:rPr>
+              <a:t>▶ 最終評価のみ（学習中は完全未使用）</a:t>
+            </a:r>
+          </a:p>
+        </p:txBody>
+      </p:sp>
+      <p:sp>
+        <p:nvSpPr>
+          <p:cNvPr id="17" name="TextBox 16"/>
+          <p:cNvSpPr txBox="1"/>
+          <p:nvPr/>
+        </p:nvSpPr>
+        <p:spPr>
+          <a:xfrm>
+            <a:off x="502920" y="4529520"/>
+            <a:ext cx="5212080" cy="457200"/>
+          </a:xfrm>
+          <a:prstGeom prst="rect">
+            <a:avLst/>
+          </a:prstGeom>
+          <a:noFill/>
+        </p:spPr>
+        <p:txBody>
+          <a:bodyPr wrap="square">
+            <a:spAutoFit/>
+          </a:bodyPr>
+          <a:lstStyle/>
+          <a:p>
+            <a:pPr algn="l"/>
+            <a:r>
+              <a:rPr sz="1100" b="1">
+                <a:solidFill>
+                  <a:srgbClr val="1A237E"/>
+                </a:solidFill>
+              </a:rPr>
+              <a:t>話者独立設計：</a:t>
+            </a:r>
+            <a:r>
+              <a:rPr sz="1100" b="0">
+                <a:solidFill>
+                  <a:srgbClr val="212121"/>
+                </a:solidFill>
+              </a:rPr>
+              <a:t>train / dev / test で話者IDが完全に重複しない</a:t>
+            </a:r>
+          </a:p>
+        </p:txBody>
+      </p:sp>
+      <p:sp>
+        <p:nvSpPr>
+          <p:cNvPr id="18" name="TextBox 17"/>
+          <p:cNvSpPr txBox="1"/>
+          <p:nvPr/>
+        </p:nvSpPr>
+        <p:spPr>
+          <a:xfrm>
+            <a:off x="6474552" y="1417320"/>
+            <a:ext cx="5212080" cy="411480"/>
+          </a:xfrm>
+          <a:prstGeom prst="rect">
+            <a:avLst/>
+          </a:prstGeom>
+          <a:noFill/>
+        </p:spPr>
+        <p:txBody>
+          <a:bodyPr wrap="square">
+            <a:spAutoFit/>
+          </a:bodyPr>
+          <a:lstStyle/>
+          <a:p>
+            <a:pPr algn="l"/>
+            <a:r>
+              <a:rPr sz="1500" b="1">
+                <a:solidFill>
+                  <a:srgbClr val="1B5E20"/>
+                </a:solidFill>
+              </a:rPr>
+              <a:t>Fine-tuningでの使い方</a:t>
+            </a:r>
+          </a:p>
+        </p:txBody>
+      </p:sp>
+      <p:sp>
+        <p:nvSpPr>
+          <p:cNvPr id="19" name="TextBox 18"/>
+          <p:cNvSpPr txBox="1"/>
+          <p:nvPr/>
+        </p:nvSpPr>
+        <p:spPr>
+          <a:xfrm>
+            <a:off x="6474552" y="1920240"/>
+            <a:ext cx="5212080" cy="320040"/>
+          </a:xfrm>
+          <a:prstGeom prst="rect">
+            <a:avLst/>
+          </a:prstGeom>
+          <a:noFill/>
+        </p:spPr>
+        <p:txBody>
+          <a:bodyPr wrap="square">
+            <a:spAutoFit/>
+          </a:bodyPr>
+          <a:lstStyle/>
+          <a:p>
+            <a:pPr algn="l"/>
+            <a:r>
+              <a:rPr sz="1300" b="1">
+                <a:solidFill>
+                  <a:srgbClr val="1565C0"/>
+                </a:solidFill>
+              </a:rPr>
+              <a:t>① trainデータ  →  学習</a:t>
+            </a:r>
+          </a:p>
+        </p:txBody>
+      </p:sp>
+      <p:sp>
+        <p:nvSpPr>
+          <p:cNvPr id="20" name="TextBox 19"/>
+          <p:cNvSpPr txBox="1"/>
+          <p:nvPr/>
+        </p:nvSpPr>
+        <p:spPr>
+          <a:xfrm>
+            <a:off x="6657480" y="2240280"/>
+            <a:ext cx="5029152" cy="548640"/>
+          </a:xfrm>
+          <a:prstGeom prst="rect">
+            <a:avLst/>
+          </a:prstGeom>
+          <a:noFill/>
+        </p:spPr>
+        <p:txBody>
+          <a:bodyPr wrap="square">
+            <a:spAutoFit/>
+          </a:bodyPr>
+          <a:lstStyle/>
+          <a:p>
+            <a:pPr algn="l"/>
+            <a:r>
+              <a:rPr sz="1200" b="0">
+                <a:solidFill>
+                  <a:srgbClr val="212121"/>
+                </a:solidFill>
+              </a:rPr>
+              <a:t>喉マイク音声 + 韓国語テキストのペアで学習</a:t>
+            </a:r>
+          </a:p>
+          <a:p>
+            <a:pPr algn="l"/>
+            <a:r>
+              <a:rPr sz="1200" b="0">
+                <a:solidFill>
+                  <a:srgbClr val="212121"/>
+                </a:solidFill>
+              </a:rPr>
+              <a:t>気導マイクデータは使用しない</a:t>
+            </a:r>
+          </a:p>
+        </p:txBody>
+      </p:sp>
+      <p:sp>
+        <p:nvSpPr>
+          <p:cNvPr id="21" name="TextBox 20"/>
+          <p:cNvSpPr txBox="1"/>
+          <p:nvPr/>
+        </p:nvSpPr>
+        <p:spPr>
+          <a:xfrm>
+            <a:off x="6474552" y="2880360"/>
+            <a:ext cx="5212080" cy="320040"/>
+          </a:xfrm>
+          <a:prstGeom prst="rect">
+            <a:avLst/>
+          </a:prstGeom>
+          <a:noFill/>
+        </p:spPr>
+        <p:txBody>
+          <a:bodyPr wrap="square">
+            <a:spAutoFit/>
+          </a:bodyPr>
+          <a:lstStyle/>
+          <a:p>
+            <a:pPr algn="l"/>
+            <a:r>
+              <a:rPr sz="1300" b="1">
+                <a:solidFill>
+                  <a:srgbClr val="6A1B9A"/>
+                </a:solidFill>
+              </a:rPr>
+              <a:t>② devデータ  →  エポックごとにCER検証</a:t>
+            </a:r>
+          </a:p>
+        </p:txBody>
+      </p:sp>
+      <p:sp>
+        <p:nvSpPr>
+          <p:cNvPr id="22" name="TextBox 21"/>
+          <p:cNvSpPr txBox="1"/>
+          <p:nvPr/>
+        </p:nvSpPr>
+        <p:spPr>
+          <a:xfrm>
+            <a:off x="6657480" y="3200400"/>
+            <a:ext cx="5029152" cy="685800"/>
+          </a:xfrm>
+          <a:prstGeom prst="rect">
+            <a:avLst/>
+          </a:prstGeom>
+          <a:noFill/>
+        </p:spPr>
+        <p:txBody>
+          <a:bodyPr wrap="square">
+            <a:spAutoFit/>
+          </a:bodyPr>
+          <a:lstStyle/>
+          <a:p>
+            <a:pPr algn="l"/>
+            <a:r>
+              <a:rPr sz="1200" b="0">
+                <a:solidFill>
+                  <a:srgbClr val="212121"/>
+                </a:solidFill>
+              </a:rPr>
+              <a:t>eval_strategy='epoch' — 毎エポック終了後に自動評価</a:t>
+            </a:r>
+          </a:p>
+          <a:p>
+            <a:pPr algn="l"/>
+            <a:r>
+              <a:rPr sz="1200" b="0">
+                <a:solidFill>
+                  <a:srgbClr val="212121"/>
+                </a:solidFill>
+              </a:rPr>
+              <a:t>early stopping（patience=3）の判断に使用</a:t>
+            </a:r>
+          </a:p>
+          <a:p>
+            <a:pPr algn="l"/>
+            <a:r>
+              <a:rPr sz="1200" b="0">
+                <a:solidFill>
+                  <a:srgbClr val="212121"/>
+                </a:solidFill>
+              </a:rPr>
+              <a:t>最良エポックのモデルを自動保存して採用</a:t>
+            </a:r>
+          </a:p>
+        </p:txBody>
+      </p:sp>
+      <p:sp>
+        <p:nvSpPr>
+          <p:cNvPr id="23" name="TextBox 22"/>
+          <p:cNvSpPr txBox="1"/>
+          <p:nvPr/>
+        </p:nvSpPr>
+        <p:spPr>
+          <a:xfrm>
+            <a:off x="6474552" y="3977280"/>
+            <a:ext cx="5212080" cy="320040"/>
+          </a:xfrm>
+          <a:prstGeom prst="rect">
+            <a:avLst/>
+          </a:prstGeom>
+          <a:noFill/>
+        </p:spPr>
+        <p:txBody>
+          <a:bodyPr wrap="square">
+            <a:spAutoFit/>
+          </a:bodyPr>
+          <a:lstStyle/>
+          <a:p>
+            <a:pPr algn="l"/>
+            <a:r>
+              <a:rPr sz="1300" b="1">
+                <a:solidFill>
+                  <a:srgbClr val="1B5E20"/>
+                </a:solidFill>
+              </a:rPr>
+              <a:t>③ testデータ  →  最終評価のみ</a:t>
+            </a:r>
+          </a:p>
+        </p:txBody>
+      </p:sp>
+      <p:sp>
+        <p:nvSpPr>
+          <p:cNvPr id="24" name="TextBox 23"/>
+          <p:cNvSpPr txBox="1"/>
+          <p:nvPr/>
+        </p:nvSpPr>
+        <p:spPr>
+          <a:xfrm>
+            <a:off x="6657480" y="4297320"/>
+            <a:ext cx="5029152" cy="548640"/>
+          </a:xfrm>
+          <a:prstGeom prst="rect">
+            <a:avLst/>
+          </a:prstGeom>
+          <a:noFill/>
+        </p:spPr>
+        <p:txBody>
+          <a:bodyPr wrap="square">
+            <a:spAutoFit/>
+          </a:bodyPr>
+          <a:lstStyle/>
+          <a:p>
+            <a:pPr algn="l"/>
+            <a:r>
+              <a:rPr sz="1200" b="0">
+                <a:solidFill>
+                  <a:srgbClr val="212121"/>
+                </a:solidFill>
+              </a:rPr>
+              <a:t>Fine-tuning 中は一切アクセスしない</a:t>
+            </a:r>
+          </a:p>
+          <a:p>
+            <a:pPr algn="l"/>
+            <a:r>
+              <a:rPr sz="1200" b="0">
+                <a:solidFill>
+                  <a:srgbClr val="212121"/>
+                </a:solidFill>
+              </a:rPr>
+              <a:t>→ 最終CER 0.1498（10話者・1,000発話）を達成</a:t>
+            </a:r>
+          </a:p>
+        </p:txBody>
+      </p:sp>
+      <p:sp>
+        <p:nvSpPr>
+          <p:cNvPr id="25" name="Rectangle 24"/>
+          <p:cNvSpPr/>
+          <p:nvPr/>
+        </p:nvSpPr>
+        <p:spPr>
+          <a:xfrm>
+            <a:off x="365760" y="5806440"/>
+            <a:ext cx="11430000" cy="685800"/>
+          </a:xfrm>
+          <a:prstGeom prst="rect">
+            <a:avLst/>
+          </a:prstGeom>
+          <a:solidFill>
+            <a:srgbClr val="FFEBEE"/>
+          </a:solidFill>
+          <a:ln>
+            <a:noFill/>
+          </a:ln>
+        </p:spPr>
+        <p:style>
+          <a:lnRef idx="1">
+            <a:schemeClr val="accent1"/>
+          </a:lnRef>
+          <a:fillRef idx="3">
+            <a:schemeClr val="accent1"/>
+          </a:fillRef>
+          <a:effectRef idx="2">
+            <a:schemeClr val="accent1"/>
+          </a:effectRef>
+          <a:fontRef idx="minor">
+            <a:schemeClr val="lt1"/>
+          </a:fontRef>
+        </p:style>
+        <p:txBody>
+          <a:bodyPr rtlCol="0" anchor="ctr"/>
+          <a:lstStyle/>
+          <a:p>
+            <a:pPr algn="ctr"/>
             <a:endParaRPr/>
           </a:p>
         </p:txBody>
       </p:sp>
       <p:sp>
         <p:nvSpPr>
-          <p:cNvPr id="16" name="TextBox 15"/>
-          <p:cNvSpPr txBox="1"/>
-          <p:nvPr/>
-        </p:nvSpPr>
-        <p:spPr>
-          <a:xfrm>
-            <a:off x="548640" y="4736592"/>
-            <a:ext cx="1828800" cy="347472"/>
-          </a:xfrm>
-          <a:prstGeom prst="rect">
-            <a:avLst/>
-          </a:prstGeom>
-          <a:noFill/>
-        </p:spPr>
-        <p:txBody>
-          <a:bodyPr wrap="square">
-            <a:spAutoFit/>
-          </a:bodyPr>
-          <a:lstStyle/>
-          <a:p>
-            <a:pPr algn="l"/>
+          <p:cNvPr id="26" name="TextBox 25"/>
+          <p:cNvSpPr txBox="1"/>
+          <p:nvPr/>
+        </p:nvSpPr>
+        <p:spPr>
+          <a:xfrm>
+            <a:off x="548640" y="5925312"/>
+            <a:ext cx="11064240" cy="411480"/>
+          </a:xfrm>
+          <a:prstGeom prst="rect">
+            <a:avLst/>
+          </a:prstGeom>
+          <a:noFill/>
+        </p:spPr>
+        <p:txBody>
+          <a:bodyPr wrap="square">
+            <a:spAutoFit/>
+          </a:bodyPr>
+          <a:lstStyle/>
+          <a:p>
+            <a:pPr algn="ctr"/>
             <a:r>
               <a:rPr sz="1500" b="1">
                 <a:solidFill>
-                  <a:srgbClr val="1A237E"/>
-                </a:solidFill>
-              </a:rPr>
-              <a:t>まとめ</a:t>
-            </a:r>
-          </a:p>
-        </p:txBody>
-      </p:sp>
-      <p:sp>
-        <p:nvSpPr>
-          <p:cNvPr id="17" name="TextBox 16"/>
-          <p:cNvSpPr txBox="1"/>
-          <p:nvPr/>
-        </p:nvSpPr>
-        <p:spPr>
-          <a:xfrm>
-            <a:off x="548640" y="5120640"/>
-            <a:ext cx="457200" cy="384048"/>
-          </a:xfrm>
-          <a:prstGeom prst="rect">
-            <a:avLst/>
-          </a:prstGeom>
-          <a:noFill/>
-        </p:spPr>
-        <p:txBody>
-          <a:bodyPr wrap="square">
-            <a:spAutoFit/>
-          </a:bodyPr>
-          <a:lstStyle/>
-          <a:p>
-            <a:pPr algn="l"/>
-            <a:r>
-              <a:rPr sz="1400" b="1">
-                <a:solidFill>
                   <a:srgbClr val="C62828"/>
                 </a:solidFill>
               </a:rPr>
-              <a:t>①</a:t>
-            </a:r>
-          </a:p>
-        </p:txBody>
-      </p:sp>
-      <p:sp>
-        <p:nvSpPr>
-          <p:cNvPr id="18" name="TextBox 17"/>
-          <p:cNvSpPr txBox="1"/>
-          <p:nvPr/>
-        </p:nvSpPr>
-        <p:spPr>
-          <a:xfrm>
-            <a:off x="1005840" y="5120640"/>
-            <a:ext cx="10607040" cy="384048"/>
-          </a:xfrm>
-          <a:prstGeom prst="rect">
-            <a:avLst/>
-          </a:prstGeom>
-          <a:noFill/>
-        </p:spPr>
-        <p:txBody>
-          <a:bodyPr wrap="square">
-            <a:spAutoFit/>
-          </a:bodyPr>
-          <a:lstStyle/>
-          <a:p>
-            <a:pPr algn="l"/>
-            <a:r>
-              <a:rPr sz="1400" b="0">
-                <a:solidFill>
-                  <a:srgbClr val="212121"/>
-                </a:solidFill>
-              </a:rPr>
-              <a:t>STOI↑PESQ↑でもCERが悪化する逆行現象が喉マイクでも全ノイズ条件で一貫して観測された</a:t>
-            </a:r>
-          </a:p>
-        </p:txBody>
-      </p:sp>
-      <p:sp>
-        <p:nvSpPr>
-          <p:cNvPr id="19" name="TextBox 18"/>
-          <p:cNvSpPr txBox="1"/>
-          <p:nvPr/>
-        </p:nvSpPr>
-        <p:spPr>
-          <a:xfrm>
-            <a:off x="548640" y="5577840"/>
-            <a:ext cx="457200" cy="384048"/>
-          </a:xfrm>
-          <a:prstGeom prst="rect">
-            <a:avLst/>
-          </a:prstGeom>
-          <a:noFill/>
-        </p:spPr>
-        <p:txBody>
-          <a:bodyPr wrap="square">
-            <a:spAutoFit/>
-          </a:bodyPr>
-          <a:lstStyle/>
-          <a:p>
-            <a:pPr algn="l"/>
-            <a:r>
-              <a:rPr sz="1400" b="1">
-                <a:solidFill>
-                  <a:srgbClr val="FF6F00"/>
-                </a:solidFill>
-              </a:rPr>
-              <a:t>②</a:t>
-            </a:r>
-          </a:p>
-        </p:txBody>
-      </p:sp>
-      <p:sp>
-        <p:nvSpPr>
-          <p:cNvPr id="20" name="TextBox 19"/>
-          <p:cNvSpPr txBox="1"/>
-          <p:nvPr/>
-        </p:nvSpPr>
-        <p:spPr>
-          <a:xfrm>
-            <a:off x="1005840" y="5577840"/>
-            <a:ext cx="10607040" cy="384048"/>
-          </a:xfrm>
-          <a:prstGeom prst="rect">
-            <a:avLst/>
-          </a:prstGeom>
-          <a:noFill/>
-        </p:spPr>
-        <p:txBody>
-          <a:bodyPr wrap="square">
-            <a:spAutoFit/>
-          </a:bodyPr>
-          <a:lstStyle/>
-          <a:p>
-            <a:pPr algn="l"/>
-            <a:r>
-              <a:rPr sz="1400" b="0">
-                <a:solidFill>
-                  <a:srgbClr val="212121"/>
-                </a:solidFill>
-              </a:rPr>
-              <a:t>知覚品質指標（STOI・PESQ）は喉マイクASR性能の指標として不適切</a:t>
-            </a:r>
-          </a:p>
-        </p:txBody>
-      </p:sp>
-      <p:sp>
-        <p:nvSpPr>
-          <p:cNvPr id="21" name="TextBox 20"/>
-          <p:cNvSpPr txBox="1"/>
-          <p:nvPr/>
-        </p:nvSpPr>
-        <p:spPr>
-          <a:xfrm>
-            <a:off x="548640" y="6035040"/>
-            <a:ext cx="457200" cy="384048"/>
-          </a:xfrm>
-          <a:prstGeom prst="rect">
-            <a:avLst/>
-          </a:prstGeom>
-          <a:noFill/>
-        </p:spPr>
-        <p:txBody>
-          <a:bodyPr wrap="square">
-            <a:spAutoFit/>
-          </a:bodyPr>
-          <a:lstStyle/>
-          <a:p>
-            <a:pPr algn="l"/>
-            <a:r>
-              <a:rPr sz="1400" b="1">
-                <a:solidFill>
-                  <a:srgbClr val="2E7D32"/>
-                </a:solidFill>
-              </a:rPr>
-              <a:t>③</a:t>
-            </a:r>
-          </a:p>
-        </p:txBody>
-      </p:sp>
-      <p:sp>
-        <p:nvSpPr>
-          <p:cNvPr id="22" name="TextBox 21"/>
-          <p:cNvSpPr txBox="1"/>
-          <p:nvPr/>
-        </p:nvSpPr>
-        <p:spPr>
-          <a:xfrm>
-            <a:off x="1005840" y="6035040"/>
-            <a:ext cx="10607040" cy="384048"/>
-          </a:xfrm>
-          <a:prstGeom prst="rect">
-            <a:avLst/>
-          </a:prstGeom>
-          <a:noFill/>
-        </p:spPr>
-        <p:txBody>
-          <a:bodyPr wrap="square">
-            <a:spAutoFit/>
-          </a:bodyPr>
-          <a:lstStyle/>
-          <a:p>
-            <a:pPr algn="l"/>
-            <a:r>
-              <a:rPr sz="1400" b="0">
-                <a:solidFill>
-                  <a:srgbClr val="212121"/>
-                </a:solidFill>
-              </a:rPr>
-              <a:t>Whisper FTでCER 72.4%改善（0.544→0.150，10話者）—音声処理よりASR適応が根本解決</a:t>
+              <a:t>CER 0.1498 は Fine-tuning 中に一度も見ていない test データで達成 — 話者独立・発話独立で信頼性が高い</a:t>
             </a:r>
           </a:p>
         </p:txBody>
@@ -8515,6 +9360,1819 @@
 </file>
 
 <file path=ppt/slides/slide7.xml><?xml version="1.0" encoding="utf-8"?>
+<p:sld xmlns:a="http://schemas.openxmlformats.org/drawingml/2006/main" xmlns:r="http://schemas.openxmlformats.org/officeDocument/2006/relationships" xmlns:p="http://schemas.openxmlformats.org/presentationml/2006/main">
+  <p:cSld>
+    <p:spTree>
+      <p:nvGrpSpPr>
+        <p:cNvPr id="1" name=""/>
+        <p:cNvGrpSpPr/>
+        <p:nvPr/>
+      </p:nvGrpSpPr>
+      <p:grpSpPr>
+        <a:xfrm>
+          <a:off x="0" y="0"/>
+          <a:ext cx="0" cy="0"/>
+          <a:chOff x="0" y="0"/>
+          <a:chExt cx="0" cy="0"/>
+        </a:xfrm>
+      </p:grpSpPr>
+      <p:sp>
+        <p:nvSpPr>
+          <p:cNvPr id="2" name="Rectangle 1"/>
+          <p:cNvSpPr/>
+          <p:nvPr/>
+        </p:nvSpPr>
+        <p:spPr>
+          <a:xfrm>
+            <a:off x="0" y="0"/>
+            <a:ext cx="12188952" cy="1188720"/>
+          </a:xfrm>
+          <a:prstGeom prst="rect">
+            <a:avLst/>
+          </a:prstGeom>
+          <a:solidFill>
+            <a:srgbClr val="1A237E"/>
+          </a:solidFill>
+          <a:ln>
+            <a:noFill/>
+          </a:ln>
+        </p:spPr>
+        <p:style>
+          <a:lnRef idx="1">
+            <a:schemeClr val="accent1"/>
+          </a:lnRef>
+          <a:fillRef idx="3">
+            <a:schemeClr val="accent1"/>
+          </a:fillRef>
+          <a:effectRef idx="2">
+            <a:schemeClr val="accent1"/>
+          </a:effectRef>
+          <a:fontRef idx="minor">
+            <a:schemeClr val="lt1"/>
+          </a:fontRef>
+        </p:style>
+        <p:txBody>
+          <a:bodyPr rtlCol="0" anchor="ctr"/>
+          <a:lstStyle/>
+          <a:p>
+            <a:pPr algn="ctr"/>
+            <a:endParaRPr/>
+          </a:p>
+        </p:txBody>
+      </p:sp>
+      <p:sp>
+        <p:nvSpPr>
+          <p:cNvPr id="3" name="TextBox 2"/>
+          <p:cNvSpPr txBox="1"/>
+          <p:nvPr/>
+        </p:nvSpPr>
+        <p:spPr>
+          <a:xfrm>
+            <a:off x="411480" y="137160"/>
+            <a:ext cx="10789920" cy="777240"/>
+          </a:xfrm>
+          <a:prstGeom prst="rect">
+            <a:avLst/>
+          </a:prstGeom>
+          <a:noFill/>
+        </p:spPr>
+        <p:txBody>
+          <a:bodyPr wrap="square">
+            <a:spAutoFit/>
+          </a:bodyPr>
+          <a:lstStyle/>
+          <a:p>
+            <a:pPr algn="l"/>
+            <a:r>
+              <a:rPr sz="2600" b="1">
+                <a:solidFill>
+                  <a:srgbClr val="FFFFFF"/>
+                </a:solidFill>
+              </a:rPr>
+              <a:t>TAPSデータセット — 他研究での活用状況</a:t>
+            </a:r>
+          </a:p>
+        </p:txBody>
+      </p:sp>
+      <p:sp>
+        <p:nvSpPr>
+          <p:cNvPr id="4" name="TextBox 3"/>
+          <p:cNvSpPr txBox="1"/>
+          <p:nvPr/>
+        </p:nvSpPr>
+        <p:spPr>
+          <a:xfrm>
+            <a:off x="11100000" y="411480"/>
+            <a:ext cx="900000" cy="365760"/>
+          </a:xfrm>
+          <a:prstGeom prst="rect">
+            <a:avLst/>
+          </a:prstGeom>
+          <a:noFill/>
+        </p:spPr>
+        <p:txBody>
+          <a:bodyPr wrap="square">
+            <a:spAutoFit/>
+          </a:bodyPr>
+          <a:lstStyle/>
+          <a:p>
+            <a:pPr algn="r"/>
+            <a:r>
+              <a:rPr sz="1300" b="0">
+                <a:solidFill>
+                  <a:srgbClr val="78909C"/>
+                </a:solidFill>
+              </a:rPr>
+              <a:t>補足</a:t>
+            </a:r>
+          </a:p>
+        </p:txBody>
+      </p:sp>
+      <p:sp>
+        <p:nvSpPr>
+          <p:cNvPr id="5" name="Rectangle 4"/>
+          <p:cNvSpPr/>
+          <p:nvPr/>
+        </p:nvSpPr>
+        <p:spPr>
+          <a:xfrm>
+            <a:off x="0" y="6583680"/>
+            <a:ext cx="12188952" cy="274320"/>
+          </a:xfrm>
+          <a:prstGeom prst="rect">
+            <a:avLst/>
+          </a:prstGeom>
+          <a:solidFill>
+            <a:srgbClr val="E8EAF6"/>
+          </a:solidFill>
+          <a:ln>
+            <a:noFill/>
+          </a:ln>
+        </p:spPr>
+        <p:style>
+          <a:lnRef idx="1">
+            <a:schemeClr val="accent1"/>
+          </a:lnRef>
+          <a:fillRef idx="3">
+            <a:schemeClr val="accent1"/>
+          </a:fillRef>
+          <a:effectRef idx="2">
+            <a:schemeClr val="accent1"/>
+          </a:effectRef>
+          <a:fontRef idx="minor">
+            <a:schemeClr val="lt1"/>
+          </a:fontRef>
+        </p:style>
+        <p:txBody>
+          <a:bodyPr rtlCol="0" anchor="ctr"/>
+          <a:lstStyle/>
+          <a:p>
+            <a:pPr algn="ctr"/>
+            <a:endParaRPr/>
+          </a:p>
+        </p:txBody>
+      </p:sp>
+      <p:sp>
+        <p:nvSpPr>
+          <p:cNvPr id="6" name="TextBox 5"/>
+          <p:cNvSpPr txBox="1"/>
+          <p:nvPr/>
+        </p:nvSpPr>
+        <p:spPr>
+          <a:xfrm>
+            <a:off x="274320" y="6601968"/>
+            <a:ext cx="11612880" cy="228600"/>
+          </a:xfrm>
+          <a:prstGeom prst="rect">
+            <a:avLst/>
+          </a:prstGeom>
+          <a:noFill/>
+        </p:spPr>
+        <p:txBody>
+          <a:bodyPr wrap="square">
+            <a:spAutoFit/>
+          </a:bodyPr>
+          <a:lstStyle/>
+          <a:p>
+            <a:pPr algn="l"/>
+            <a:r>
+              <a:rPr sz="900" b="0">
+                <a:solidFill>
+                  <a:srgbClr val="78909C"/>
+                </a:solidFill>
+              </a:rPr>
+              <a:t>骨伝導マイク音声認識研究 — 概要</a:t>
+            </a:r>
+          </a:p>
+        </p:txBody>
+      </p:sp>
+      <p:sp>
+        <p:nvSpPr>
+          <p:cNvPr id="7" name="Rectangle 6"/>
+          <p:cNvSpPr/>
+          <p:nvPr/>
+        </p:nvSpPr>
+        <p:spPr>
+          <a:xfrm>
+            <a:off x="365760" y="1280160"/>
+            <a:ext cx="11457432" cy="320040"/>
+          </a:xfrm>
+          <a:prstGeom prst="rect">
+            <a:avLst/>
+          </a:prstGeom>
+          <a:solidFill>
+            <a:srgbClr val="E8EAF6"/>
+          </a:solidFill>
+          <a:ln>
+            <a:noFill/>
+          </a:ln>
+        </p:spPr>
+        <p:style>
+          <a:lnRef idx="1">
+            <a:schemeClr val="accent1"/>
+          </a:lnRef>
+          <a:fillRef idx="3">
+            <a:schemeClr val="accent1"/>
+          </a:fillRef>
+          <a:effectRef idx="2">
+            <a:schemeClr val="accent1"/>
+          </a:effectRef>
+          <a:fontRef idx="minor">
+            <a:schemeClr val="lt1"/>
+          </a:fontRef>
+        </p:style>
+        <p:txBody>
+          <a:bodyPr rtlCol="0" anchor="ctr"/>
+          <a:lstStyle/>
+          <a:p>
+            <a:pPr algn="ctr"/>
+            <a:r>
+              <a:rPr sz="1100" b="0">
+                <a:solidFill>
+                  <a:srgbClr val="37474F"/>
+                </a:solidFill>
+              </a:rPr>
+              <a:t>公開: 2025年2月　|　現在の引用数: 5件（2026年4月時点）　|　著者グループによる後続研究が中心</a:t>
+            </a:r>
+          </a:p>
+        </p:txBody>
+      </p:sp>
+      <p:sp>
+        <p:nvSpPr>
+          <p:cNvPr id="8" name="Rectangle 7"/>
+          <p:cNvSpPr/>
+          <p:nvPr/>
+        </p:nvSpPr>
+        <p:spPr>
+          <a:xfrm>
+            <a:off x="365760" y="1645920"/>
+            <a:ext cx="5486400" cy="4160160"/>
+          </a:xfrm>
+          <a:prstGeom prst="rect">
+            <a:avLst/>
+          </a:prstGeom>
+          <a:solidFill>
+            <a:srgbClr val="E3F2FD"/>
+          </a:solidFill>
+          <a:ln>
+            <a:noFill/>
+          </a:ln>
+        </p:spPr>
+        <p:style>
+          <a:lnRef idx="1">
+            <a:schemeClr val="accent1"/>
+          </a:lnRef>
+          <a:fillRef idx="3">
+            <a:schemeClr val="accent1"/>
+          </a:fillRef>
+          <a:effectRef idx="2">
+            <a:schemeClr val="accent1"/>
+          </a:effectRef>
+          <a:fontRef idx="minor">
+            <a:schemeClr val="lt1"/>
+          </a:fontRef>
+        </p:style>
+        <p:txBody>
+          <a:bodyPr rtlCol="0" anchor="ctr"/>
+          <a:lstStyle/>
+          <a:p>
+            <a:pPr algn="ctr"/>
+            <a:endParaRPr/>
+          </a:p>
+        </p:txBody>
+      </p:sp>
+      <p:sp>
+        <p:nvSpPr>
+          <p:cNvPr id="9" name="Rectangle 8"/>
+          <p:cNvSpPr/>
+          <p:nvPr/>
+        </p:nvSpPr>
+        <p:spPr>
+          <a:xfrm>
+            <a:off x="6336792" y="1645920"/>
+            <a:ext cx="5486400" cy="4160160"/>
+          </a:xfrm>
+          <a:prstGeom prst="rect">
+            <a:avLst/>
+          </a:prstGeom>
+          <a:solidFill>
+            <a:srgbClr val="F3E5F5"/>
+          </a:solidFill>
+          <a:ln>
+            <a:noFill/>
+          </a:ln>
+        </p:spPr>
+        <p:style>
+          <a:lnRef idx="1">
+            <a:schemeClr val="accent1"/>
+          </a:lnRef>
+          <a:fillRef idx="3">
+            <a:schemeClr val="accent1"/>
+          </a:fillRef>
+          <a:effectRef idx="2">
+            <a:schemeClr val="accent1"/>
+          </a:effectRef>
+          <a:fontRef idx="minor">
+            <a:schemeClr val="lt1"/>
+          </a:fontRef>
+        </p:style>
+        <p:txBody>
+          <a:bodyPr rtlCol="0" anchor="ctr"/>
+          <a:lstStyle/>
+          <a:p>
+            <a:pPr algn="ctr"/>
+            <a:endParaRPr/>
+          </a:p>
+        </p:txBody>
+      </p:sp>
+      <p:sp>
+        <p:nvSpPr>
+          <p:cNvPr id="10" name="TextBox 9"/>
+          <p:cNvSpPr txBox="1"/>
+          <p:nvPr/>
+        </p:nvSpPr>
+        <p:spPr>
+          <a:xfrm>
+            <a:off x="502920" y="1737360"/>
+            <a:ext cx="5212080" cy="365760"/>
+          </a:xfrm>
+          <a:prstGeom prst="rect">
+            <a:avLst/>
+          </a:prstGeom>
+          <a:noFill/>
+        </p:spPr>
+        <p:txBody>
+          <a:bodyPr wrap="square">
+            <a:spAutoFit/>
+          </a:bodyPr>
+          <a:lstStyle/>
+          <a:p>
+            <a:pPr algn="l"/>
+            <a:r>
+              <a:rPr sz="1400" b="1">
+                <a:solidFill>
+                  <a:srgbClr val="1A237E"/>
+                </a:solidFill>
+              </a:rPr>
+              <a:t>TAPSで実験した研究（2件）</a:t>
+            </a:r>
+          </a:p>
+        </p:txBody>
+      </p:sp>
+      <p:sp>
+        <p:nvSpPr>
+          <p:cNvPr id="11" name="TextBox 10"/>
+          <p:cNvSpPr txBox="1"/>
+          <p:nvPr/>
+        </p:nvSpPr>
+        <p:spPr>
+          <a:xfrm>
+            <a:off x="6474552" y="1737360"/>
+            <a:ext cx="5212080" cy="365760"/>
+          </a:xfrm>
+          <a:prstGeom prst="rect">
+            <a:avLst/>
+          </a:prstGeom>
+          <a:noFill/>
+        </p:spPr>
+        <p:txBody>
+          <a:bodyPr wrap="square">
+            <a:spAutoFit/>
+          </a:bodyPr>
+          <a:lstStyle/>
+          <a:p>
+            <a:pPr algn="l"/>
+            <a:r>
+              <a:rPr sz="1400" b="1">
+                <a:solidFill>
+                  <a:srgbClr val="6A1B9A"/>
+                </a:solidFill>
+              </a:rPr>
+              <a:t>サーベイ・関連データセット（3件）</a:t>
+            </a:r>
+          </a:p>
+        </p:txBody>
+      </p:sp>
+      <p:sp>
+        <p:nvSpPr>
+          <p:cNvPr id="12" name="Rectangle 11"/>
+          <p:cNvSpPr/>
+          <p:nvPr/>
+        </p:nvSpPr>
+        <p:spPr>
+          <a:xfrm>
+            <a:off x="502920" y="2194560"/>
+            <a:ext cx="91440" cy="1371600"/>
+          </a:xfrm>
+          <a:prstGeom prst="rect">
+            <a:avLst/>
+          </a:prstGeom>
+          <a:solidFill>
+            <a:srgbClr val="1565C0"/>
+          </a:solidFill>
+          <a:ln>
+            <a:noFill/>
+          </a:ln>
+        </p:spPr>
+        <p:style>
+          <a:lnRef idx="1">
+            <a:schemeClr val="accent1"/>
+          </a:lnRef>
+          <a:fillRef idx="3">
+            <a:schemeClr val="accent1"/>
+          </a:fillRef>
+          <a:effectRef idx="2">
+            <a:schemeClr val="accent1"/>
+          </a:effectRef>
+          <a:fontRef idx="minor">
+            <a:schemeClr val="lt1"/>
+          </a:fontRef>
+        </p:style>
+        <p:txBody>
+          <a:bodyPr rtlCol="0" anchor="ctr"/>
+          <a:lstStyle/>
+          <a:p>
+            <a:pPr algn="ctr"/>
+            <a:endParaRPr/>
+          </a:p>
+        </p:txBody>
+      </p:sp>
+      <p:sp>
+        <p:nvSpPr>
+          <p:cNvPr id="13" name="TextBox 12"/>
+          <p:cNvSpPr txBox="1"/>
+          <p:nvPr/>
+        </p:nvSpPr>
+        <p:spPr>
+          <a:xfrm>
+            <a:off x="640080" y="2194560"/>
+            <a:ext cx="5075040" cy="1371600"/>
+          </a:xfrm>
+          <a:prstGeom prst="rect">
+            <a:avLst/>
+          </a:prstGeom>
+          <a:noFill/>
+        </p:spPr>
+        <p:txBody>
+          <a:bodyPr wrap="square">
+            <a:spAutoFit/>
+          </a:bodyPr>
+          <a:lstStyle/>
+          <a:p>
+            <a:pPr algn="l"/>
+            <a:r>
+              <a:rPr sz="1200" b="1">
+                <a:solidFill>
+                  <a:srgbClr val="1565C0"/>
+                </a:solidFill>
+              </a:rPr>
+              <a:t>Modality-Specific SE &amp; Noise-Adaptive Fusion</a:t>
+            </a:r>
+          </a:p>
+          <a:p>
+            <a:pPr algn="l"/>
+            <a:r>
+              <a:rPr sz="1000" b="0">
+                <a:solidFill>
+                  <a:srgbClr val="546E7A"/>
+                </a:solidFill>
+              </a:rPr>
+              <a:t>Kim &amp; Chung, Interspeech 2025　※TAPS著者グループ</a:t>
+            </a:r>
+          </a:p>
+          <a:p>
+            <a:pPr algn="l"/>
+            <a:r>
+              <a:rPr sz="1100" b="0">
+                <a:solidFill>
+                  <a:srgbClr val="212121"/>
+                </a:solidFill>
+              </a:rPr>
+              <a:t>喉マイク＋気導マイクを2つの専門NNで処理・融合。</a:t>
+            </a:r>
+          </a:p>
+          <a:p>
+            <a:pPr algn="l"/>
+            <a:r>
+              <a:rPr sz="1100" b="0">
+                <a:solidFill>
+                  <a:srgbClr val="212121"/>
+                </a:solidFill>
+              </a:rPr>
+              <a:t>TAPSで評価: SE適用時のCER 84.4% → 24.4%</a:t>
+            </a:r>
+          </a:p>
+        </p:txBody>
+      </p:sp>
+      <p:sp>
+        <p:nvSpPr>
+          <p:cNvPr id="14" name="Rectangle 13"/>
+          <p:cNvSpPr/>
+          <p:nvPr/>
+        </p:nvSpPr>
+        <p:spPr>
+          <a:xfrm>
+            <a:off x="502920" y="3749040"/>
+            <a:ext cx="91440" cy="1371600"/>
+          </a:xfrm>
+          <a:prstGeom prst="rect">
+            <a:avLst/>
+          </a:prstGeom>
+          <a:solidFill>
+            <a:srgbClr val="0277BD"/>
+          </a:solidFill>
+          <a:ln>
+            <a:noFill/>
+          </a:ln>
+        </p:spPr>
+        <p:style>
+          <a:lnRef idx="1">
+            <a:schemeClr val="accent1"/>
+          </a:lnRef>
+          <a:fillRef idx="3">
+            <a:schemeClr val="accent1"/>
+          </a:fillRef>
+          <a:effectRef idx="2">
+            <a:schemeClr val="accent1"/>
+          </a:effectRef>
+          <a:fontRef idx="minor">
+            <a:schemeClr val="lt1"/>
+          </a:fontRef>
+        </p:style>
+        <p:txBody>
+          <a:bodyPr rtlCol="0" anchor="ctr"/>
+          <a:lstStyle/>
+          <a:p>
+            <a:pPr algn="ctr"/>
+            <a:endParaRPr/>
+          </a:p>
+        </p:txBody>
+      </p:sp>
+      <p:sp>
+        <p:nvSpPr>
+          <p:cNvPr id="15" name="TextBox 14"/>
+          <p:cNvSpPr txBox="1"/>
+          <p:nvPr/>
+        </p:nvSpPr>
+        <p:spPr>
+          <a:xfrm>
+            <a:off x="640080" y="3749040"/>
+            <a:ext cx="5075040" cy="1371600"/>
+          </a:xfrm>
+          <a:prstGeom prst="rect">
+            <a:avLst/>
+          </a:prstGeom>
+          <a:noFill/>
+        </p:spPr>
+        <p:txBody>
+          <a:bodyPr wrap="square">
+            <a:spAutoFit/>
+          </a:bodyPr>
+          <a:lstStyle/>
+          <a:p>
+            <a:pPr algn="l"/>
+            <a:r>
+              <a:rPr sz="1200" b="1">
+                <a:solidFill>
+                  <a:srgbClr val="0277BD"/>
+                </a:solidFill>
+              </a:rPr>
+              <a:t>Harmonic Attention &amp; Phase Estimation（LAU-Net）</a:t>
+            </a:r>
+          </a:p>
+          <a:p>
+            <a:pPr algn="l"/>
+            <a:r>
+              <a:rPr sz="1000" b="0">
+                <a:solidFill>
+                  <a:srgbClr val="546E7A"/>
+                </a:solidFill>
+              </a:rPr>
+              <a:t>Song et al., 2025　※TAPS著者グループ</a:t>
+            </a:r>
+          </a:p>
+          <a:p>
+            <a:pPr algn="l"/>
+            <a:r>
+              <a:rPr sz="1100" b="0">
+                <a:solidFill>
+                  <a:srgbClr val="212121"/>
+                </a:solidFill>
+              </a:rPr>
+              <a:t>皮膚装着型加速度計向け軽量リアルタイムSEモデル。</a:t>
+            </a:r>
+          </a:p>
+          <a:p>
+            <a:pPr algn="l"/>
+            <a:r>
+              <a:rPr sz="1100" b="0">
+                <a:solidFill>
+                  <a:srgbClr val="212121"/>
+                </a:solidFill>
+              </a:rPr>
+              <a:t>調和スペクトル強調＋適応位相推定でTAPSにて評価</a:t>
+            </a:r>
+          </a:p>
+        </p:txBody>
+      </p:sp>
+      <p:sp>
+        <p:nvSpPr>
+          <p:cNvPr id="16" name="Rectangle 15"/>
+          <p:cNvSpPr/>
+          <p:nvPr/>
+        </p:nvSpPr>
+        <p:spPr>
+          <a:xfrm>
+            <a:off x="6474552" y="2194560"/>
+            <a:ext cx="91440" cy="822960"/>
+          </a:xfrm>
+          <a:prstGeom prst="rect">
+            <a:avLst/>
+          </a:prstGeom>
+          <a:solidFill>
+            <a:srgbClr val="6A1B9A"/>
+          </a:solidFill>
+          <a:ln>
+            <a:noFill/>
+          </a:ln>
+        </p:spPr>
+        <p:style>
+          <a:lnRef idx="1">
+            <a:schemeClr val="accent1"/>
+          </a:lnRef>
+          <a:fillRef idx="3">
+            <a:schemeClr val="accent1"/>
+          </a:fillRef>
+          <a:effectRef idx="2">
+            <a:schemeClr val="accent1"/>
+          </a:effectRef>
+          <a:fontRef idx="minor">
+            <a:schemeClr val="lt1"/>
+          </a:fontRef>
+        </p:style>
+        <p:txBody>
+          <a:bodyPr rtlCol="0" anchor="ctr"/>
+          <a:lstStyle/>
+          <a:p>
+            <a:pPr algn="ctr"/>
+            <a:endParaRPr/>
+          </a:p>
+        </p:txBody>
+      </p:sp>
+      <p:sp>
+        <p:nvSpPr>
+          <p:cNvPr id="17" name="TextBox 16"/>
+          <p:cNvSpPr txBox="1"/>
+          <p:nvPr/>
+        </p:nvSpPr>
+        <p:spPr>
+          <a:xfrm>
+            <a:off x="6611712" y="2194560"/>
+            <a:ext cx="5074920" cy="822960"/>
+          </a:xfrm>
+          <a:prstGeom prst="rect">
+            <a:avLst/>
+          </a:prstGeom>
+          <a:noFill/>
+        </p:spPr>
+        <p:txBody>
+          <a:bodyPr wrap="square">
+            <a:spAutoFit/>
+          </a:bodyPr>
+          <a:lstStyle/>
+          <a:p>
+            <a:pPr algn="l"/>
+            <a:r>
+              <a:rPr sz="1200" b="1">
+                <a:solidFill>
+                  <a:srgbClr val="6A1B9A"/>
+                </a:solidFill>
+              </a:rPr>
+              <a:t>Silent Speech Interfaces in the Era of LLMs</a:t>
+            </a:r>
+          </a:p>
+          <a:p>
+            <a:pPr algn="l"/>
+            <a:r>
+              <a:rPr sz="1000" b="0">
+                <a:solidFill>
+                  <a:srgbClr val="546E7A"/>
+                </a:solidFill>
+              </a:rPr>
+              <a:t>Xu et al., 2026　サーベイ論文</a:t>
+            </a:r>
+          </a:p>
+          <a:p>
+            <a:pPr algn="l"/>
+            <a:r>
+              <a:rPr sz="1100" b="0">
+                <a:solidFill>
+                  <a:srgbClr val="212121"/>
+                </a:solidFill>
+              </a:rPr>
+              <a:t>LLM時代の非音響音声IFの包括的分類。喉マイクを参照</a:t>
+            </a:r>
+          </a:p>
+        </p:txBody>
+      </p:sp>
+      <p:sp>
+        <p:nvSpPr>
+          <p:cNvPr id="18" name="Rectangle 17"/>
+          <p:cNvSpPr/>
+          <p:nvPr/>
+        </p:nvSpPr>
+        <p:spPr>
+          <a:xfrm>
+            <a:off x="6474552" y="3200400"/>
+            <a:ext cx="91440" cy="822960"/>
+          </a:xfrm>
+          <a:prstGeom prst="rect">
+            <a:avLst/>
+          </a:prstGeom>
+          <a:solidFill>
+            <a:srgbClr val="7B1FA2"/>
+          </a:solidFill>
+          <a:ln>
+            <a:noFill/>
+          </a:ln>
+        </p:spPr>
+        <p:style>
+          <a:lnRef idx="1">
+            <a:schemeClr val="accent1"/>
+          </a:lnRef>
+          <a:fillRef idx="3">
+            <a:schemeClr val="accent1"/>
+          </a:fillRef>
+          <a:effectRef idx="2">
+            <a:schemeClr val="accent1"/>
+          </a:effectRef>
+          <a:fontRef idx="minor">
+            <a:schemeClr val="lt1"/>
+          </a:fontRef>
+        </p:style>
+        <p:txBody>
+          <a:bodyPr rtlCol="0" anchor="ctr"/>
+          <a:lstStyle/>
+          <a:p>
+            <a:pPr algn="ctr"/>
+            <a:endParaRPr/>
+          </a:p>
+        </p:txBody>
+      </p:sp>
+      <p:sp>
+        <p:nvSpPr>
+          <p:cNvPr id="19" name="TextBox 18"/>
+          <p:cNvSpPr txBox="1"/>
+          <p:nvPr/>
+        </p:nvSpPr>
+        <p:spPr>
+          <a:xfrm>
+            <a:off x="6611712" y="3200400"/>
+            <a:ext cx="5074920" cy="822960"/>
+          </a:xfrm>
+          <a:prstGeom prst="rect">
+            <a:avLst/>
+          </a:prstGeom>
+          <a:noFill/>
+        </p:spPr>
+        <p:txBody>
+          <a:bodyPr wrap="square">
+            <a:spAutoFit/>
+          </a:bodyPr>
+          <a:lstStyle/>
+          <a:p>
+            <a:pPr algn="l"/>
+            <a:r>
+              <a:rPr sz="1200" b="1">
+                <a:solidFill>
+                  <a:srgbClr val="7B1FA2"/>
+                </a:solidFill>
+              </a:rPr>
+              <a:t>AI-Powered SE Solutions to Laryngeal Disorders</a:t>
+            </a:r>
+          </a:p>
+          <a:p>
+            <a:pPr algn="l"/>
+            <a:r>
+              <a:rPr sz="1000" b="0">
+                <a:solidFill>
+                  <a:srgbClr val="546E7A"/>
+                </a:solidFill>
+              </a:rPr>
+              <a:t>Patel et al., 2026　サーベイ論文</a:t>
+            </a:r>
+          </a:p>
+          <a:p>
+            <a:pPr algn="l"/>
+            <a:r>
+              <a:rPr sz="1100" b="0">
+                <a:solidFill>
+                  <a:srgbClr val="212121"/>
+                </a:solidFill>
+              </a:rPr>
+              <a:t>喉頭疾患向けAI音声強調技術のサーベイ。関連文献として引用</a:t>
+            </a:r>
+          </a:p>
+        </p:txBody>
+      </p:sp>
+      <p:sp>
+        <p:nvSpPr>
+          <p:cNvPr id="20" name="Rectangle 19"/>
+          <p:cNvSpPr/>
+          <p:nvPr/>
+        </p:nvSpPr>
+        <p:spPr>
+          <a:xfrm>
+            <a:off x="6474552" y="4206240"/>
+            <a:ext cx="91440" cy="822960"/>
+          </a:xfrm>
+          <a:prstGeom prst="rect">
+            <a:avLst/>
+          </a:prstGeom>
+          <a:solidFill>
+            <a:srgbClr val="1B5E20"/>
+          </a:solidFill>
+          <a:ln>
+            <a:noFill/>
+          </a:ln>
+        </p:spPr>
+        <p:style>
+          <a:lnRef idx="1">
+            <a:schemeClr val="accent1"/>
+          </a:lnRef>
+          <a:fillRef idx="3">
+            <a:schemeClr val="accent1"/>
+          </a:fillRef>
+          <a:effectRef idx="2">
+            <a:schemeClr val="accent1"/>
+          </a:effectRef>
+          <a:fontRef idx="minor">
+            <a:schemeClr val="lt1"/>
+          </a:fontRef>
+        </p:style>
+        <p:txBody>
+          <a:bodyPr rtlCol="0" anchor="ctr"/>
+          <a:lstStyle/>
+          <a:p>
+            <a:pPr algn="ctr"/>
+            <a:endParaRPr/>
+          </a:p>
+        </p:txBody>
+      </p:sp>
+      <p:sp>
+        <p:nvSpPr>
+          <p:cNvPr id="21" name="TextBox 20"/>
+          <p:cNvSpPr txBox="1"/>
+          <p:nvPr/>
+        </p:nvSpPr>
+        <p:spPr>
+          <a:xfrm>
+            <a:off x="6611712" y="4206240"/>
+            <a:ext cx="5074920" cy="822960"/>
+          </a:xfrm>
+          <a:prstGeom prst="rect">
+            <a:avLst/>
+          </a:prstGeom>
+          <a:noFill/>
+        </p:spPr>
+        <p:txBody>
+          <a:bodyPr wrap="square">
+            <a:spAutoFit/>
+          </a:bodyPr>
+          <a:lstStyle/>
+          <a:p>
+            <a:pPr algn="l"/>
+            <a:r>
+              <a:rPr sz="1200" b="1">
+                <a:solidFill>
+                  <a:srgbClr val="1B5E20"/>
+                </a:solidFill>
+              </a:rPr>
+              <a:t>Vibravox: French Speech with Body-Conduction Sensors</a:t>
+            </a:r>
+          </a:p>
+          <a:p>
+            <a:pPr algn="l"/>
+            <a:r>
+              <a:rPr sz="1000" b="0">
+                <a:solidFill>
+                  <a:srgbClr val="546E7A"/>
+                </a:solidFill>
+              </a:rPr>
+              <a:t>Hauret et al., 2024　関連データセット論文</a:t>
+            </a:r>
+          </a:p>
+          <a:p>
+            <a:pPr algn="l"/>
+            <a:r>
+              <a:rPr sz="1100" b="0">
+                <a:solidFill>
+                  <a:srgbClr val="212121"/>
+                </a:solidFill>
+              </a:rPr>
+              <a:t>仏語体伝導音声5センサ・45時間。体伝導研究の比較対象として相互参照</a:t>
+            </a:r>
+          </a:p>
+        </p:txBody>
+      </p:sp>
+      <p:sp>
+        <p:nvSpPr>
+          <p:cNvPr id="22" name="Rectangle 21"/>
+          <p:cNvSpPr/>
+          <p:nvPr/>
+        </p:nvSpPr>
+        <p:spPr>
+          <a:xfrm>
+            <a:off x="365760" y="5806440"/>
+            <a:ext cx="11430000" cy="685800"/>
+          </a:xfrm>
+          <a:prstGeom prst="rect">
+            <a:avLst/>
+          </a:prstGeom>
+          <a:solidFill>
+            <a:srgbClr val="FFFDE7"/>
+          </a:solidFill>
+          <a:ln>
+            <a:noFill/>
+          </a:ln>
+        </p:spPr>
+        <p:style>
+          <a:lnRef idx="1">
+            <a:schemeClr val="accent1"/>
+          </a:lnRef>
+          <a:fillRef idx="3">
+            <a:schemeClr val="accent1"/>
+          </a:fillRef>
+          <a:effectRef idx="2">
+            <a:schemeClr val="accent1"/>
+          </a:effectRef>
+          <a:fontRef idx="minor">
+            <a:schemeClr val="lt1"/>
+          </a:fontRef>
+        </p:style>
+        <p:txBody>
+          <a:bodyPr rtlCol="0" anchor="ctr"/>
+          <a:lstStyle/>
+          <a:p>
+            <a:pPr algn="ctr"/>
+            <a:endParaRPr/>
+          </a:p>
+        </p:txBody>
+      </p:sp>
+      <p:sp>
+        <p:nvSpPr>
+          <p:cNvPr id="23" name="TextBox 22"/>
+          <p:cNvSpPr txBox="1"/>
+          <p:nvPr/>
+        </p:nvSpPr>
+        <p:spPr>
+          <a:xfrm>
+            <a:off x="548640" y="5925312"/>
+            <a:ext cx="11064240" cy="411480"/>
+          </a:xfrm>
+          <a:prstGeom prst="rect">
+            <a:avLst/>
+          </a:prstGeom>
+          <a:noFill/>
+        </p:spPr>
+        <p:txBody>
+          <a:bodyPr wrap="square">
+            <a:spAutoFit/>
+          </a:bodyPr>
+          <a:lstStyle/>
+          <a:p>
+            <a:pPr algn="ctr"/>
+            <a:r>
+              <a:rPr sz="1300" b="1" dirty="0" err="1">
+                <a:solidFill>
+                  <a:srgbClr val="E65100"/>
+                </a:solidFill>
+              </a:rPr>
+              <a:t>現時点で実験的利用はほぼPOSTECHグループ限定</a:t>
+            </a:r>
+            <a:r>
+              <a:rPr sz="1300" b="1" dirty="0">
+                <a:solidFill>
+                  <a:srgbClr val="E65100"/>
+                </a:solidFill>
+              </a:rPr>
+              <a:t> — </a:t>
+            </a:r>
+            <a:r>
+              <a:rPr sz="1300" b="1" dirty="0" err="1">
+                <a:solidFill>
+                  <a:srgbClr val="E65100"/>
+                </a:solidFill>
+              </a:rPr>
+              <a:t>外部研究者によるASR応用はほぼ未着手のフロンティア領域</a:t>
+            </a:r>
+            <a:endParaRPr sz="1300" b="1" dirty="0">
+              <a:solidFill>
+                <a:srgbClr val="E65100"/>
+              </a:solidFill>
+            </a:endParaRPr>
+          </a:p>
+        </p:txBody>
+      </p:sp>
+    </p:spTree>
+  </p:cSld>
+  <p:clrMapOvr>
+    <a:masterClrMapping/>
+  </p:clrMapOvr>
+</p:sld>
+</file>
+
+<file path=ppt/slides/slide8.xml><?xml version="1.0" encoding="utf-8"?>
+<p:sld xmlns:a="http://schemas.openxmlformats.org/drawingml/2006/main" xmlns:r="http://schemas.openxmlformats.org/officeDocument/2006/relationships" xmlns:p="http://schemas.openxmlformats.org/presentationml/2006/main">
+  <p:cSld>
+    <p:spTree>
+      <p:nvGrpSpPr>
+        <p:cNvPr id="1" name=""/>
+        <p:cNvGrpSpPr/>
+        <p:nvPr/>
+      </p:nvGrpSpPr>
+      <p:grpSpPr>
+        <a:xfrm>
+          <a:off x="0" y="0"/>
+          <a:ext cx="0" cy="0"/>
+          <a:chOff x="0" y="0"/>
+          <a:chExt cx="0" cy="0"/>
+        </a:xfrm>
+      </p:grpSpPr>
+      <p:sp>
+        <p:nvSpPr>
+          <p:cNvPr id="2" name="Rectangle 1"/>
+          <p:cNvSpPr/>
+          <p:nvPr/>
+        </p:nvSpPr>
+        <p:spPr>
+          <a:xfrm>
+            <a:off x="0" y="0"/>
+            <a:ext cx="12188952" cy="1188720"/>
+          </a:xfrm>
+          <a:prstGeom prst="rect">
+            <a:avLst/>
+          </a:prstGeom>
+          <a:solidFill>
+            <a:srgbClr val="1A237E"/>
+          </a:solidFill>
+          <a:ln>
+            <a:noFill/>
+          </a:ln>
+        </p:spPr>
+        <p:style>
+          <a:lnRef idx="1">
+            <a:schemeClr val="accent1"/>
+          </a:lnRef>
+          <a:fillRef idx="3">
+            <a:schemeClr val="accent1"/>
+          </a:fillRef>
+          <a:effectRef idx="2">
+            <a:schemeClr val="accent1"/>
+          </a:effectRef>
+          <a:fontRef idx="minor">
+            <a:schemeClr val="lt1"/>
+          </a:fontRef>
+        </p:style>
+        <p:txBody>
+          <a:bodyPr rtlCol="0" anchor="ctr"/>
+          <a:lstStyle/>
+          <a:p>
+            <a:pPr algn="ctr"/>
+            <a:endParaRPr/>
+          </a:p>
+        </p:txBody>
+      </p:sp>
+      <p:sp>
+        <p:nvSpPr>
+          <p:cNvPr id="3" name="TextBox 2"/>
+          <p:cNvSpPr txBox="1"/>
+          <p:nvPr/>
+        </p:nvSpPr>
+        <p:spPr>
+          <a:xfrm>
+            <a:off x="411480" y="137160"/>
+            <a:ext cx="10789920" cy="777240"/>
+          </a:xfrm>
+          <a:prstGeom prst="rect">
+            <a:avLst/>
+          </a:prstGeom>
+          <a:noFill/>
+        </p:spPr>
+        <p:txBody>
+          <a:bodyPr wrap="square">
+            <a:spAutoFit/>
+          </a:bodyPr>
+          <a:lstStyle/>
+          <a:p>
+            <a:pPr algn="l"/>
+            <a:r>
+              <a:rPr sz="2600" b="1">
+                <a:solidFill>
+                  <a:srgbClr val="FFFFFF"/>
+                </a:solidFill>
+              </a:rPr>
+              <a:t>解決策と結論：「音声を直す」より「ASRを慣れさせる」</a:t>
+            </a:r>
+          </a:p>
+        </p:txBody>
+      </p:sp>
+      <p:sp>
+        <p:nvSpPr>
+          <p:cNvPr id="4" name="TextBox 3"/>
+          <p:cNvSpPr txBox="1"/>
+          <p:nvPr/>
+        </p:nvSpPr>
+        <p:spPr>
+          <a:xfrm>
+            <a:off x="11247120" y="411480"/>
+            <a:ext cx="822960" cy="365760"/>
+          </a:xfrm>
+          <a:prstGeom prst="rect">
+            <a:avLst/>
+          </a:prstGeom>
+          <a:noFill/>
+        </p:spPr>
+        <p:txBody>
+          <a:bodyPr wrap="square">
+            <a:spAutoFit/>
+          </a:bodyPr>
+          <a:lstStyle/>
+          <a:p>
+            <a:pPr algn="r"/>
+            <a:r>
+              <a:rPr sz="1300" b="0">
+                <a:solidFill>
+                  <a:srgbClr val="78909C"/>
+                </a:solidFill>
+              </a:rPr>
+              <a:t>6 / 5</a:t>
+            </a:r>
+          </a:p>
+        </p:txBody>
+      </p:sp>
+      <p:sp>
+        <p:nvSpPr>
+          <p:cNvPr id="5" name="Rectangle 4"/>
+          <p:cNvSpPr/>
+          <p:nvPr/>
+        </p:nvSpPr>
+        <p:spPr>
+          <a:xfrm>
+            <a:off x="0" y="6583680"/>
+            <a:ext cx="12188952" cy="274320"/>
+          </a:xfrm>
+          <a:prstGeom prst="rect">
+            <a:avLst/>
+          </a:prstGeom>
+          <a:solidFill>
+            <a:srgbClr val="E8EAF6"/>
+          </a:solidFill>
+          <a:ln>
+            <a:noFill/>
+          </a:ln>
+        </p:spPr>
+        <p:style>
+          <a:lnRef idx="1">
+            <a:schemeClr val="accent1"/>
+          </a:lnRef>
+          <a:fillRef idx="3">
+            <a:schemeClr val="accent1"/>
+          </a:fillRef>
+          <a:effectRef idx="2">
+            <a:schemeClr val="accent1"/>
+          </a:effectRef>
+          <a:fontRef idx="minor">
+            <a:schemeClr val="lt1"/>
+          </a:fontRef>
+        </p:style>
+        <p:txBody>
+          <a:bodyPr rtlCol="0" anchor="ctr"/>
+          <a:lstStyle/>
+          <a:p>
+            <a:pPr algn="ctr"/>
+            <a:endParaRPr/>
+          </a:p>
+        </p:txBody>
+      </p:sp>
+      <p:sp>
+        <p:nvSpPr>
+          <p:cNvPr id="6" name="TextBox 5"/>
+          <p:cNvSpPr txBox="1"/>
+          <p:nvPr/>
+        </p:nvSpPr>
+        <p:spPr>
+          <a:xfrm>
+            <a:off x="274320" y="6601968"/>
+            <a:ext cx="11612880" cy="228600"/>
+          </a:xfrm>
+          <a:prstGeom prst="rect">
+            <a:avLst/>
+          </a:prstGeom>
+          <a:noFill/>
+        </p:spPr>
+        <p:txBody>
+          <a:bodyPr wrap="square">
+            <a:spAutoFit/>
+          </a:bodyPr>
+          <a:lstStyle/>
+          <a:p>
+            <a:pPr algn="l"/>
+            <a:r>
+              <a:rPr sz="900" b="0">
+                <a:solidFill>
+                  <a:srgbClr val="78909C"/>
+                </a:solidFill>
+              </a:rPr>
+              <a:t>骨伝導マイク音声認識研究 — 概要</a:t>
+            </a:r>
+          </a:p>
+        </p:txBody>
+      </p:sp>
+      <p:sp>
+        <p:nvSpPr>
+          <p:cNvPr id="7" name="Rectangle 6"/>
+          <p:cNvSpPr/>
+          <p:nvPr/>
+        </p:nvSpPr>
+        <p:spPr>
+          <a:xfrm>
+            <a:off x="365760" y="1325880"/>
+            <a:ext cx="5394960" cy="3200400"/>
+          </a:xfrm>
+          <a:prstGeom prst="rect">
+            <a:avLst/>
+          </a:prstGeom>
+          <a:solidFill>
+            <a:srgbClr val="E8F5E9"/>
+          </a:solidFill>
+          <a:ln>
+            <a:noFill/>
+          </a:ln>
+        </p:spPr>
+        <p:style>
+          <a:lnRef idx="1">
+            <a:schemeClr val="accent1"/>
+          </a:lnRef>
+          <a:fillRef idx="3">
+            <a:schemeClr val="accent1"/>
+          </a:fillRef>
+          <a:effectRef idx="2">
+            <a:schemeClr val="accent1"/>
+          </a:effectRef>
+          <a:fontRef idx="minor">
+            <a:schemeClr val="lt1"/>
+          </a:fontRef>
+        </p:style>
+        <p:txBody>
+          <a:bodyPr rtlCol="0" anchor="ctr"/>
+          <a:lstStyle/>
+          <a:p>
+            <a:pPr algn="ctr"/>
+            <a:endParaRPr/>
+          </a:p>
+        </p:txBody>
+      </p:sp>
+      <p:sp>
+        <p:nvSpPr>
+          <p:cNvPr id="8" name="TextBox 7"/>
+          <p:cNvSpPr txBox="1"/>
+          <p:nvPr/>
+        </p:nvSpPr>
+        <p:spPr>
+          <a:xfrm>
+            <a:off x="502920" y="1417320"/>
+            <a:ext cx="5120640" cy="365760"/>
+          </a:xfrm>
+          <a:prstGeom prst="rect">
+            <a:avLst/>
+          </a:prstGeom>
+          <a:noFill/>
+        </p:spPr>
+        <p:txBody>
+          <a:bodyPr wrap="square">
+            <a:spAutoFit/>
+          </a:bodyPr>
+          <a:lstStyle/>
+          <a:p>
+            <a:pPr algn="l"/>
+            <a:r>
+              <a:rPr sz="1400" b="1">
+                <a:solidFill>
+                  <a:srgbClr val="2E7D32"/>
+                </a:solidFill>
+              </a:rPr>
+              <a:t>解決策：Whisper ファインチューニング（FT）</a:t>
+            </a:r>
+          </a:p>
+        </p:txBody>
+      </p:sp>
+      <p:sp>
+        <p:nvSpPr>
+          <p:cNvPr id="9" name="TextBox 8"/>
+          <p:cNvSpPr txBox="1"/>
+          <p:nvPr/>
+        </p:nvSpPr>
+        <p:spPr>
+          <a:xfrm>
+            <a:off x="548640" y="1874519"/>
+            <a:ext cx="5120640" cy="502920"/>
+          </a:xfrm>
+          <a:prstGeom prst="rect">
+            <a:avLst/>
+          </a:prstGeom>
+          <a:noFill/>
+        </p:spPr>
+        <p:txBody>
+          <a:bodyPr wrap="square">
+            <a:spAutoFit/>
+          </a:bodyPr>
+          <a:lstStyle/>
+          <a:p>
+            <a:pPr algn="l"/>
+            <a:r>
+              <a:rPr sz="1300" b="0">
+                <a:solidFill>
+                  <a:srgbClr val="212121"/>
+                </a:solidFill>
+              </a:rPr>
+              <a:t>喉マイク音声 4,000発話でWhisper smallを再学習
+→ ASRモデルが喉マイクの音響特性を直接学習</a:t>
+            </a:r>
+          </a:p>
+        </p:txBody>
+      </p:sp>
+      <p:pic>
+        <p:nvPicPr>
+          <p:cNvPr id="10" name="Picture 9" descr="image.png"/>
+          <p:cNvPicPr>
+            <a:picLocks noChangeAspect="1"/>
+          </p:cNvPicPr>
+          <p:nvPr/>
+        </p:nvPicPr>
+        <p:blipFill>
+          <a:blip r:embed="rId2"/>
+          <a:stretch>
+            <a:fillRect/>
+          </a:stretch>
+        </p:blipFill>
+        <p:spPr>
+          <a:xfrm>
+            <a:off x="457200" y="2423160"/>
+            <a:ext cx="4846320" cy="1963595"/>
+          </a:xfrm>
+          <a:prstGeom prst="rect">
+            <a:avLst/>
+          </a:prstGeom>
+        </p:spPr>
+      </p:pic>
+      <p:sp>
+        <p:nvSpPr>
+          <p:cNvPr id="11" name="Rectangle 10"/>
+          <p:cNvSpPr/>
+          <p:nvPr/>
+        </p:nvSpPr>
+        <p:spPr>
+          <a:xfrm>
+            <a:off x="6126480" y="1325880"/>
+            <a:ext cx="5669280" cy="3200400"/>
+          </a:xfrm>
+          <a:prstGeom prst="rect">
+            <a:avLst/>
+          </a:prstGeom>
+          <a:solidFill>
+            <a:srgbClr val="F5F5F5"/>
+          </a:solidFill>
+          <a:ln>
+            <a:noFill/>
+          </a:ln>
+        </p:spPr>
+        <p:style>
+          <a:lnRef idx="1">
+            <a:schemeClr val="accent1"/>
+          </a:lnRef>
+          <a:fillRef idx="3">
+            <a:schemeClr val="accent1"/>
+          </a:fillRef>
+          <a:effectRef idx="2">
+            <a:schemeClr val="accent1"/>
+          </a:effectRef>
+          <a:fontRef idx="minor">
+            <a:schemeClr val="lt1"/>
+          </a:fontRef>
+        </p:style>
+        <p:txBody>
+          <a:bodyPr rtlCol="0" anchor="ctr"/>
+          <a:lstStyle/>
+          <a:p>
+            <a:pPr algn="ctr"/>
+            <a:endParaRPr/>
+          </a:p>
+        </p:txBody>
+      </p:sp>
+      <p:sp>
+        <p:nvSpPr>
+          <p:cNvPr id="12" name="TextBox 11"/>
+          <p:cNvSpPr txBox="1"/>
+          <p:nvPr/>
+        </p:nvSpPr>
+        <p:spPr>
+          <a:xfrm>
+            <a:off x="6263640" y="1417320"/>
+            <a:ext cx="5394960" cy="365760"/>
+          </a:xfrm>
+          <a:prstGeom prst="rect">
+            <a:avLst/>
+          </a:prstGeom>
+          <a:noFill/>
+        </p:spPr>
+        <p:txBody>
+          <a:bodyPr wrap="square">
+            <a:spAutoFit/>
+          </a:bodyPr>
+          <a:lstStyle/>
+          <a:p>
+            <a:pPr algn="l"/>
+            <a:r>
+              <a:rPr sz="1400" b="1">
+                <a:solidFill>
+                  <a:srgbClr val="1A237E"/>
+                </a:solidFill>
+              </a:rPr>
+              <a:t>補足：SE × FT の組み合わせ比較</a:t>
+            </a:r>
+          </a:p>
+        </p:txBody>
+      </p:sp>
+      <p:pic>
+        <p:nvPicPr>
+          <p:cNvPr id="13" name="Picture 12" descr="image.png"/>
+          <p:cNvPicPr>
+            <a:picLocks noChangeAspect="1"/>
+          </p:cNvPicPr>
+          <p:nvPr/>
+        </p:nvPicPr>
+        <p:blipFill>
+          <a:blip r:embed="rId3"/>
+          <a:stretch>
+            <a:fillRect/>
+          </a:stretch>
+        </p:blipFill>
+        <p:spPr>
+          <a:xfrm>
+            <a:off x="6217920" y="1874519"/>
+            <a:ext cx="5394960" cy="3146361"/>
+          </a:xfrm>
+          <a:prstGeom prst="rect">
+            <a:avLst/>
+          </a:prstGeom>
+        </p:spPr>
+      </p:pic>
+      <p:sp>
+        <p:nvSpPr>
+          <p:cNvPr id="14" name="TextBox 13"/>
+          <p:cNvSpPr txBox="1"/>
+          <p:nvPr/>
+        </p:nvSpPr>
+        <p:spPr>
+          <a:xfrm>
+            <a:off x="6263640" y="4206240"/>
+            <a:ext cx="5394960" cy="274320"/>
+          </a:xfrm>
+          <a:prstGeom prst="rect">
+            <a:avLst/>
+          </a:prstGeom>
+          <a:noFill/>
+        </p:spPr>
+        <p:txBody>
+          <a:bodyPr wrap="square">
+            <a:spAutoFit/>
+          </a:bodyPr>
+          <a:lstStyle/>
+          <a:p>
+            <a:pPr algn="l"/>
+            <a:r>
+              <a:rPr sz="1200" b="0">
+                <a:solidFill>
+                  <a:srgbClr val="78909C"/>
+                </a:solidFill>
+              </a:rPr>
+              <a:t>FT後もSEの逆効果は残るが悪影響は縮小（+0.091→+0.036）</a:t>
+            </a:r>
+          </a:p>
+        </p:txBody>
+      </p:sp>
+      <p:sp>
+        <p:nvSpPr>
+          <p:cNvPr id="15" name="Rectangle 14"/>
+          <p:cNvSpPr/>
+          <p:nvPr/>
+        </p:nvSpPr>
+        <p:spPr>
+          <a:xfrm>
+            <a:off x="365760" y="4663440"/>
+            <a:ext cx="11430000" cy="1874519"/>
+          </a:xfrm>
+          <a:prstGeom prst="rect">
+            <a:avLst/>
+          </a:prstGeom>
+          <a:solidFill>
+            <a:srgbClr val="FFF9C4"/>
+          </a:solidFill>
+          <a:ln>
+            <a:noFill/>
+          </a:ln>
+        </p:spPr>
+        <p:style>
+          <a:lnRef idx="1">
+            <a:schemeClr val="accent1"/>
+          </a:lnRef>
+          <a:fillRef idx="3">
+            <a:schemeClr val="accent1"/>
+          </a:fillRef>
+          <a:effectRef idx="2">
+            <a:schemeClr val="accent1"/>
+          </a:effectRef>
+          <a:fontRef idx="minor">
+            <a:schemeClr val="lt1"/>
+          </a:fontRef>
+        </p:style>
+        <p:txBody>
+          <a:bodyPr rtlCol="0" anchor="ctr"/>
+          <a:lstStyle/>
+          <a:p>
+            <a:pPr algn="ctr"/>
+            <a:endParaRPr/>
+          </a:p>
+        </p:txBody>
+      </p:sp>
+      <p:sp>
+        <p:nvSpPr>
+          <p:cNvPr id="16" name="TextBox 15"/>
+          <p:cNvSpPr txBox="1"/>
+          <p:nvPr/>
+        </p:nvSpPr>
+        <p:spPr>
+          <a:xfrm>
+            <a:off x="548640" y="4736592"/>
+            <a:ext cx="1828800" cy="347472"/>
+          </a:xfrm>
+          <a:prstGeom prst="rect">
+            <a:avLst/>
+          </a:prstGeom>
+          <a:noFill/>
+        </p:spPr>
+        <p:txBody>
+          <a:bodyPr wrap="square">
+            <a:spAutoFit/>
+          </a:bodyPr>
+          <a:lstStyle/>
+          <a:p>
+            <a:pPr algn="l"/>
+            <a:r>
+              <a:rPr sz="1500" b="1">
+                <a:solidFill>
+                  <a:srgbClr val="1A237E"/>
+                </a:solidFill>
+              </a:rPr>
+              <a:t>まとめ</a:t>
+            </a:r>
+          </a:p>
+        </p:txBody>
+      </p:sp>
+      <p:sp>
+        <p:nvSpPr>
+          <p:cNvPr id="17" name="TextBox 16"/>
+          <p:cNvSpPr txBox="1"/>
+          <p:nvPr/>
+        </p:nvSpPr>
+        <p:spPr>
+          <a:xfrm>
+            <a:off x="548640" y="5120640"/>
+            <a:ext cx="457200" cy="384048"/>
+          </a:xfrm>
+          <a:prstGeom prst="rect">
+            <a:avLst/>
+          </a:prstGeom>
+          <a:noFill/>
+        </p:spPr>
+        <p:txBody>
+          <a:bodyPr wrap="square">
+            <a:spAutoFit/>
+          </a:bodyPr>
+          <a:lstStyle/>
+          <a:p>
+            <a:pPr algn="l"/>
+            <a:r>
+              <a:rPr sz="1400" b="1">
+                <a:solidFill>
+                  <a:srgbClr val="C62828"/>
+                </a:solidFill>
+              </a:rPr>
+              <a:t>①</a:t>
+            </a:r>
+          </a:p>
+        </p:txBody>
+      </p:sp>
+      <p:sp>
+        <p:nvSpPr>
+          <p:cNvPr id="18" name="TextBox 17"/>
+          <p:cNvSpPr txBox="1"/>
+          <p:nvPr/>
+        </p:nvSpPr>
+        <p:spPr>
+          <a:xfrm>
+            <a:off x="1005840" y="5120640"/>
+            <a:ext cx="10607040" cy="384048"/>
+          </a:xfrm>
+          <a:prstGeom prst="rect">
+            <a:avLst/>
+          </a:prstGeom>
+          <a:noFill/>
+        </p:spPr>
+        <p:txBody>
+          <a:bodyPr wrap="square">
+            <a:spAutoFit/>
+          </a:bodyPr>
+          <a:lstStyle/>
+          <a:p>
+            <a:pPr algn="l"/>
+            <a:r>
+              <a:rPr sz="1400" b="0">
+                <a:solidFill>
+                  <a:srgbClr val="212121"/>
+                </a:solidFill>
+              </a:rPr>
+              <a:t>STOI↑PESQ↑でもCERが悪化する逆行現象が喉マイクでも全ノイズ条件で一貫して観測された</a:t>
+            </a:r>
+          </a:p>
+        </p:txBody>
+      </p:sp>
+      <p:sp>
+        <p:nvSpPr>
+          <p:cNvPr id="19" name="TextBox 18"/>
+          <p:cNvSpPr txBox="1"/>
+          <p:nvPr/>
+        </p:nvSpPr>
+        <p:spPr>
+          <a:xfrm>
+            <a:off x="548640" y="5577840"/>
+            <a:ext cx="457200" cy="384048"/>
+          </a:xfrm>
+          <a:prstGeom prst="rect">
+            <a:avLst/>
+          </a:prstGeom>
+          <a:noFill/>
+        </p:spPr>
+        <p:txBody>
+          <a:bodyPr wrap="square">
+            <a:spAutoFit/>
+          </a:bodyPr>
+          <a:lstStyle/>
+          <a:p>
+            <a:pPr algn="l"/>
+            <a:r>
+              <a:rPr sz="1400" b="1">
+                <a:solidFill>
+                  <a:srgbClr val="FF6F00"/>
+                </a:solidFill>
+              </a:rPr>
+              <a:t>②</a:t>
+            </a:r>
+          </a:p>
+        </p:txBody>
+      </p:sp>
+      <p:sp>
+        <p:nvSpPr>
+          <p:cNvPr id="20" name="TextBox 19"/>
+          <p:cNvSpPr txBox="1"/>
+          <p:nvPr/>
+        </p:nvSpPr>
+        <p:spPr>
+          <a:xfrm>
+            <a:off x="1005840" y="5577840"/>
+            <a:ext cx="10607040" cy="384048"/>
+          </a:xfrm>
+          <a:prstGeom prst="rect">
+            <a:avLst/>
+          </a:prstGeom>
+          <a:noFill/>
+        </p:spPr>
+        <p:txBody>
+          <a:bodyPr wrap="square">
+            <a:spAutoFit/>
+          </a:bodyPr>
+          <a:lstStyle/>
+          <a:p>
+            <a:pPr algn="l"/>
+            <a:r>
+              <a:rPr sz="1400" b="0">
+                <a:solidFill>
+                  <a:srgbClr val="212121"/>
+                </a:solidFill>
+              </a:rPr>
+              <a:t>知覚品質指標（STOI・PESQ）は喉マイクASR性能の指標として不適切</a:t>
+            </a:r>
+          </a:p>
+        </p:txBody>
+      </p:sp>
+      <p:sp>
+        <p:nvSpPr>
+          <p:cNvPr id="21" name="TextBox 20"/>
+          <p:cNvSpPr txBox="1"/>
+          <p:nvPr/>
+        </p:nvSpPr>
+        <p:spPr>
+          <a:xfrm>
+            <a:off x="548640" y="6035040"/>
+            <a:ext cx="457200" cy="384048"/>
+          </a:xfrm>
+          <a:prstGeom prst="rect">
+            <a:avLst/>
+          </a:prstGeom>
+          <a:noFill/>
+        </p:spPr>
+        <p:txBody>
+          <a:bodyPr wrap="square">
+            <a:spAutoFit/>
+          </a:bodyPr>
+          <a:lstStyle/>
+          <a:p>
+            <a:pPr algn="l"/>
+            <a:r>
+              <a:rPr sz="1400" b="1">
+                <a:solidFill>
+                  <a:srgbClr val="2E7D32"/>
+                </a:solidFill>
+              </a:rPr>
+              <a:t>③</a:t>
+            </a:r>
+          </a:p>
+        </p:txBody>
+      </p:sp>
+      <p:sp>
+        <p:nvSpPr>
+          <p:cNvPr id="22" name="TextBox 21"/>
+          <p:cNvSpPr txBox="1"/>
+          <p:nvPr/>
+        </p:nvSpPr>
+        <p:spPr>
+          <a:xfrm>
+            <a:off x="1005840" y="6035040"/>
+            <a:ext cx="10607040" cy="384048"/>
+          </a:xfrm>
+          <a:prstGeom prst="rect">
+            <a:avLst/>
+          </a:prstGeom>
+          <a:noFill/>
+        </p:spPr>
+        <p:txBody>
+          <a:bodyPr wrap="square">
+            <a:spAutoFit/>
+          </a:bodyPr>
+          <a:lstStyle/>
+          <a:p>
+            <a:pPr algn="l"/>
+            <a:r>
+              <a:rPr sz="1400" b="0">
+                <a:solidFill>
+                  <a:srgbClr val="212121"/>
+                </a:solidFill>
+              </a:rPr>
+              <a:t>Whisper FTでCER 72.4%改善（0.544→0.150，10話者）—音声処理よりASR適応が根本解決</a:t>
+            </a:r>
+          </a:p>
+        </p:txBody>
+      </p:sp>
+    </p:spTree>
+  </p:cSld>
+  <p:clrMapOvr>
+    <a:masterClrMapping/>
+  </p:clrMapOvr>
+</p:sld>
+</file>
+
+<file path=ppt/slides/slide9.xml><?xml version="1.0" encoding="utf-8"?>
 <p:sld xmlns:a="http://schemas.openxmlformats.org/drawingml/2006/main" xmlns:r="http://schemas.openxmlformats.org/officeDocument/2006/relationships" xmlns:p="http://schemas.openxmlformats.org/presentationml/2006/main">
   <p:cSld>
     <p:spTree>

</xml_diff>